<commit_message>
Remove animations and fix minor issues
</commit_message>
<xml_diff>
--- a/MyOwnPresentations/Divide_Conquer_Recursion_II.pptx
+++ b/MyOwnPresentations/Divide_Conquer_Recursion_II.pptx
@@ -5,7 +5,7 @@
     <p:sldMasterId id="2147483660" r:id="rId1"/>
   </p:sldMasterIdLst>
   <p:notesMasterIdLst>
-    <p:notesMasterId r:id="rId58"/>
+    <p:notesMasterId r:id="rId62"/>
   </p:notesMasterIdLst>
   <p:sldIdLst>
     <p:sldId id="257" r:id="rId2"/>
@@ -64,6 +64,10 @@
     <p:sldId id="312" r:id="rId55"/>
     <p:sldId id="317" r:id="rId56"/>
     <p:sldId id="318" r:id="rId57"/>
+    <p:sldId id="319" r:id="rId58"/>
+    <p:sldId id="322" r:id="rId59"/>
+    <p:sldId id="321" r:id="rId60"/>
+    <p:sldId id="320" r:id="rId61"/>
   </p:sldIdLst>
   <p:sldSz cx="12192000" cy="6858000"/>
   <p:notesSz cx="6858000" cy="9144000"/>
@@ -252,7 +256,7 @@
           <a:p>
             <a:fld id="{20ADFE78-208B-402D-B1CF-A34F52562469}" type="datetimeFigureOut">
               <a:rPr lang="en-US" smtClean="0"/>
-              <a:t>8/22/2025</a:t>
+              <a:t>8/23/2025</a:t>
             </a:fld>
             <a:endParaRPr lang="en-US"/>
           </a:p>
@@ -666,7 +670,7 @@
           <a:p>
             <a:fld id="{5C041930-F8FC-4542-827E-E504F4750562}" type="datetimeFigureOut">
               <a:rPr lang="en-US" smtClean="0"/>
-              <a:t>8/22/2025</a:t>
+              <a:t>8/23/2025</a:t>
             </a:fld>
             <a:endParaRPr lang="en-US"/>
           </a:p>
@@ -864,7 +868,7 @@
           <a:p>
             <a:fld id="{5C041930-F8FC-4542-827E-E504F4750562}" type="datetimeFigureOut">
               <a:rPr lang="en-US" smtClean="0"/>
-              <a:t>8/22/2025</a:t>
+              <a:t>8/23/2025</a:t>
             </a:fld>
             <a:endParaRPr lang="en-US"/>
           </a:p>
@@ -1072,7 +1076,7 @@
           <a:p>
             <a:fld id="{5C041930-F8FC-4542-827E-E504F4750562}" type="datetimeFigureOut">
               <a:rPr lang="en-US" smtClean="0"/>
-              <a:t>8/22/2025</a:t>
+              <a:t>8/23/2025</a:t>
             </a:fld>
             <a:endParaRPr lang="en-US"/>
           </a:p>
@@ -1270,7 +1274,7 @@
           <a:p>
             <a:fld id="{5C041930-F8FC-4542-827E-E504F4750562}" type="datetimeFigureOut">
               <a:rPr lang="en-US" smtClean="0"/>
-              <a:t>8/22/2025</a:t>
+              <a:t>8/23/2025</a:t>
             </a:fld>
             <a:endParaRPr lang="en-US"/>
           </a:p>
@@ -1545,7 +1549,7 @@
           <a:p>
             <a:fld id="{5C041930-F8FC-4542-827E-E504F4750562}" type="datetimeFigureOut">
               <a:rPr lang="en-US" smtClean="0"/>
-              <a:t>8/22/2025</a:t>
+              <a:t>8/23/2025</a:t>
             </a:fld>
             <a:endParaRPr lang="en-US"/>
           </a:p>
@@ -1810,7 +1814,7 @@
           <a:p>
             <a:fld id="{5C041930-F8FC-4542-827E-E504F4750562}" type="datetimeFigureOut">
               <a:rPr lang="en-US" smtClean="0"/>
-              <a:t>8/22/2025</a:t>
+              <a:t>8/23/2025</a:t>
             </a:fld>
             <a:endParaRPr lang="en-US"/>
           </a:p>
@@ -2222,7 +2226,7 @@
           <a:p>
             <a:fld id="{5C041930-F8FC-4542-827E-E504F4750562}" type="datetimeFigureOut">
               <a:rPr lang="en-US" smtClean="0"/>
-              <a:t>8/22/2025</a:t>
+              <a:t>8/23/2025</a:t>
             </a:fld>
             <a:endParaRPr lang="en-US"/>
           </a:p>
@@ -2363,7 +2367,7 @@
           <a:p>
             <a:fld id="{5C041930-F8FC-4542-827E-E504F4750562}" type="datetimeFigureOut">
               <a:rPr lang="en-US" smtClean="0"/>
-              <a:t>8/22/2025</a:t>
+              <a:t>8/23/2025</a:t>
             </a:fld>
             <a:endParaRPr lang="en-US"/>
           </a:p>
@@ -2476,7 +2480,7 @@
           <a:p>
             <a:fld id="{5C041930-F8FC-4542-827E-E504F4750562}" type="datetimeFigureOut">
               <a:rPr lang="en-US" smtClean="0"/>
-              <a:t>8/22/2025</a:t>
+              <a:t>8/23/2025</a:t>
             </a:fld>
             <a:endParaRPr lang="en-US"/>
           </a:p>
@@ -2787,7 +2791,7 @@
           <a:p>
             <a:fld id="{5C041930-F8FC-4542-827E-E504F4750562}" type="datetimeFigureOut">
               <a:rPr lang="en-US" smtClean="0"/>
-              <a:t>8/22/2025</a:t>
+              <a:t>8/23/2025</a:t>
             </a:fld>
             <a:endParaRPr lang="en-US"/>
           </a:p>
@@ -3075,7 +3079,7 @@
           <a:p>
             <a:fld id="{5C041930-F8FC-4542-827E-E504F4750562}" type="datetimeFigureOut">
               <a:rPr lang="en-US" smtClean="0"/>
-              <a:t>8/22/2025</a:t>
+              <a:t>8/23/2025</a:t>
             </a:fld>
             <a:endParaRPr lang="en-US"/>
           </a:p>
@@ -3316,7 +3320,7 @@
           <a:p>
             <a:fld id="{5C041930-F8FC-4542-827E-E504F4750562}" type="datetimeFigureOut">
               <a:rPr lang="en-US" smtClean="0"/>
-              <a:t>8/22/2025</a:t>
+              <a:t>8/23/2025</a:t>
             </a:fld>
             <a:endParaRPr lang="en-US"/>
           </a:p>
@@ -4105,7 +4109,7 @@
           <a:p>
             <a:pPr algn="l"/>
             <a:r>
-              <a:rPr lang="hu-HU">
+              <a:rPr lang="hu-HU" dirty="0">
                 <a:solidFill>
                   <a:srgbClr val="FFFFFF"/>
                 </a:solidFill>
@@ -4113,18 +4117,29 @@
               <a:t>University of </a:t>
             </a:r>
             <a:r>
-              <a:rPr lang="en-US">
+              <a:rPr lang="en-US" dirty="0">
                 <a:solidFill>
                   <a:srgbClr val="FFFFFF"/>
                 </a:solidFill>
               </a:rPr>
-              <a:t>Szeged – Robert Nagy</a:t>
+              <a:t>Szeged </a:t>
             </a:r>
           </a:p>
           <a:p>
             <a:pPr algn="l"/>
             <a:r>
-              <a:rPr lang="en-US">
+              <a:rPr lang="en-US" sz="1600" dirty="0">
+                <a:solidFill>
+                  <a:srgbClr val="FFFFFF"/>
+                </a:solidFill>
+              </a:rPr>
+              <a:t>Robert Nagy</a:t>
+            </a:r>
+          </a:p>
+          <a:p>
+            <a:pPr algn="l"/>
+            <a:r>
+              <a:rPr lang="en-US" dirty="0">
                 <a:solidFill>
                   <a:srgbClr val="FFFFFF"/>
                 </a:solidFill>
@@ -4134,7 +4149,7 @@
           </a:p>
           <a:p>
             <a:pPr algn="l"/>
-            <a:endParaRPr lang="hu-HU">
+            <a:endParaRPr lang="hu-HU" dirty="0">
               <a:solidFill>
                 <a:srgbClr val="FFFFFF"/>
               </a:solidFill>
@@ -5760,8 +5775,8 @@
           </a:p>
         </p:txBody>
       </p:sp>
-      <mc:AlternateContent xmlns:mc="http://schemas.openxmlformats.org/markup-compatibility/2006" xmlns:a14="http://schemas.microsoft.com/office/drawing/2010/main">
-        <mc:Choice Requires="a14">
+      <mc:AlternateContent xmlns:mc="http://schemas.openxmlformats.org/markup-compatibility/2006">
+        <mc:Choice xmlns:a14="http://schemas.microsoft.com/office/drawing/2010/main" Requires="a14">
           <p:sp>
             <p:nvSpPr>
               <p:cNvPr id="2" name="Title 1">
@@ -5798,7 +5813,7 @@
                     </m:oMathParaPr>
                     <m:oMath xmlns:m="http://schemas.openxmlformats.org/officeDocument/2006/math">
                       <m:r>
-                        <a:rPr lang="en-US" sz="4800" b="0" i="1" kern="1200">
+                        <a:rPr lang="en-US" sz="4800" b="0" i="1" kern="1200" smtClean="0">
                           <a:solidFill>
                             <a:schemeClr val="tx1"/>
                           </a:solidFill>
@@ -5897,6 +5912,17 @@
                           <a:cs typeface="+mj-cs"/>
                         </a:rPr>
                         <m:t>+</m:t>
+                      </m:r>
+                      <m:r>
+                        <a:rPr lang="en-US" sz="4800" b="0" i="1" kern="1200" smtClean="0">
+                          <a:solidFill>
+                            <a:schemeClr val="tx1"/>
+                          </a:solidFill>
+                          <a:latin typeface="Cambria Math" panose="02040503050406030204" pitchFamily="18" charset="0"/>
+                          <a:ea typeface="+mj-ea"/>
+                          <a:cs typeface="+mj-cs"/>
+                        </a:rPr>
+                        <m:t>2</m:t>
                       </m:r>
                       <m:r>
                         <a:rPr lang="en-US" sz="4800" b="0" i="1" kern="1200">
@@ -6020,7 +6046,7 @@
                     </m:oMath>
                   </m:oMathPara>
                 </a14:m>
-                <a:endParaRPr lang="en-US" sz="4800" kern="1200">
+                <a:endParaRPr lang="en-US" sz="4800" kern="1200" dirty="0">
                   <a:solidFill>
                     <a:schemeClr val="tx1"/>
                   </a:solidFill>
@@ -6032,7 +6058,7 @@
             </p:txBody>
           </p:sp>
         </mc:Choice>
-        <mc:Fallback xmlns="">
+        <mc:Fallback>
           <p:sp>
             <p:nvSpPr>
               <p:cNvPr id="2" name="Title 1">
@@ -6542,8 +6568,8 @@
           </a:p>
         </p:txBody>
       </p:sp>
-      <mc:AlternateContent xmlns:mc="http://schemas.openxmlformats.org/markup-compatibility/2006" xmlns:a14="http://schemas.microsoft.com/office/drawing/2010/main">
-        <mc:Choice Requires="a14">
+      <mc:AlternateContent xmlns:mc="http://schemas.openxmlformats.org/markup-compatibility/2006">
+        <mc:Choice xmlns:a14="http://schemas.microsoft.com/office/drawing/2010/main" Requires="a14">
           <p:sp>
             <p:nvSpPr>
               <p:cNvPr id="2" name="Title 1">
@@ -6580,7 +6606,7 @@
                     </m:oMathParaPr>
                     <m:oMath xmlns:m="http://schemas.openxmlformats.org/officeDocument/2006/math">
                       <m:r>
-                        <a:rPr lang="en-US" sz="4800" b="0" i="1" kern="1200">
+                        <a:rPr lang="en-US" sz="4800" b="0" i="1" kern="1200" smtClean="0">
                           <a:solidFill>
                             <a:schemeClr val="tx1"/>
                           </a:solidFill>
@@ -6627,6 +6653,17 @@
                           <a:cs typeface="+mj-cs"/>
                         </a:rPr>
                         <m:t>=</m:t>
+                      </m:r>
+                      <m:r>
+                        <a:rPr lang="en-US" sz="4800" b="0" i="1" kern="1200" smtClean="0">
+                          <a:solidFill>
+                            <a:schemeClr val="tx1"/>
+                          </a:solidFill>
+                          <a:latin typeface="Cambria Math" panose="02040503050406030204" pitchFamily="18" charset="0"/>
+                          <a:ea typeface="+mj-ea"/>
+                          <a:cs typeface="+mj-cs"/>
+                        </a:rPr>
+                        <m:t>2</m:t>
                       </m:r>
                       <m:r>
                         <a:rPr lang="en-US" sz="4800" b="0" i="1" kern="1200">
@@ -6762,7 +6799,7 @@
             </p:txBody>
           </p:sp>
         </mc:Choice>
-        <mc:Fallback xmlns="">
+        <mc:Fallback>
           <p:sp>
             <p:nvSpPr>
               <p:cNvPr id="2" name="Title 1">
@@ -10152,8 +10189,8 @@
           </a:p>
         </p:txBody>
       </p:sp>
-      <mc:AlternateContent xmlns:mc="http://schemas.openxmlformats.org/markup-compatibility/2006">
-        <mc:Choice xmlns:a14="http://schemas.microsoft.com/office/drawing/2010/main" Requires="a14">
+      <mc:AlternateContent xmlns:mc="http://schemas.openxmlformats.org/markup-compatibility/2006" xmlns:a14="http://schemas.microsoft.com/office/drawing/2010/main">
+        <mc:Choice Requires="a14">
           <p:sp>
             <p:nvSpPr>
               <p:cNvPr id="2" name="Title 1">
@@ -10375,7 +10412,7 @@
             </p:txBody>
           </p:sp>
         </mc:Choice>
-        <mc:Fallback>
+        <mc:Fallback xmlns="">
           <p:sp>
             <p:nvSpPr>
               <p:cNvPr id="2" name="Title 1">
@@ -10868,8 +10905,8 @@
           </a:p>
         </p:txBody>
       </p:sp>
-      <mc:AlternateContent xmlns:mc="http://schemas.openxmlformats.org/markup-compatibility/2006">
-        <mc:Choice xmlns:a14="http://schemas.microsoft.com/office/drawing/2010/main" Requires="a14">
+      <mc:AlternateContent xmlns:mc="http://schemas.openxmlformats.org/markup-compatibility/2006" xmlns:a14="http://schemas.microsoft.com/office/drawing/2010/main">
+        <mc:Choice Requires="a14">
           <p:sp>
             <p:nvSpPr>
               <p:cNvPr id="2" name="Title 1">
@@ -11014,7 +11051,7 @@
             </p:txBody>
           </p:sp>
         </mc:Choice>
-        <mc:Fallback>
+        <mc:Fallback xmlns="">
           <p:sp>
             <p:nvSpPr>
               <p:cNvPr id="2" name="Title 1">
@@ -11058,8 +11095,8 @@
           </p:sp>
         </mc:Fallback>
       </mc:AlternateContent>
-      <mc:AlternateContent xmlns:mc="http://schemas.openxmlformats.org/markup-compatibility/2006">
-        <mc:Choice xmlns:a14="http://schemas.microsoft.com/office/drawing/2010/main" Requires="a14">
+      <mc:AlternateContent xmlns:mc="http://schemas.openxmlformats.org/markup-compatibility/2006" xmlns:a14="http://schemas.microsoft.com/office/drawing/2010/main">
+        <mc:Choice Requires="a14">
           <p:sp>
             <p:nvSpPr>
               <p:cNvPr id="3" name="Content Placeholder 2">
@@ -11144,7 +11181,7 @@
             </p:txBody>
           </p:sp>
         </mc:Choice>
-        <mc:Fallback>
+        <mc:Fallback xmlns="">
           <p:sp>
             <p:nvSpPr>
               <p:cNvPr id="3" name="Content Placeholder 2">
@@ -11626,8 +11663,8 @@
           </a:p>
         </p:txBody>
       </p:sp>
-      <mc:AlternateContent xmlns:mc="http://schemas.openxmlformats.org/markup-compatibility/2006">
-        <mc:Choice xmlns:a14="http://schemas.microsoft.com/office/drawing/2010/main" Requires="a14">
+      <mc:AlternateContent xmlns:mc="http://schemas.openxmlformats.org/markup-compatibility/2006" xmlns:a14="http://schemas.microsoft.com/office/drawing/2010/main">
+        <mc:Choice Requires="a14">
           <p:sp>
             <p:nvSpPr>
               <p:cNvPr id="2" name="Title 1">
@@ -11772,7 +11809,7 @@
             </p:txBody>
           </p:sp>
         </mc:Choice>
-        <mc:Fallback>
+        <mc:Fallback xmlns="">
           <p:sp>
             <p:nvSpPr>
               <p:cNvPr id="2" name="Title 1">
@@ -11816,8 +11853,8 @@
           </p:sp>
         </mc:Fallback>
       </mc:AlternateContent>
-      <mc:AlternateContent xmlns:mc="http://schemas.openxmlformats.org/markup-compatibility/2006">
-        <mc:Choice xmlns:a14="http://schemas.microsoft.com/office/drawing/2010/main" Requires="a14">
+      <mc:AlternateContent xmlns:mc="http://schemas.openxmlformats.org/markup-compatibility/2006" xmlns:a14="http://schemas.microsoft.com/office/drawing/2010/main">
+        <mc:Choice Requires="a14">
           <p:sp>
             <p:nvSpPr>
               <p:cNvPr id="3" name="Content Placeholder 2">
@@ -12000,7 +12037,7 @@
             </p:txBody>
           </p:sp>
         </mc:Choice>
-        <mc:Fallback>
+        <mc:Fallback xmlns="">
           <p:sp>
             <p:nvSpPr>
               <p:cNvPr id="3" name="Content Placeholder 2">
@@ -12857,8 +12894,8 @@
           </a:p>
         </p:txBody>
       </p:sp>
-      <mc:AlternateContent xmlns:mc="http://schemas.openxmlformats.org/markup-compatibility/2006">
-        <mc:Choice xmlns:a14="http://schemas.microsoft.com/office/drawing/2010/main" Requires="a14">
+      <mc:AlternateContent xmlns:mc="http://schemas.openxmlformats.org/markup-compatibility/2006" xmlns:a14="http://schemas.microsoft.com/office/drawing/2010/main">
+        <mc:Choice Requires="a14">
           <p:sp>
             <p:nvSpPr>
               <p:cNvPr id="2" name="Title 1">
@@ -13003,7 +13040,7 @@
             </p:txBody>
           </p:sp>
         </mc:Choice>
-        <mc:Fallback>
+        <mc:Fallback xmlns="">
           <p:sp>
             <p:nvSpPr>
               <p:cNvPr id="2" name="Title 1">
@@ -13047,8 +13084,8 @@
           </p:sp>
         </mc:Fallback>
       </mc:AlternateContent>
-      <mc:AlternateContent xmlns:mc="http://schemas.openxmlformats.org/markup-compatibility/2006">
-        <mc:Choice xmlns:a14="http://schemas.microsoft.com/office/drawing/2010/main" Requires="a14">
+      <mc:AlternateContent xmlns:mc="http://schemas.openxmlformats.org/markup-compatibility/2006" xmlns:a14="http://schemas.microsoft.com/office/drawing/2010/main">
+        <mc:Choice Requires="a14">
           <p:sp>
             <p:nvSpPr>
               <p:cNvPr id="3" name="Content Placeholder 2">
@@ -13305,7 +13342,7 @@
             </p:txBody>
           </p:sp>
         </mc:Choice>
-        <mc:Fallback>
+        <mc:Fallback xmlns="">
           <p:sp>
             <p:nvSpPr>
               <p:cNvPr id="3" name="Content Placeholder 2">
@@ -13830,8 +13867,8 @@
           <a:chExt cx="0" cy="0"/>
         </a:xfrm>
       </p:grpSpPr>
-      <mc:AlternateContent xmlns:mc="http://schemas.openxmlformats.org/markup-compatibility/2006">
-        <mc:Choice xmlns:a14="http://schemas.microsoft.com/office/drawing/2010/main" Requires="a14">
+      <mc:AlternateContent xmlns:mc="http://schemas.openxmlformats.org/markup-compatibility/2006" xmlns:a14="http://schemas.microsoft.com/office/drawing/2010/main">
+        <mc:Choice Requires="a14">
           <p:sp>
             <p:nvSpPr>
               <p:cNvPr id="3" name="Content Placeholder 2">
@@ -14209,7 +14246,7 @@
             </p:txBody>
           </p:sp>
         </mc:Choice>
-        <mc:Fallback>
+        <mc:Fallback xmlns="">
           <p:sp>
             <p:nvSpPr>
               <p:cNvPr id="3" name="Content Placeholder 2">
@@ -14376,8 +14413,8 @@
           <a:chExt cx="0" cy="0"/>
         </a:xfrm>
       </p:grpSpPr>
-      <mc:AlternateContent xmlns:mc="http://schemas.openxmlformats.org/markup-compatibility/2006">
-        <mc:Choice xmlns:a14="http://schemas.microsoft.com/office/drawing/2010/main" Requires="a14">
+      <mc:AlternateContent xmlns:mc="http://schemas.openxmlformats.org/markup-compatibility/2006" xmlns:a14="http://schemas.microsoft.com/office/drawing/2010/main">
+        <mc:Choice Requires="a14">
           <p:sp>
             <p:nvSpPr>
               <p:cNvPr id="3" name="Content Placeholder 2">
@@ -14755,7 +14792,7 @@
             </p:txBody>
           </p:sp>
         </mc:Choice>
-        <mc:Fallback>
+        <mc:Fallback xmlns="">
           <p:sp>
             <p:nvSpPr>
               <p:cNvPr id="3" name="Content Placeholder 2">
@@ -14922,8 +14959,8 @@
           <a:chExt cx="0" cy="0"/>
         </a:xfrm>
       </p:grpSpPr>
-      <mc:AlternateContent xmlns:mc="http://schemas.openxmlformats.org/markup-compatibility/2006">
-        <mc:Choice xmlns:a14="http://schemas.microsoft.com/office/drawing/2010/main" Requires="a14">
+      <mc:AlternateContent xmlns:mc="http://schemas.openxmlformats.org/markup-compatibility/2006" xmlns:a14="http://schemas.microsoft.com/office/drawing/2010/main">
+        <mc:Choice Requires="a14">
           <p:sp>
             <p:nvSpPr>
               <p:cNvPr id="3" name="Content Placeholder 2">
@@ -15301,7 +15338,7 @@
             </p:txBody>
           </p:sp>
         </mc:Choice>
-        <mc:Fallback>
+        <mc:Fallback xmlns="">
           <p:sp>
             <p:nvSpPr>
               <p:cNvPr id="3" name="Content Placeholder 2">
@@ -15766,8 +15803,8 @@
           <a:chExt cx="0" cy="0"/>
         </a:xfrm>
       </p:grpSpPr>
-      <mc:AlternateContent xmlns:mc="http://schemas.openxmlformats.org/markup-compatibility/2006">
-        <mc:Choice xmlns:a14="http://schemas.microsoft.com/office/drawing/2010/main" Requires="a14">
+      <mc:AlternateContent xmlns:mc="http://schemas.openxmlformats.org/markup-compatibility/2006" xmlns:a14="http://schemas.microsoft.com/office/drawing/2010/main">
+        <mc:Choice Requires="a14">
           <p:sp>
             <p:nvSpPr>
               <p:cNvPr id="2" name="Title 1">
@@ -15789,6 +15826,7 @@
               <a:bodyPr/>
               <a:lstStyle/>
               <a:p>
+                <a:pPr/>
                 <a14:m>
                   <m:oMathPara xmlns:m="http://schemas.openxmlformats.org/officeDocument/2006/math">
                     <m:oMathParaPr>
@@ -15886,7 +15924,7 @@
             </p:txBody>
           </p:sp>
         </mc:Choice>
-        <mc:Fallback>
+        <mc:Fallback xmlns="">
           <p:sp>
             <p:nvSpPr>
               <p:cNvPr id="2" name="Title 1">
@@ -15962,8 +16000,8 @@
           <a:chExt cx="0" cy="0"/>
         </a:xfrm>
       </p:grpSpPr>
-      <mc:AlternateContent xmlns:mc="http://schemas.openxmlformats.org/markup-compatibility/2006">
-        <mc:Choice xmlns:a14="http://schemas.microsoft.com/office/drawing/2010/main" Requires="a14">
+      <mc:AlternateContent xmlns:mc="http://schemas.openxmlformats.org/markup-compatibility/2006" xmlns:a14="http://schemas.microsoft.com/office/drawing/2010/main">
+        <mc:Choice Requires="a14">
           <p:sp>
             <p:nvSpPr>
               <p:cNvPr id="2" name="Title 1">
@@ -16083,7 +16121,7 @@
             </p:txBody>
           </p:sp>
         </mc:Choice>
-        <mc:Fallback>
+        <mc:Fallback xmlns="">
           <p:sp>
             <p:nvSpPr>
               <p:cNvPr id="2" name="Title 1">
@@ -16123,8 +16161,8 @@
           </p:sp>
         </mc:Fallback>
       </mc:AlternateContent>
-      <mc:AlternateContent xmlns:mc="http://schemas.openxmlformats.org/markup-compatibility/2006">
-        <mc:Choice xmlns:a14="http://schemas.microsoft.com/office/drawing/2010/main" Requires="a14">
+      <mc:AlternateContent xmlns:mc="http://schemas.openxmlformats.org/markup-compatibility/2006" xmlns:a14="http://schemas.microsoft.com/office/drawing/2010/main">
+        <mc:Choice Requires="a14">
           <p:sp>
             <p:nvSpPr>
               <p:cNvPr id="3" name="Content Placeholder 2">
@@ -16197,7 +16235,7 @@
             </p:txBody>
           </p:sp>
         </mc:Choice>
-        <mc:Fallback>
+        <mc:Fallback xmlns="">
           <p:sp>
             <p:nvSpPr>
               <p:cNvPr id="3" name="Content Placeholder 2">
@@ -16273,8 +16311,8 @@
           <a:chExt cx="0" cy="0"/>
         </a:xfrm>
       </p:grpSpPr>
-      <mc:AlternateContent xmlns:mc="http://schemas.openxmlformats.org/markup-compatibility/2006">
-        <mc:Choice xmlns:a14="http://schemas.microsoft.com/office/drawing/2010/main" Requires="a14">
+      <mc:AlternateContent xmlns:mc="http://schemas.openxmlformats.org/markup-compatibility/2006" xmlns:a14="http://schemas.microsoft.com/office/drawing/2010/main">
+        <mc:Choice Requires="a14">
           <p:sp>
             <p:nvSpPr>
               <p:cNvPr id="2" name="Title 1">
@@ -16394,7 +16432,7 @@
             </p:txBody>
           </p:sp>
         </mc:Choice>
-        <mc:Fallback>
+        <mc:Fallback xmlns="">
           <p:sp>
             <p:nvSpPr>
               <p:cNvPr id="2" name="Title 1">
@@ -16434,8 +16472,8 @@
           </p:sp>
         </mc:Fallback>
       </mc:AlternateContent>
-      <mc:AlternateContent xmlns:mc="http://schemas.openxmlformats.org/markup-compatibility/2006">
-        <mc:Choice xmlns:a14="http://schemas.microsoft.com/office/drawing/2010/main" Requires="a14">
+      <mc:AlternateContent xmlns:mc="http://schemas.openxmlformats.org/markup-compatibility/2006" xmlns:a14="http://schemas.microsoft.com/office/drawing/2010/main">
+        <mc:Choice Requires="a14">
           <p:sp>
             <p:nvSpPr>
               <p:cNvPr id="3" name="Content Placeholder 2">
@@ -16734,7 +16772,7 @@
             </p:txBody>
           </p:sp>
         </mc:Choice>
-        <mc:Fallback>
+        <mc:Fallback xmlns="">
           <p:sp>
             <p:nvSpPr>
               <p:cNvPr id="3" name="Content Placeholder 2">
@@ -16810,8 +16848,8 @@
           <a:chExt cx="0" cy="0"/>
         </a:xfrm>
       </p:grpSpPr>
-      <mc:AlternateContent xmlns:mc="http://schemas.openxmlformats.org/markup-compatibility/2006">
-        <mc:Choice xmlns:a14="http://schemas.microsoft.com/office/drawing/2010/main" Requires="a14">
+      <mc:AlternateContent xmlns:mc="http://schemas.openxmlformats.org/markup-compatibility/2006" xmlns:a14="http://schemas.microsoft.com/office/drawing/2010/main">
+        <mc:Choice Requires="a14">
           <p:sp>
             <p:nvSpPr>
               <p:cNvPr id="2" name="Title 1">
@@ -16931,7 +16969,7 @@
             </p:txBody>
           </p:sp>
         </mc:Choice>
-        <mc:Fallback>
+        <mc:Fallback xmlns="">
           <p:sp>
             <p:nvSpPr>
               <p:cNvPr id="2" name="Title 1">
@@ -16971,8 +17009,8 @@
           </p:sp>
         </mc:Fallback>
       </mc:AlternateContent>
-      <mc:AlternateContent xmlns:mc="http://schemas.openxmlformats.org/markup-compatibility/2006">
-        <mc:Choice xmlns:a14="http://schemas.microsoft.com/office/drawing/2010/main" Requires="a14">
+      <mc:AlternateContent xmlns:mc="http://schemas.openxmlformats.org/markup-compatibility/2006" xmlns:a14="http://schemas.microsoft.com/office/drawing/2010/main">
+        <mc:Choice Requires="a14">
           <p:sp>
             <p:nvSpPr>
               <p:cNvPr id="3" name="Content Placeholder 2">
@@ -17395,7 +17433,7 @@
             </p:txBody>
           </p:sp>
         </mc:Choice>
-        <mc:Fallback>
+        <mc:Fallback xmlns="">
           <p:sp>
             <p:nvSpPr>
               <p:cNvPr id="3" name="Content Placeholder 2">
@@ -17692,8 +17730,8 @@
           <a:chExt cx="0" cy="0"/>
         </a:xfrm>
       </p:grpSpPr>
-      <mc:AlternateContent xmlns:mc="http://schemas.openxmlformats.org/markup-compatibility/2006">
-        <mc:Choice xmlns:a14="http://schemas.microsoft.com/office/drawing/2010/main" Requires="a14">
+      <mc:AlternateContent xmlns:mc="http://schemas.openxmlformats.org/markup-compatibility/2006" xmlns:a14="http://schemas.microsoft.com/office/drawing/2010/main">
+        <mc:Choice Requires="a14">
           <p:sp>
             <p:nvSpPr>
               <p:cNvPr id="2" name="Title 1">
@@ -17813,7 +17851,7 @@
             </p:txBody>
           </p:sp>
         </mc:Choice>
-        <mc:Fallback>
+        <mc:Fallback xmlns="">
           <p:sp>
             <p:nvSpPr>
               <p:cNvPr id="2" name="Title 1">
@@ -17853,8 +17891,8 @@
           </p:sp>
         </mc:Fallback>
       </mc:AlternateContent>
-      <mc:AlternateContent xmlns:mc="http://schemas.openxmlformats.org/markup-compatibility/2006">
-        <mc:Choice xmlns:a14="http://schemas.microsoft.com/office/drawing/2010/main" Requires="a14">
+      <mc:AlternateContent xmlns:mc="http://schemas.openxmlformats.org/markup-compatibility/2006" xmlns:a14="http://schemas.microsoft.com/office/drawing/2010/main">
+        <mc:Choice Requires="a14">
           <p:sp>
             <p:nvSpPr>
               <p:cNvPr id="3" name="Content Placeholder 2">
@@ -18277,7 +18315,7 @@
             </p:txBody>
           </p:sp>
         </mc:Choice>
-        <mc:Fallback>
+        <mc:Fallback xmlns="">
           <p:sp>
             <p:nvSpPr>
               <p:cNvPr id="3" name="Content Placeholder 2">
@@ -18317,8 +18355,8 @@
           </p:sp>
         </mc:Fallback>
       </mc:AlternateContent>
-      <mc:AlternateContent xmlns:mc="http://schemas.openxmlformats.org/markup-compatibility/2006">
-        <mc:Choice xmlns:a14="http://schemas.microsoft.com/office/drawing/2010/main" Requires="a14">
+      <mc:AlternateContent xmlns:mc="http://schemas.openxmlformats.org/markup-compatibility/2006" xmlns:a14="http://schemas.microsoft.com/office/drawing/2010/main">
+        <mc:Choice Requires="a14">
           <p:sp>
             <p:nvSpPr>
               <p:cNvPr id="4" name="TextBox 3">
@@ -18441,7 +18479,7 @@
             </p:txBody>
           </p:sp>
         </mc:Choice>
-        <mc:Fallback>
+        <mc:Fallback xmlns="">
           <p:sp>
             <p:nvSpPr>
               <p:cNvPr id="4" name="TextBox 3">
@@ -18544,8 +18582,8 @@
           </a:p>
         </p:txBody>
       </p:sp>
-      <mc:AlternateContent xmlns:mc="http://schemas.openxmlformats.org/markup-compatibility/2006">
-        <mc:Choice xmlns:a14="http://schemas.microsoft.com/office/drawing/2010/main" Requires="a14">
+      <mc:AlternateContent xmlns:mc="http://schemas.openxmlformats.org/markup-compatibility/2006" xmlns:a14="http://schemas.microsoft.com/office/drawing/2010/main">
+        <mc:Choice Requires="a14">
           <p:sp>
             <p:nvSpPr>
               <p:cNvPr id="3" name="Content Placeholder 2">
@@ -18609,7 +18647,7 @@
             </p:txBody>
           </p:sp>
         </mc:Choice>
-        <mc:Fallback>
+        <mc:Fallback xmlns="">
           <p:sp>
             <p:nvSpPr>
               <p:cNvPr id="3" name="Content Placeholder 2">
@@ -18713,8 +18751,8 @@
           </a:p>
         </p:txBody>
       </p:sp>
-      <mc:AlternateContent xmlns:mc="http://schemas.openxmlformats.org/markup-compatibility/2006">
-        <mc:Choice xmlns:a14="http://schemas.microsoft.com/office/drawing/2010/main" Requires="a14">
+      <mc:AlternateContent xmlns:mc="http://schemas.openxmlformats.org/markup-compatibility/2006" xmlns:a14="http://schemas.microsoft.com/office/drawing/2010/main">
+        <mc:Choice Requires="a14">
           <p:sp>
             <p:nvSpPr>
               <p:cNvPr id="3" name="Content Placeholder 2">
@@ -18982,7 +19020,7 @@
             </p:txBody>
           </p:sp>
         </mc:Choice>
-        <mc:Fallback>
+        <mc:Fallback xmlns="">
           <p:sp>
             <p:nvSpPr>
               <p:cNvPr id="3" name="Content Placeholder 2">
@@ -19086,8 +19124,8 @@
           </a:p>
         </p:txBody>
       </p:sp>
-      <mc:AlternateContent xmlns:mc="http://schemas.openxmlformats.org/markup-compatibility/2006">
-        <mc:Choice xmlns:a14="http://schemas.microsoft.com/office/drawing/2010/main" Requires="a14">
+      <mc:AlternateContent xmlns:mc="http://schemas.openxmlformats.org/markup-compatibility/2006" xmlns:a14="http://schemas.microsoft.com/office/drawing/2010/main">
+        <mc:Choice Requires="a14">
           <p:sp>
             <p:nvSpPr>
               <p:cNvPr id="3" name="Content Placeholder 2">
@@ -19578,7 +19616,7 @@
             </p:txBody>
           </p:sp>
         </mc:Choice>
-        <mc:Fallback>
+        <mc:Fallback xmlns="">
           <p:sp>
             <p:nvSpPr>
               <p:cNvPr id="3" name="Content Placeholder 2">
@@ -20103,8 +20141,8 @@
           <a:chExt cx="0" cy="0"/>
         </a:xfrm>
       </p:grpSpPr>
-      <mc:AlternateContent xmlns:mc="http://schemas.openxmlformats.org/markup-compatibility/2006">
-        <mc:Choice xmlns:a14="http://schemas.microsoft.com/office/drawing/2010/main" Requires="a14">
+      <mc:AlternateContent xmlns:mc="http://schemas.openxmlformats.org/markup-compatibility/2006" xmlns:a14="http://schemas.microsoft.com/office/drawing/2010/main">
+        <mc:Choice Requires="a14">
           <p:sp>
             <p:nvSpPr>
               <p:cNvPr id="2" name="Title 1">
@@ -20226,7 +20264,7 @@
             </p:txBody>
           </p:sp>
         </mc:Choice>
-        <mc:Fallback>
+        <mc:Fallback xmlns="">
           <p:sp>
             <p:nvSpPr>
               <p:cNvPr id="2" name="Title 1">
@@ -20266,8 +20304,8 @@
           </p:sp>
         </mc:Fallback>
       </mc:AlternateContent>
-      <mc:AlternateContent xmlns:mc="http://schemas.openxmlformats.org/markup-compatibility/2006">
-        <mc:Choice xmlns:a14="http://schemas.microsoft.com/office/drawing/2010/main" Requires="a14">
+      <mc:AlternateContent xmlns:mc="http://schemas.openxmlformats.org/markup-compatibility/2006" xmlns:a14="http://schemas.microsoft.com/office/drawing/2010/main">
+        <mc:Choice Requires="a14">
           <p:sp>
             <p:nvSpPr>
               <p:cNvPr id="3" name="Content Placeholder 2">
@@ -20362,7 +20400,7 @@
             </p:txBody>
           </p:sp>
         </mc:Choice>
-        <mc:Fallback>
+        <mc:Fallback xmlns="">
           <p:sp>
             <p:nvSpPr>
               <p:cNvPr id="3" name="Content Placeholder 2">
@@ -20432,8 +20470,8 @@
           <a:chExt cx="0" cy="0"/>
         </a:xfrm>
       </p:grpSpPr>
-      <mc:AlternateContent xmlns:mc="http://schemas.openxmlformats.org/markup-compatibility/2006">
-        <mc:Choice xmlns:a14="http://schemas.microsoft.com/office/drawing/2010/main" Requires="a14">
+      <mc:AlternateContent xmlns:mc="http://schemas.openxmlformats.org/markup-compatibility/2006" xmlns:a14="http://schemas.microsoft.com/office/drawing/2010/main">
+        <mc:Choice Requires="a14">
           <p:sp>
             <p:nvSpPr>
               <p:cNvPr id="2" name="Title 1">
@@ -20457,6 +20495,7 @@
               </a:bodyPr>
               <a:lstStyle/>
               <a:p>
+                <a:pPr/>
                 <a14:m>
                   <m:oMathPara xmlns:m="http://schemas.openxmlformats.org/officeDocument/2006/math">
                     <m:oMathParaPr>
@@ -20554,7 +20593,7 @@
             </p:txBody>
           </p:sp>
         </mc:Choice>
-        <mc:Fallback>
+        <mc:Fallback xmlns="">
           <p:sp>
             <p:nvSpPr>
               <p:cNvPr id="2" name="Title 1">
@@ -20594,8 +20633,8 @@
           </p:sp>
         </mc:Fallback>
       </mc:AlternateContent>
-      <mc:AlternateContent xmlns:mc="http://schemas.openxmlformats.org/markup-compatibility/2006">
-        <mc:Choice xmlns:a14="http://schemas.microsoft.com/office/drawing/2010/main" Requires="a14">
+      <mc:AlternateContent xmlns:mc="http://schemas.openxmlformats.org/markup-compatibility/2006" xmlns:a14="http://schemas.microsoft.com/office/drawing/2010/main">
+        <mc:Choice Requires="a14">
           <p:sp>
             <p:nvSpPr>
               <p:cNvPr id="3" name="Content Placeholder 2">
@@ -20858,7 +20897,9 @@
                       <m:rPr>
                         <m:sty m:val="p"/>
                       </m:rPr>
-                      <a:rPr lang="el-GR" i="1"/>
+                      <a:rPr lang="el-GR" i="1">
+                        <a:latin typeface="Cambria Math" panose="02040503050406030204" pitchFamily="18" charset="0"/>
+                      </a:rPr>
                       <m:t>Θ</m:t>
                     </m:r>
                     <m:r>
@@ -20877,7 +20918,7 @@
             </p:txBody>
           </p:sp>
         </mc:Choice>
-        <mc:Fallback>
+        <mc:Fallback xmlns="">
           <p:sp>
             <p:nvSpPr>
               <p:cNvPr id="3" name="Content Placeholder 2">
@@ -20953,8 +20994,8 @@
           <a:chExt cx="0" cy="0"/>
         </a:xfrm>
       </p:grpSpPr>
-      <mc:AlternateContent xmlns:mc="http://schemas.openxmlformats.org/markup-compatibility/2006">
-        <mc:Choice xmlns:a14="http://schemas.microsoft.com/office/drawing/2010/main" Requires="a14">
+      <mc:AlternateContent xmlns:mc="http://schemas.openxmlformats.org/markup-compatibility/2006" xmlns:a14="http://schemas.microsoft.com/office/drawing/2010/main">
+        <mc:Choice Requires="a14">
           <p:sp>
             <p:nvSpPr>
               <p:cNvPr id="2" name="Title 1">
@@ -21076,7 +21117,7 @@
             </p:txBody>
           </p:sp>
         </mc:Choice>
-        <mc:Fallback>
+        <mc:Fallback xmlns="">
           <p:sp>
             <p:nvSpPr>
               <p:cNvPr id="2" name="Title 1">
@@ -21116,8 +21157,8 @@
           </p:sp>
         </mc:Fallback>
       </mc:AlternateContent>
-      <mc:AlternateContent xmlns:mc="http://schemas.openxmlformats.org/markup-compatibility/2006">
-        <mc:Choice xmlns:a14="http://schemas.microsoft.com/office/drawing/2010/main" Requires="a14">
+      <mc:AlternateContent xmlns:mc="http://schemas.openxmlformats.org/markup-compatibility/2006" xmlns:a14="http://schemas.microsoft.com/office/drawing/2010/main">
+        <mc:Choice Requires="a14">
           <p:sp>
             <p:nvSpPr>
               <p:cNvPr id="3" name="Content Placeholder 2">
@@ -21442,7 +21483,9 @@
                       <m:rPr>
                         <m:sty m:val="p"/>
                       </m:rPr>
-                      <a:rPr lang="el-GR" i="1"/>
+                      <a:rPr lang="el-GR" i="1">
+                        <a:latin typeface="Cambria Math" panose="02040503050406030204" pitchFamily="18" charset="0"/>
+                      </a:rPr>
                       <m:t>Θ</m:t>
                     </m:r>
                     <m:d>
@@ -21588,7 +21631,9 @@
                       <m:rPr>
                         <m:sty m:val="p"/>
                       </m:rPr>
-                      <a:rPr lang="el-GR" i="1"/>
+                      <a:rPr lang="el-GR" i="1">
+                        <a:latin typeface="Cambria Math" panose="02040503050406030204" pitchFamily="18" charset="0"/>
+                      </a:rPr>
                       <m:t>Θ</m:t>
                     </m:r>
                     <m:d>
@@ -21621,7 +21666,7 @@
             </p:txBody>
           </p:sp>
         </mc:Choice>
-        <mc:Fallback>
+        <mc:Fallback xmlns="">
           <p:sp>
             <p:nvSpPr>
               <p:cNvPr id="3" name="Content Placeholder 2">
@@ -21661,8 +21706,8 @@
           </p:sp>
         </mc:Fallback>
       </mc:AlternateContent>
-      <mc:AlternateContent xmlns:mc="http://schemas.openxmlformats.org/markup-compatibility/2006">
-        <mc:Choice xmlns:a14="http://schemas.microsoft.com/office/drawing/2010/main" Requires="a14">
+      <mc:AlternateContent xmlns:mc="http://schemas.openxmlformats.org/markup-compatibility/2006" xmlns:a14="http://schemas.microsoft.com/office/drawing/2010/main">
+        <mc:Choice Requires="a14">
           <p:sp>
             <p:nvSpPr>
               <p:cNvPr id="4" name="TextBox 3">
@@ -21778,7 +21823,7 @@
             </p:txBody>
           </p:sp>
         </mc:Choice>
-        <mc:Fallback>
+        <mc:Fallback xmlns="">
           <p:sp>
             <p:nvSpPr>
               <p:cNvPr id="4" name="TextBox 3">
@@ -21853,8 +21898,8 @@
           <a:chExt cx="0" cy="0"/>
         </a:xfrm>
       </p:grpSpPr>
-      <mc:AlternateContent xmlns:mc="http://schemas.openxmlformats.org/markup-compatibility/2006">
-        <mc:Choice xmlns:a14="http://schemas.microsoft.com/office/drawing/2010/main" Requires="a14">
+      <mc:AlternateContent xmlns:mc="http://schemas.openxmlformats.org/markup-compatibility/2006" xmlns:a14="http://schemas.microsoft.com/office/drawing/2010/main">
+        <mc:Choice Requires="a14">
           <p:sp>
             <p:nvSpPr>
               <p:cNvPr id="2" name="Title 1">
@@ -21876,6 +21921,7 @@
               <a:bodyPr/>
               <a:lstStyle/>
               <a:p>
+                <a:pPr/>
                 <a14:m>
                   <m:oMathPara xmlns:m="http://schemas.openxmlformats.org/officeDocument/2006/math">
                     <m:oMathParaPr>
@@ -22003,7 +22049,7 @@
             </p:txBody>
           </p:sp>
         </mc:Choice>
-        <mc:Fallback>
+        <mc:Fallback xmlns="">
           <p:sp>
             <p:nvSpPr>
               <p:cNvPr id="2" name="Title 1">
@@ -22079,8 +22125,8 @@
           <a:chExt cx="0" cy="0"/>
         </a:xfrm>
       </p:grpSpPr>
-      <mc:AlternateContent xmlns:mc="http://schemas.openxmlformats.org/markup-compatibility/2006">
-        <mc:Choice xmlns:a14="http://schemas.microsoft.com/office/drawing/2010/main" Requires="a14">
+      <mc:AlternateContent xmlns:mc="http://schemas.openxmlformats.org/markup-compatibility/2006" xmlns:a14="http://schemas.microsoft.com/office/drawing/2010/main">
+        <mc:Choice Requires="a14">
           <p:sp>
             <p:nvSpPr>
               <p:cNvPr id="2" name="Title 1">
@@ -22230,7 +22276,7 @@
             </p:txBody>
           </p:sp>
         </mc:Choice>
-        <mc:Fallback>
+        <mc:Fallback xmlns="">
           <p:sp>
             <p:nvSpPr>
               <p:cNvPr id="2" name="Title 1">
@@ -22527,8 +22573,8 @@
           <a:chExt cx="0" cy="0"/>
         </a:xfrm>
       </p:grpSpPr>
-      <mc:AlternateContent xmlns:mc="http://schemas.openxmlformats.org/markup-compatibility/2006">
-        <mc:Choice xmlns:a14="http://schemas.microsoft.com/office/drawing/2010/main" Requires="a14">
+      <mc:AlternateContent xmlns:mc="http://schemas.openxmlformats.org/markup-compatibility/2006" xmlns:a14="http://schemas.microsoft.com/office/drawing/2010/main">
+        <mc:Choice Requires="a14">
           <p:sp>
             <p:nvSpPr>
               <p:cNvPr id="3" name="Content Placeholder 2">
@@ -22765,7 +22811,7 @@
             </p:txBody>
           </p:sp>
         </mc:Choice>
-        <mc:Fallback>
+        <mc:Fallback xmlns="">
           <p:sp>
             <p:nvSpPr>
               <p:cNvPr id="3" name="Content Placeholder 2">
@@ -22910,8 +22956,8 @@
           <a:chExt cx="0" cy="0"/>
         </a:xfrm>
       </p:grpSpPr>
-      <mc:AlternateContent xmlns:mc="http://schemas.openxmlformats.org/markup-compatibility/2006">
-        <mc:Choice xmlns:a14="http://schemas.microsoft.com/office/drawing/2010/main" Requires="a14">
+      <mc:AlternateContent xmlns:mc="http://schemas.openxmlformats.org/markup-compatibility/2006" xmlns:a14="http://schemas.microsoft.com/office/drawing/2010/main">
+        <mc:Choice Requires="a14">
           <p:sp>
             <p:nvSpPr>
               <p:cNvPr id="3" name="Content Placeholder 2">
@@ -22950,61 +22996,61 @@
                     </m:oMathParaPr>
                     <m:oMath xmlns:m="http://schemas.openxmlformats.org/officeDocument/2006/math">
                       <m:r>
-                        <a:rPr lang="en-US" b="0" i="1" smtClean="0">
+                        <a:rPr lang="en-US" sz="3200" b="0" i="1" smtClean="0">
                           <a:latin typeface="Cambria Math" panose="02040503050406030204" pitchFamily="18" charset="0"/>
                         </a:rPr>
                         <m:t>𝑖𝑓</m:t>
                       </m:r>
                       <m:r>
-                        <a:rPr lang="en-US" b="0" i="1" smtClean="0">
+                        <a:rPr lang="en-US" sz="3200" b="0" i="1" smtClean="0">
                           <a:latin typeface="Cambria Math" panose="02040503050406030204" pitchFamily="18" charset="0"/>
                         </a:rPr>
                         <m:t> ∃</m:t>
                       </m:r>
                       <m:r>
-                        <a:rPr lang="en-US" b="0" i="1" smtClean="0">
+                        <a:rPr lang="en-US" sz="3200" b="0" i="1" smtClean="0">
                           <a:latin typeface="Cambria Math" panose="02040503050406030204" pitchFamily="18" charset="0"/>
                           <a:ea typeface="Cambria Math" panose="02040503050406030204" pitchFamily="18" charset="0"/>
                         </a:rPr>
                         <m:t>𝜖</m:t>
                       </m:r>
                       <m:r>
-                        <a:rPr lang="en-US" b="0" i="1" smtClean="0">
+                        <a:rPr lang="en-US" sz="3200" b="0" i="1" smtClean="0">
                           <a:latin typeface="Cambria Math" panose="02040503050406030204" pitchFamily="18" charset="0"/>
                           <a:ea typeface="Cambria Math" panose="02040503050406030204" pitchFamily="18" charset="0"/>
                         </a:rPr>
                         <m:t>&gt;0, </m:t>
                       </m:r>
                       <m:r>
-                        <a:rPr lang="en-US" b="0" i="1" smtClean="0">
+                        <a:rPr lang="en-US" sz="3200" b="0" i="1" smtClean="0">
                           <a:latin typeface="Cambria Math" panose="02040503050406030204" pitchFamily="18" charset="0"/>
                           <a:ea typeface="Cambria Math" panose="02040503050406030204" pitchFamily="18" charset="0"/>
                         </a:rPr>
                         <m:t>𝑠𝑢𝑐h</m:t>
                       </m:r>
                       <m:r>
-                        <a:rPr lang="en-US" b="0" i="1" smtClean="0">
+                        <a:rPr lang="en-US" sz="3200" b="0" i="1" smtClean="0">
                           <a:latin typeface="Cambria Math" panose="02040503050406030204" pitchFamily="18" charset="0"/>
                           <a:ea typeface="Cambria Math" panose="02040503050406030204" pitchFamily="18" charset="0"/>
                         </a:rPr>
                         <m:t> </m:t>
                       </m:r>
                       <m:r>
-                        <a:rPr lang="en-US" b="0" i="1" smtClean="0">
+                        <a:rPr lang="en-US" sz="3200" b="0" i="1" smtClean="0">
                           <a:latin typeface="Cambria Math" panose="02040503050406030204" pitchFamily="18" charset="0"/>
                           <a:ea typeface="Cambria Math" panose="02040503050406030204" pitchFamily="18" charset="0"/>
                         </a:rPr>
                         <m:t>𝑡h𝑎𝑡</m:t>
                       </m:r>
                       <m:r>
-                        <a:rPr lang="en-US" b="0" i="1" smtClean="0">
+                        <a:rPr lang="en-US" sz="3200" b="0" i="1" smtClean="0">
                           <a:latin typeface="Cambria Math" panose="02040503050406030204" pitchFamily="18" charset="0"/>
                           <a:ea typeface="Cambria Math" panose="02040503050406030204" pitchFamily="18" charset="0"/>
                         </a:rPr>
                         <m:t> </m:t>
                       </m:r>
                       <m:r>
-                        <a:rPr lang="en-US" b="0" i="1" smtClean="0">
+                        <a:rPr lang="en-US" sz="3200" b="0" i="1" smtClean="0">
                           <a:latin typeface="Cambria Math" panose="02040503050406030204" pitchFamily="18" charset="0"/>
                           <a:ea typeface="Cambria Math" panose="02040503050406030204" pitchFamily="18" charset="0"/>
                         </a:rPr>
@@ -23013,7 +23059,7 @@
                       <m:d>
                         <m:dPr>
                           <m:ctrlPr>
-                            <a:rPr lang="en-US" b="0" i="1" smtClean="0">
+                            <a:rPr lang="en-US" sz="3200" b="0" i="1" smtClean="0">
                               <a:latin typeface="Cambria Math" panose="02040503050406030204" pitchFamily="18" charset="0"/>
                               <a:ea typeface="Cambria Math" panose="02040503050406030204" pitchFamily="18" charset="0"/>
                             </a:rPr>
@@ -23021,7 +23067,7 @@
                         </m:dPr>
                         <m:e>
                           <m:r>
-                            <a:rPr lang="en-US" b="0" i="1" smtClean="0">
+                            <a:rPr lang="en-US" sz="3200" b="0" i="1" smtClean="0">
                               <a:latin typeface="Cambria Math" panose="02040503050406030204" pitchFamily="18" charset="0"/>
                               <a:ea typeface="Cambria Math" panose="02040503050406030204" pitchFamily="18" charset="0"/>
                             </a:rPr>
@@ -23030,7 +23076,7 @@
                         </m:e>
                       </m:d>
                       <m:r>
-                        <a:rPr lang="en-US" b="0" i="1" smtClean="0">
+                        <a:rPr lang="en-US" sz="3200" b="0" i="1" smtClean="0">
                           <a:latin typeface="Cambria Math" panose="02040503050406030204" pitchFamily="18" charset="0"/>
                           <a:ea typeface="Cambria Math" panose="02040503050406030204" pitchFamily="18" charset="0"/>
                         </a:rPr>
@@ -23040,7 +23086,7 @@
                         <m:rPr>
                           <m:sty m:val="p"/>
                         </m:rPr>
-                        <a:rPr lang="el-GR" b="0" i="1" smtClean="0">
+                        <a:rPr lang="el-GR" sz="3200" b="0" i="1" smtClean="0">
                           <a:latin typeface="Cambria Math" panose="02040503050406030204" pitchFamily="18" charset="0"/>
                           <a:ea typeface="Cambria Math" panose="02040503050406030204" pitchFamily="18" charset="0"/>
                         </a:rPr>
@@ -23049,7 +23095,7 @@
                       <m:d>
                         <m:dPr>
                           <m:ctrlPr>
-                            <a:rPr lang="en-US" b="0" i="1" smtClean="0">
+                            <a:rPr lang="en-US" sz="3200" b="0" i="1" smtClean="0">
                               <a:latin typeface="Cambria Math" panose="02040503050406030204" pitchFamily="18" charset="0"/>
                               <a:ea typeface="Cambria Math" panose="02040503050406030204" pitchFamily="18" charset="0"/>
                             </a:rPr>
@@ -23059,7 +23105,7 @@
                           <m:sSup>
                             <m:sSupPr>
                               <m:ctrlPr>
-                                <a:rPr lang="en-US" b="0" i="1" smtClean="0">
+                                <a:rPr lang="en-US" sz="3200" b="0" i="1" smtClean="0">
                                   <a:latin typeface="Cambria Math" panose="02040503050406030204" pitchFamily="18" charset="0"/>
                                   <a:ea typeface="Cambria Math" panose="02040503050406030204" pitchFamily="18" charset="0"/>
                                 </a:rPr>
@@ -23067,7 +23113,7 @@
                             </m:sSupPr>
                             <m:e>
                               <m:r>
-                                <a:rPr lang="en-US" b="0" i="1" smtClean="0">
+                                <a:rPr lang="en-US" sz="3200" b="0" i="1" smtClean="0">
                                   <a:latin typeface="Cambria Math" panose="02040503050406030204" pitchFamily="18" charset="0"/>
                                   <a:ea typeface="Cambria Math" panose="02040503050406030204" pitchFamily="18" charset="0"/>
                                 </a:rPr>
@@ -23078,7 +23124,7 @@
                               <m:sSub>
                                 <m:sSubPr>
                                   <m:ctrlPr>
-                                    <a:rPr lang="en-US" b="0" i="1" smtClean="0">
+                                    <a:rPr lang="en-US" sz="3200" b="0" i="1" smtClean="0">
                                       <a:latin typeface="Cambria Math" panose="02040503050406030204" pitchFamily="18" charset="0"/>
                                       <a:ea typeface="Cambria Math" panose="02040503050406030204" pitchFamily="18" charset="0"/>
                                     </a:rPr>
@@ -23086,7 +23132,7 @@
                                 </m:sSubPr>
                                 <m:e>
                                   <m:r>
-                                    <a:rPr lang="en-US" b="0" i="1" smtClean="0">
+                                    <a:rPr lang="en-US" sz="3200" b="0" i="1" smtClean="0">
                                       <a:latin typeface="Cambria Math" panose="02040503050406030204" pitchFamily="18" charset="0"/>
                                       <a:ea typeface="Cambria Math" panose="02040503050406030204" pitchFamily="18" charset="0"/>
                                     </a:rPr>
@@ -23095,7 +23141,7 @@
                                 </m:e>
                                 <m:sub>
                                   <m:r>
-                                    <a:rPr lang="en-US" b="0" i="1" smtClean="0">
+                                    <a:rPr lang="en-US" sz="3200" b="0" i="1" smtClean="0">
                                       <a:latin typeface="Cambria Math" panose="02040503050406030204" pitchFamily="18" charset="0"/>
                                       <a:ea typeface="Cambria Math" panose="02040503050406030204" pitchFamily="18" charset="0"/>
                                     </a:rPr>
@@ -23106,7 +23152,7 @@
                               <m:d>
                                 <m:dPr>
                                   <m:ctrlPr>
-                                    <a:rPr lang="en-US" b="0" i="1" smtClean="0">
+                                    <a:rPr lang="en-US" sz="3200" b="0" i="1" smtClean="0">
                                       <a:latin typeface="Cambria Math" panose="02040503050406030204" pitchFamily="18" charset="0"/>
                                       <a:ea typeface="Cambria Math" panose="02040503050406030204" pitchFamily="18" charset="0"/>
                                     </a:rPr>
@@ -23114,7 +23160,7 @@
                                 </m:dPr>
                                 <m:e>
                                   <m:r>
-                                    <a:rPr lang="en-US" b="0" i="1" smtClean="0">
+                                    <a:rPr lang="en-US" sz="3200" b="0" i="1" smtClean="0">
                                       <a:latin typeface="Cambria Math" panose="02040503050406030204" pitchFamily="18" charset="0"/>
                                       <a:ea typeface="Cambria Math" panose="02040503050406030204" pitchFamily="18" charset="0"/>
                                     </a:rPr>
@@ -23123,14 +23169,14 @@
                                 </m:e>
                               </m:d>
                               <m:r>
-                                <a:rPr lang="en-US" b="0" i="1" smtClean="0">
+                                <a:rPr lang="en-US" sz="3200" b="0" i="1" smtClean="0">
                                   <a:latin typeface="Cambria Math" panose="02040503050406030204" pitchFamily="18" charset="0"/>
                                   <a:ea typeface="Cambria Math" panose="02040503050406030204" pitchFamily="18" charset="0"/>
                                 </a:rPr>
                                 <m:t>+</m:t>
                               </m:r>
                               <m:r>
-                                <a:rPr lang="en-US" i="1">
+                                <a:rPr lang="en-US" sz="3200" i="1">
                                   <a:latin typeface="Cambria Math" panose="02040503050406030204" pitchFamily="18" charset="0"/>
                                   <a:ea typeface="Cambria Math" panose="02040503050406030204" pitchFamily="18" charset="0"/>
                                 </a:rPr>
@@ -23143,7 +23189,7 @@
                     </m:oMath>
                   </m:oMathPara>
                 </a14:m>
-                <a:endParaRPr lang="en-US" i="1" dirty="0">
+                <a:endParaRPr lang="en-US" sz="3200" i="1" dirty="0">
                   <a:latin typeface="Cambria Math" panose="02040503050406030204" pitchFamily="18" charset="0"/>
                   <a:ea typeface="Cambria Math" panose="02040503050406030204" pitchFamily="18" charset="0"/>
                 </a:endParaRPr>
@@ -23153,150 +23199,211 @@
                   <a:buNone/>
                 </a:pPr>
                 <a14:m>
-                  <m:oMathPara xmlns:m="http://schemas.openxmlformats.org/officeDocument/2006/math">
-                    <m:oMathParaPr>
-                      <m:jc m:val="left"/>
-                    </m:oMathParaPr>
-                    <m:oMath xmlns:m="http://schemas.openxmlformats.org/officeDocument/2006/math">
-                      <m:r>
-                        <a:rPr lang="en-US" b="0" i="1" smtClean="0">
-                          <a:latin typeface="Cambria Math" panose="02040503050406030204" pitchFamily="18" charset="0"/>
-                          <a:ea typeface="Cambria Math" panose="02040503050406030204" pitchFamily="18" charset="0"/>
-                        </a:rPr>
-                        <m:t>𝑎𝑛𝑑</m:t>
-                      </m:r>
-                      <m:r>
-                        <a:rPr lang="en-US" b="0" i="1" smtClean="0">
-                          <a:latin typeface="Cambria Math" panose="02040503050406030204" pitchFamily="18" charset="0"/>
-                          <a:ea typeface="Cambria Math" panose="02040503050406030204" pitchFamily="18" charset="0"/>
-                        </a:rPr>
-                        <m:t> </m:t>
-                      </m:r>
-                      <m:r>
-                        <a:rPr lang="en-US" b="0" i="1" smtClean="0">
-                          <a:latin typeface="Cambria Math" panose="02040503050406030204" pitchFamily="18" charset="0"/>
-                          <a:ea typeface="Cambria Math" panose="02040503050406030204" pitchFamily="18" charset="0"/>
-                        </a:rPr>
-                        <m:t>𝑖𝑓</m:t>
-                      </m:r>
-                      <m:r>
-                        <a:rPr lang="en-US" b="0" i="1" smtClean="0">
-                          <a:latin typeface="Cambria Math" panose="02040503050406030204" pitchFamily="18" charset="0"/>
-                          <a:ea typeface="Cambria Math" panose="02040503050406030204" pitchFamily="18" charset="0"/>
-                        </a:rPr>
-                        <m:t> ∃</m:t>
-                      </m:r>
-                      <m:r>
-                        <a:rPr lang="en-US" b="0" i="1" smtClean="0">
-                          <a:latin typeface="Cambria Math" panose="02040503050406030204" pitchFamily="18" charset="0"/>
-                        </a:rPr>
-                        <m:t>𝑐</m:t>
-                      </m:r>
-                      <m:r>
-                        <a:rPr lang="en-US" b="0" i="1" smtClean="0">
-                          <a:latin typeface="Cambria Math" panose="02040503050406030204" pitchFamily="18" charset="0"/>
-                        </a:rPr>
-                        <m:t>&lt;1, </m:t>
-                      </m:r>
-                      <m:r>
-                        <a:rPr lang="en-US" b="0" i="1" smtClean="0">
-                          <a:latin typeface="Cambria Math" panose="02040503050406030204" pitchFamily="18" charset="0"/>
-                        </a:rPr>
-                        <m:t>𝑠𝑢𝑐h</m:t>
-                      </m:r>
-                      <m:r>
-                        <a:rPr lang="en-US" b="0" i="1" smtClean="0">
-                          <a:latin typeface="Cambria Math" panose="02040503050406030204" pitchFamily="18" charset="0"/>
-                        </a:rPr>
-                        <m:t> </m:t>
-                      </m:r>
-                      <m:r>
-                        <a:rPr lang="en-US" b="0" i="1" smtClean="0">
-                          <a:latin typeface="Cambria Math" panose="02040503050406030204" pitchFamily="18" charset="0"/>
-                        </a:rPr>
-                        <m:t>𝑡h𝑎𝑡</m:t>
-                      </m:r>
-                      <m:r>
-                        <a:rPr lang="en-US" b="0" i="1" smtClean="0">
-                          <a:latin typeface="Cambria Math" panose="02040503050406030204" pitchFamily="18" charset="0"/>
-                        </a:rPr>
-                        <m:t> </m:t>
-                      </m:r>
-                      <m:r>
-                        <a:rPr lang="en-US" b="0" i="1" smtClean="0">
-                          <a:latin typeface="Cambria Math" panose="02040503050406030204" pitchFamily="18" charset="0"/>
-                        </a:rPr>
-                        <m:t>𝑎𝑓</m:t>
-                      </m:r>
-                      <m:d>
-                        <m:dPr>
-                          <m:ctrlPr>
-                            <a:rPr lang="en-US" b="0" i="1" smtClean="0">
-                              <a:latin typeface="Cambria Math" panose="02040503050406030204" pitchFamily="18" charset="0"/>
-                            </a:rPr>
-                          </m:ctrlPr>
-                        </m:dPr>
-                        <m:e>
-                          <m:f>
-                            <m:fPr>
-                              <m:ctrlPr>
-                                <a:rPr lang="en-US" b="0" i="1" smtClean="0">
-                                  <a:latin typeface="Cambria Math" panose="02040503050406030204" pitchFamily="18" charset="0"/>
-                                </a:rPr>
-                              </m:ctrlPr>
-                            </m:fPr>
-                            <m:num>
-                              <m:r>
-                                <a:rPr lang="en-US" b="0" i="1" smtClean="0">
-                                  <a:latin typeface="Cambria Math" panose="02040503050406030204" pitchFamily="18" charset="0"/>
-                                </a:rPr>
-                                <m:t>𝑛</m:t>
-                              </m:r>
-                            </m:num>
-                            <m:den>
-                              <m:r>
-                                <a:rPr lang="en-US" b="0" i="1" smtClean="0">
-                                  <a:latin typeface="Cambria Math" panose="02040503050406030204" pitchFamily="18" charset="0"/>
-                                </a:rPr>
-                                <m:t>𝑏</m:t>
-                              </m:r>
-                            </m:den>
-                          </m:f>
-                        </m:e>
-                      </m:d>
-                      <m:r>
-                        <a:rPr lang="en-US" b="0" i="1" smtClean="0">
-                          <a:latin typeface="Cambria Math" panose="02040503050406030204" pitchFamily="18" charset="0"/>
-                        </a:rPr>
-                        <m:t>≤</m:t>
-                      </m:r>
-                      <m:r>
-                        <a:rPr lang="en-US" b="0" i="1" smtClean="0">
-                          <a:latin typeface="Cambria Math" panose="02040503050406030204" pitchFamily="18" charset="0"/>
-                        </a:rPr>
-                        <m:t>𝑐𝑓</m:t>
-                      </m:r>
-                      <m:d>
-                        <m:dPr>
-                          <m:ctrlPr>
-                            <a:rPr lang="en-US" b="0" i="1" smtClean="0">
-                              <a:latin typeface="Cambria Math" panose="02040503050406030204" pitchFamily="18" charset="0"/>
-                            </a:rPr>
-                          </m:ctrlPr>
-                        </m:dPr>
-                        <m:e>
-                          <m:r>
-                            <a:rPr lang="en-US" b="0" i="1" smtClean="0">
-                              <a:latin typeface="Cambria Math" panose="02040503050406030204" pitchFamily="18" charset="0"/>
-                            </a:rPr>
-                            <m:t>𝑛</m:t>
-                          </m:r>
-                        </m:e>
-                      </m:d>
-                    </m:oMath>
-                  </m:oMathPara>
+                  <m:oMath xmlns:m="http://schemas.openxmlformats.org/officeDocument/2006/math">
+                    <m:r>
+                      <a:rPr lang="en-US" sz="3200" b="0" i="1" smtClean="0">
+                        <a:latin typeface="Cambria Math" panose="02040503050406030204" pitchFamily="18" charset="0"/>
+                        <a:ea typeface="Cambria Math" panose="02040503050406030204" pitchFamily="18" charset="0"/>
+                      </a:rPr>
+                      <m:t>𝑎𝑛𝑑</m:t>
+                    </m:r>
+                    <m:r>
+                      <a:rPr lang="en-US" sz="3200" b="0" i="1" smtClean="0">
+                        <a:latin typeface="Cambria Math" panose="02040503050406030204" pitchFamily="18" charset="0"/>
+                        <a:ea typeface="Cambria Math" panose="02040503050406030204" pitchFamily="18" charset="0"/>
+                      </a:rPr>
+                      <m:t> </m:t>
+                    </m:r>
+                    <m:r>
+                      <a:rPr lang="en-US" sz="3200" b="0" i="1" smtClean="0">
+                        <a:latin typeface="Cambria Math" panose="02040503050406030204" pitchFamily="18" charset="0"/>
+                        <a:ea typeface="Cambria Math" panose="02040503050406030204" pitchFamily="18" charset="0"/>
+                      </a:rPr>
+                      <m:t>𝑖𝑓</m:t>
+                    </m:r>
+                    <m:r>
+                      <a:rPr lang="en-US" sz="3200" b="0" i="1" smtClean="0">
+                        <a:latin typeface="Cambria Math" panose="02040503050406030204" pitchFamily="18" charset="0"/>
+                        <a:ea typeface="Cambria Math" panose="02040503050406030204" pitchFamily="18" charset="0"/>
+                      </a:rPr>
+                      <m:t> ∃</m:t>
+                    </m:r>
+                    <m:r>
+                      <a:rPr lang="en-US" sz="3200" b="0" i="1" smtClean="0">
+                        <a:latin typeface="Cambria Math" panose="02040503050406030204" pitchFamily="18" charset="0"/>
+                      </a:rPr>
+                      <m:t>𝑐</m:t>
+                    </m:r>
+                    <m:r>
+                      <a:rPr lang="en-US" sz="3200" b="0" i="1" smtClean="0">
+                        <a:latin typeface="Cambria Math" panose="02040503050406030204" pitchFamily="18" charset="0"/>
+                      </a:rPr>
+                      <m:t>&lt;1, </m:t>
+                    </m:r>
+                    <m:r>
+                      <a:rPr lang="en-US" sz="3200" b="0" i="1" smtClean="0">
+                        <a:latin typeface="Cambria Math" panose="02040503050406030204" pitchFamily="18" charset="0"/>
+                      </a:rPr>
+                      <m:t>𝑠𝑢𝑐h</m:t>
+                    </m:r>
+                    <m:r>
+                      <a:rPr lang="en-US" sz="3200" b="0" i="1" smtClean="0">
+                        <a:latin typeface="Cambria Math" panose="02040503050406030204" pitchFamily="18" charset="0"/>
+                      </a:rPr>
+                      <m:t> </m:t>
+                    </m:r>
+                    <m:r>
+                      <a:rPr lang="en-US" sz="3200" b="0" i="1" smtClean="0">
+                        <a:latin typeface="Cambria Math" panose="02040503050406030204" pitchFamily="18" charset="0"/>
+                      </a:rPr>
+                      <m:t>𝑡h𝑎𝑡</m:t>
+                    </m:r>
+                    <m:r>
+                      <a:rPr lang="en-US" sz="3200" b="0" i="1" smtClean="0">
+                        <a:latin typeface="Cambria Math" panose="02040503050406030204" pitchFamily="18" charset="0"/>
+                      </a:rPr>
+                      <m:t> </m:t>
+                    </m:r>
+                    <m:r>
+                      <a:rPr lang="en-US" sz="3200" b="0" i="1" smtClean="0">
+                        <a:latin typeface="Cambria Math" panose="02040503050406030204" pitchFamily="18" charset="0"/>
+                      </a:rPr>
+                      <m:t>𝑎𝑓</m:t>
+                    </m:r>
+                    <m:d>
+                      <m:dPr>
+                        <m:ctrlPr>
+                          <a:rPr lang="en-US" sz="3200" b="0" i="1" smtClean="0">
+                            <a:latin typeface="Cambria Math" panose="02040503050406030204" pitchFamily="18" charset="0"/>
+                          </a:rPr>
+                        </m:ctrlPr>
+                      </m:dPr>
+                      <m:e>
+                        <m:f>
+                          <m:fPr>
+                            <m:ctrlPr>
+                              <a:rPr lang="en-US" sz="3200" b="0" i="1" smtClean="0">
+                                <a:latin typeface="Cambria Math" panose="02040503050406030204" pitchFamily="18" charset="0"/>
+                              </a:rPr>
+                            </m:ctrlPr>
+                          </m:fPr>
+                          <m:num>
+                            <m:r>
+                              <a:rPr lang="en-US" sz="3200" b="0" i="1" smtClean="0">
+                                <a:latin typeface="Cambria Math" panose="02040503050406030204" pitchFamily="18" charset="0"/>
+                              </a:rPr>
+                              <m:t>𝑛</m:t>
+                            </m:r>
+                          </m:num>
+                          <m:den>
+                            <m:r>
+                              <a:rPr lang="en-US" sz="3200" b="0" i="1" smtClean="0">
+                                <a:latin typeface="Cambria Math" panose="02040503050406030204" pitchFamily="18" charset="0"/>
+                              </a:rPr>
+                              <m:t>𝑏</m:t>
+                            </m:r>
+                          </m:den>
+                        </m:f>
+                      </m:e>
+                    </m:d>
+                    <m:r>
+                      <a:rPr lang="en-US" sz="3200" b="0" i="1" smtClean="0">
+                        <a:latin typeface="Cambria Math" panose="02040503050406030204" pitchFamily="18" charset="0"/>
+                      </a:rPr>
+                      <m:t>≤</m:t>
+                    </m:r>
+                    <m:r>
+                      <a:rPr lang="en-US" sz="3200" b="0" i="1" smtClean="0">
+                        <a:latin typeface="Cambria Math" panose="02040503050406030204" pitchFamily="18" charset="0"/>
+                      </a:rPr>
+                      <m:t>𝑐𝑓</m:t>
+                    </m:r>
+                    <m:d>
+                      <m:dPr>
+                        <m:ctrlPr>
+                          <a:rPr lang="en-US" sz="3200" b="0" i="1" smtClean="0">
+                            <a:latin typeface="Cambria Math" panose="02040503050406030204" pitchFamily="18" charset="0"/>
+                          </a:rPr>
+                        </m:ctrlPr>
+                      </m:dPr>
+                      <m:e>
+                        <m:r>
+                          <a:rPr lang="en-US" sz="3200" b="0" i="1" smtClean="0">
+                            <a:latin typeface="Cambria Math" panose="02040503050406030204" pitchFamily="18" charset="0"/>
+                          </a:rPr>
+                          <m:t>𝑛</m:t>
+                        </m:r>
+                      </m:e>
+                    </m:d>
+                    <m:r>
+                      <a:rPr lang="en-US" sz="3200" b="0" i="1" smtClean="0">
+                        <a:latin typeface="Cambria Math" panose="02040503050406030204" pitchFamily="18" charset="0"/>
+                      </a:rPr>
+                      <m:t>, </m:t>
+                    </m:r>
+                    <m:r>
+                      <a:rPr lang="en-US" sz="3200" b="0" i="1" smtClean="0">
+                        <a:latin typeface="Cambria Math" panose="02040503050406030204" pitchFamily="18" charset="0"/>
+                        <a:ea typeface="Cambria Math" panose="02040503050406030204" pitchFamily="18" charset="0"/>
+                      </a:rPr>
+                      <m:t>∀</m:t>
+                    </m:r>
+                    <m:r>
+                      <a:rPr lang="en-US" sz="3200" b="0" i="1" smtClean="0">
+                        <a:latin typeface="Cambria Math" panose="02040503050406030204" pitchFamily="18" charset="0"/>
+                        <a:ea typeface="Cambria Math" panose="02040503050406030204" pitchFamily="18" charset="0"/>
+                      </a:rPr>
+                      <m:t>𝑛</m:t>
+                    </m:r>
+                    <m:r>
+                      <a:rPr lang="en-US" sz="3200" b="0" i="1" smtClean="0">
+                        <a:latin typeface="Cambria Math" panose="02040503050406030204" pitchFamily="18" charset="0"/>
+                        <a:ea typeface="Cambria Math" panose="02040503050406030204" pitchFamily="18" charset="0"/>
+                      </a:rPr>
+                      <m:t>&gt; </m:t>
+                    </m:r>
+                    <m:sSub>
+                      <m:sSubPr>
+                        <m:ctrlPr>
+                          <a:rPr lang="en-US" sz="3200" b="0" i="1" smtClean="0">
+                            <a:latin typeface="Cambria Math" panose="02040503050406030204" pitchFamily="18" charset="0"/>
+                            <a:ea typeface="Cambria Math" panose="02040503050406030204" pitchFamily="18" charset="0"/>
+                          </a:rPr>
+                        </m:ctrlPr>
+                      </m:sSubPr>
+                      <m:e>
+                        <m:r>
+                          <a:rPr lang="en-US" sz="3200" b="0" i="1" smtClean="0">
+                            <a:latin typeface="Cambria Math" panose="02040503050406030204" pitchFamily="18" charset="0"/>
+                            <a:ea typeface="Cambria Math" panose="02040503050406030204" pitchFamily="18" charset="0"/>
+                          </a:rPr>
+                          <m:t>𝑛</m:t>
+                        </m:r>
+                      </m:e>
+                      <m:sub>
+                        <m:r>
+                          <a:rPr lang="en-US" sz="3200" b="0" i="1" smtClean="0">
+                            <a:latin typeface="Cambria Math" panose="02040503050406030204" pitchFamily="18" charset="0"/>
+                            <a:ea typeface="Cambria Math" panose="02040503050406030204" pitchFamily="18" charset="0"/>
+                          </a:rPr>
+                          <m:t>0</m:t>
+                        </m:r>
+                      </m:sub>
+                    </m:sSub>
+                  </m:oMath>
                 </a14:m>
-                <a:endParaRPr lang="en-US" dirty="0">
+                <a:r>
+                  <a:rPr lang="en-US" sz="3200" dirty="0">
+                    <a:ea typeface="Cambria Math" panose="02040503050406030204" pitchFamily="18" charset="0"/>
+                  </a:rPr>
+                  <a:t> </a:t>
+                </a:r>
+              </a:p>
+              <a:p>
+                <a:pPr marL="0" indent="0">
+                  <a:buNone/>
+                </a:pPr>
+                <a:endParaRPr lang="en-US" sz="3200" dirty="0">
                   <a:ea typeface="Cambria Math" panose="02040503050406030204" pitchFamily="18" charset="0"/>
                 </a:endParaRPr>
               </a:p>
@@ -23315,7 +23422,7 @@
             </p:txBody>
           </p:sp>
         </mc:Choice>
-        <mc:Fallback>
+        <mc:Fallback xmlns="">
           <p:sp>
             <p:nvSpPr>
               <p:cNvPr id="3" name="Content Placeholder 2">
@@ -23460,8 +23567,8 @@
           <a:chExt cx="0" cy="0"/>
         </a:xfrm>
       </p:grpSpPr>
-      <mc:AlternateContent xmlns:mc="http://schemas.openxmlformats.org/markup-compatibility/2006">
-        <mc:Choice xmlns:a14="http://schemas.microsoft.com/office/drawing/2010/main" Requires="a14">
+      <mc:AlternateContent xmlns:mc="http://schemas.openxmlformats.org/markup-compatibility/2006" xmlns:a14="http://schemas.microsoft.com/office/drawing/2010/main">
+        <mc:Choice Requires="a14">
           <p:sp>
             <p:nvSpPr>
               <p:cNvPr id="3" name="Content Placeholder 2">
@@ -23500,61 +23607,61 @@
                     </m:oMathParaPr>
                     <m:oMath xmlns:m="http://schemas.openxmlformats.org/officeDocument/2006/math">
                       <m:r>
-                        <a:rPr lang="en-US" b="0" i="1" smtClean="0">
+                        <a:rPr lang="en-US" sz="3200" b="0" i="1" smtClean="0">
                           <a:latin typeface="Cambria Math" panose="02040503050406030204" pitchFamily="18" charset="0"/>
                         </a:rPr>
                         <m:t>𝑖𝑓</m:t>
                       </m:r>
                       <m:r>
-                        <a:rPr lang="en-US" b="0" i="1" smtClean="0">
+                        <a:rPr lang="en-US" sz="3200" b="0" i="1" smtClean="0">
                           <a:latin typeface="Cambria Math" panose="02040503050406030204" pitchFamily="18" charset="0"/>
                         </a:rPr>
                         <m:t> ∃</m:t>
                       </m:r>
                       <m:r>
-                        <a:rPr lang="en-US" b="0" i="1" smtClean="0">
+                        <a:rPr lang="en-US" sz="3200" b="0" i="1" smtClean="0">
                           <a:latin typeface="Cambria Math" panose="02040503050406030204" pitchFamily="18" charset="0"/>
                           <a:ea typeface="Cambria Math" panose="02040503050406030204" pitchFamily="18" charset="0"/>
                         </a:rPr>
                         <m:t>𝜖</m:t>
                       </m:r>
                       <m:r>
-                        <a:rPr lang="en-US" b="0" i="1" smtClean="0">
+                        <a:rPr lang="en-US" sz="3200" b="0" i="1" smtClean="0">
                           <a:latin typeface="Cambria Math" panose="02040503050406030204" pitchFamily="18" charset="0"/>
                           <a:ea typeface="Cambria Math" panose="02040503050406030204" pitchFamily="18" charset="0"/>
                         </a:rPr>
                         <m:t>&gt;0, </m:t>
                       </m:r>
                       <m:r>
-                        <a:rPr lang="en-US" b="0" i="1" smtClean="0">
+                        <a:rPr lang="en-US" sz="3200" b="0" i="1" smtClean="0">
                           <a:latin typeface="Cambria Math" panose="02040503050406030204" pitchFamily="18" charset="0"/>
                           <a:ea typeface="Cambria Math" panose="02040503050406030204" pitchFamily="18" charset="0"/>
                         </a:rPr>
                         <m:t>𝑠𝑢𝑐h</m:t>
                       </m:r>
                       <m:r>
-                        <a:rPr lang="en-US" b="0" i="1" smtClean="0">
+                        <a:rPr lang="en-US" sz="3200" b="0" i="1" smtClean="0">
                           <a:latin typeface="Cambria Math" panose="02040503050406030204" pitchFamily="18" charset="0"/>
                           <a:ea typeface="Cambria Math" panose="02040503050406030204" pitchFamily="18" charset="0"/>
                         </a:rPr>
                         <m:t> </m:t>
                       </m:r>
                       <m:r>
-                        <a:rPr lang="en-US" b="0" i="1" smtClean="0">
+                        <a:rPr lang="en-US" sz="3200" b="0" i="1" smtClean="0">
                           <a:latin typeface="Cambria Math" panose="02040503050406030204" pitchFamily="18" charset="0"/>
                           <a:ea typeface="Cambria Math" panose="02040503050406030204" pitchFamily="18" charset="0"/>
                         </a:rPr>
                         <m:t>𝑡h𝑎𝑡</m:t>
                       </m:r>
                       <m:r>
-                        <a:rPr lang="en-US" b="0" i="1" smtClean="0">
+                        <a:rPr lang="en-US" sz="3200" b="0" i="1" smtClean="0">
                           <a:latin typeface="Cambria Math" panose="02040503050406030204" pitchFamily="18" charset="0"/>
                           <a:ea typeface="Cambria Math" panose="02040503050406030204" pitchFamily="18" charset="0"/>
                         </a:rPr>
                         <m:t> </m:t>
                       </m:r>
                       <m:r>
-                        <a:rPr lang="en-US" b="0" i="1" smtClean="0">
+                        <a:rPr lang="en-US" sz="3200" b="0" i="1" smtClean="0">
                           <a:latin typeface="Cambria Math" panose="02040503050406030204" pitchFamily="18" charset="0"/>
                           <a:ea typeface="Cambria Math" panose="02040503050406030204" pitchFamily="18" charset="0"/>
                         </a:rPr>
@@ -23563,7 +23670,7 @@
                       <m:d>
                         <m:dPr>
                           <m:ctrlPr>
-                            <a:rPr lang="en-US" b="0" i="1" smtClean="0">
+                            <a:rPr lang="en-US" sz="3200" b="0" i="1" smtClean="0">
                               <a:latin typeface="Cambria Math" panose="02040503050406030204" pitchFamily="18" charset="0"/>
                               <a:ea typeface="Cambria Math" panose="02040503050406030204" pitchFamily="18" charset="0"/>
                             </a:rPr>
@@ -23571,7 +23678,7 @@
                         </m:dPr>
                         <m:e>
                           <m:r>
-                            <a:rPr lang="en-US" b="0" i="1" smtClean="0">
+                            <a:rPr lang="en-US" sz="3200" b="0" i="1" smtClean="0">
                               <a:latin typeface="Cambria Math" panose="02040503050406030204" pitchFamily="18" charset="0"/>
                               <a:ea typeface="Cambria Math" panose="02040503050406030204" pitchFamily="18" charset="0"/>
                             </a:rPr>
@@ -23580,7 +23687,7 @@
                         </m:e>
                       </m:d>
                       <m:r>
-                        <a:rPr lang="en-US" b="0" i="1" smtClean="0">
+                        <a:rPr lang="en-US" sz="3200" b="0" i="1" smtClean="0">
                           <a:latin typeface="Cambria Math" panose="02040503050406030204" pitchFamily="18" charset="0"/>
                           <a:ea typeface="Cambria Math" panose="02040503050406030204" pitchFamily="18" charset="0"/>
                         </a:rPr>
@@ -23590,7 +23697,7 @@
                         <m:rPr>
                           <m:sty m:val="p"/>
                         </m:rPr>
-                        <a:rPr lang="el-GR" b="0" i="1" smtClean="0">
+                        <a:rPr lang="el-GR" sz="3200" b="0" i="1" smtClean="0">
                           <a:latin typeface="Cambria Math" panose="02040503050406030204" pitchFamily="18" charset="0"/>
                           <a:ea typeface="Cambria Math" panose="02040503050406030204" pitchFamily="18" charset="0"/>
                         </a:rPr>
@@ -23599,7 +23706,7 @@
                       <m:d>
                         <m:dPr>
                           <m:ctrlPr>
-                            <a:rPr lang="en-US" b="0" i="1" smtClean="0">
+                            <a:rPr lang="en-US" sz="3200" b="0" i="1" smtClean="0">
                               <a:latin typeface="Cambria Math" panose="02040503050406030204" pitchFamily="18" charset="0"/>
                               <a:ea typeface="Cambria Math" panose="02040503050406030204" pitchFamily="18" charset="0"/>
                             </a:rPr>
@@ -23609,7 +23716,7 @@
                           <m:sSup>
                             <m:sSupPr>
                               <m:ctrlPr>
-                                <a:rPr lang="en-US" b="0" i="1" smtClean="0">
+                                <a:rPr lang="en-US" sz="3200" b="0" i="1" smtClean="0">
                                   <a:latin typeface="Cambria Math" panose="02040503050406030204" pitchFamily="18" charset="0"/>
                                   <a:ea typeface="Cambria Math" panose="02040503050406030204" pitchFamily="18" charset="0"/>
                                 </a:rPr>
@@ -23617,7 +23724,7 @@
                             </m:sSupPr>
                             <m:e>
                               <m:r>
-                                <a:rPr lang="en-US" b="0" i="1" smtClean="0">
+                                <a:rPr lang="en-US" sz="3200" b="0" i="1" smtClean="0">
                                   <a:latin typeface="Cambria Math" panose="02040503050406030204" pitchFamily="18" charset="0"/>
                                   <a:ea typeface="Cambria Math" panose="02040503050406030204" pitchFamily="18" charset="0"/>
                                 </a:rPr>
@@ -23628,7 +23735,7 @@
                               <m:sSub>
                                 <m:sSubPr>
                                   <m:ctrlPr>
-                                    <a:rPr lang="en-US" b="0" i="1" smtClean="0">
+                                    <a:rPr lang="en-US" sz="3200" b="0" i="1" smtClean="0">
                                       <a:latin typeface="Cambria Math" panose="02040503050406030204" pitchFamily="18" charset="0"/>
                                       <a:ea typeface="Cambria Math" panose="02040503050406030204" pitchFamily="18" charset="0"/>
                                     </a:rPr>
@@ -23636,7 +23743,7 @@
                                 </m:sSubPr>
                                 <m:e>
                                   <m:r>
-                                    <a:rPr lang="en-US" b="0" i="1" smtClean="0">
+                                    <a:rPr lang="en-US" sz="3200" b="0" i="1" smtClean="0">
                                       <a:latin typeface="Cambria Math" panose="02040503050406030204" pitchFamily="18" charset="0"/>
                                       <a:ea typeface="Cambria Math" panose="02040503050406030204" pitchFamily="18" charset="0"/>
                                     </a:rPr>
@@ -23645,7 +23752,7 @@
                                 </m:e>
                                 <m:sub>
                                   <m:r>
-                                    <a:rPr lang="en-US" b="0" i="1" smtClean="0">
+                                    <a:rPr lang="en-US" sz="3200" b="0" i="1" smtClean="0">
                                       <a:latin typeface="Cambria Math" panose="02040503050406030204" pitchFamily="18" charset="0"/>
                                       <a:ea typeface="Cambria Math" panose="02040503050406030204" pitchFamily="18" charset="0"/>
                                     </a:rPr>
@@ -23656,7 +23763,7 @@
                               <m:d>
                                 <m:dPr>
                                   <m:ctrlPr>
-                                    <a:rPr lang="en-US" b="0" i="1" smtClean="0">
+                                    <a:rPr lang="en-US" sz="3200" b="0" i="1" smtClean="0">
                                       <a:latin typeface="Cambria Math" panose="02040503050406030204" pitchFamily="18" charset="0"/>
                                       <a:ea typeface="Cambria Math" panose="02040503050406030204" pitchFamily="18" charset="0"/>
                                     </a:rPr>
@@ -23664,7 +23771,7 @@
                                 </m:dPr>
                                 <m:e>
                                   <m:r>
-                                    <a:rPr lang="en-US" b="0" i="1" smtClean="0">
+                                    <a:rPr lang="en-US" sz="3200" b="0" i="1" smtClean="0">
                                       <a:latin typeface="Cambria Math" panose="02040503050406030204" pitchFamily="18" charset="0"/>
                                       <a:ea typeface="Cambria Math" panose="02040503050406030204" pitchFamily="18" charset="0"/>
                                     </a:rPr>
@@ -23673,14 +23780,14 @@
                                 </m:e>
                               </m:d>
                               <m:r>
-                                <a:rPr lang="en-US" b="0" i="1" smtClean="0">
+                                <a:rPr lang="en-US" sz="3200" b="0" i="1" smtClean="0">
                                   <a:latin typeface="Cambria Math" panose="02040503050406030204" pitchFamily="18" charset="0"/>
                                   <a:ea typeface="Cambria Math" panose="02040503050406030204" pitchFamily="18" charset="0"/>
                                 </a:rPr>
                                 <m:t>+</m:t>
                               </m:r>
                               <m:r>
-                                <a:rPr lang="en-US" i="1">
+                                <a:rPr lang="en-US" sz="3200" i="1">
                                   <a:latin typeface="Cambria Math" panose="02040503050406030204" pitchFamily="18" charset="0"/>
                                   <a:ea typeface="Cambria Math" panose="02040503050406030204" pitchFamily="18" charset="0"/>
                                 </a:rPr>
@@ -23693,13 +23800,16 @@
                     </m:oMath>
                   </m:oMathPara>
                 </a14:m>
-                <a:endParaRPr lang="en-US" i="1" dirty="0">
+                <a:endParaRPr lang="en-US" sz="3200" i="1" dirty="0">
                   <a:latin typeface="Cambria Math" panose="02040503050406030204" pitchFamily="18" charset="0"/>
                   <a:ea typeface="Cambria Math" panose="02040503050406030204" pitchFamily="18" charset="0"/>
                 </a:endParaRPr>
               </a:p>
               <a:p>
                 <a:pPr marL="0" indent="0">
+                  <a:lnSpc>
+                    <a:spcPct val="100000"/>
+                  </a:lnSpc>
                   <a:buNone/>
                 </a:pPr>
                 <a14:m>
@@ -23709,71 +23819,71 @@
                     </m:oMathParaPr>
                     <m:oMath xmlns:m="http://schemas.openxmlformats.org/officeDocument/2006/math">
                       <m:r>
-                        <a:rPr lang="en-US" b="0" i="1" smtClean="0">
+                        <a:rPr lang="en-US" sz="3200" b="0" i="1" smtClean="0">
                           <a:latin typeface="Cambria Math" panose="02040503050406030204" pitchFamily="18" charset="0"/>
                           <a:ea typeface="Cambria Math" panose="02040503050406030204" pitchFamily="18" charset="0"/>
                         </a:rPr>
                         <m:t>𝑎𝑛𝑑</m:t>
                       </m:r>
                       <m:r>
-                        <a:rPr lang="en-US" b="0" i="1" smtClean="0">
+                        <a:rPr lang="en-US" sz="3200" b="0" i="1" smtClean="0">
                           <a:latin typeface="Cambria Math" panose="02040503050406030204" pitchFamily="18" charset="0"/>
                           <a:ea typeface="Cambria Math" panose="02040503050406030204" pitchFamily="18" charset="0"/>
                         </a:rPr>
                         <m:t> </m:t>
                       </m:r>
                       <m:r>
-                        <a:rPr lang="en-US" b="0" i="1" smtClean="0">
+                        <a:rPr lang="en-US" sz="3200" b="0" i="1" smtClean="0">
                           <a:latin typeface="Cambria Math" panose="02040503050406030204" pitchFamily="18" charset="0"/>
                           <a:ea typeface="Cambria Math" panose="02040503050406030204" pitchFamily="18" charset="0"/>
                         </a:rPr>
                         <m:t>𝑖𝑓</m:t>
                       </m:r>
                       <m:r>
-                        <a:rPr lang="en-US" b="0" i="1" smtClean="0">
+                        <a:rPr lang="en-US" sz="3200" b="0" i="1" smtClean="0">
                           <a:latin typeface="Cambria Math" panose="02040503050406030204" pitchFamily="18" charset="0"/>
                           <a:ea typeface="Cambria Math" panose="02040503050406030204" pitchFamily="18" charset="0"/>
                         </a:rPr>
                         <m:t> ∃</m:t>
                       </m:r>
                       <m:r>
-                        <a:rPr lang="en-US" b="0" i="1" smtClean="0">
+                        <a:rPr lang="en-US" sz="3200" b="0" i="1" smtClean="0">
                           <a:latin typeface="Cambria Math" panose="02040503050406030204" pitchFamily="18" charset="0"/>
                         </a:rPr>
                         <m:t>𝑐</m:t>
                       </m:r>
                       <m:r>
-                        <a:rPr lang="en-US" b="0" i="1" smtClean="0">
+                        <a:rPr lang="en-US" sz="3200" b="0" i="1" smtClean="0">
                           <a:latin typeface="Cambria Math" panose="02040503050406030204" pitchFamily="18" charset="0"/>
                         </a:rPr>
                         <m:t>&lt;1, </m:t>
                       </m:r>
                       <m:r>
-                        <a:rPr lang="en-US" b="0" i="1" smtClean="0">
+                        <a:rPr lang="en-US" sz="3200" b="0" i="1" smtClean="0">
                           <a:latin typeface="Cambria Math" panose="02040503050406030204" pitchFamily="18" charset="0"/>
                         </a:rPr>
                         <m:t>𝑠𝑢𝑐h</m:t>
                       </m:r>
                       <m:r>
-                        <a:rPr lang="en-US" b="0" i="1" smtClean="0">
+                        <a:rPr lang="en-US" sz="3200" b="0" i="1" smtClean="0">
                           <a:latin typeface="Cambria Math" panose="02040503050406030204" pitchFamily="18" charset="0"/>
                         </a:rPr>
                         <m:t> </m:t>
                       </m:r>
                       <m:r>
-                        <a:rPr lang="en-US" b="0" i="1" smtClean="0">
+                        <a:rPr lang="en-US" sz="3200" b="0" i="1" smtClean="0">
                           <a:latin typeface="Cambria Math" panose="02040503050406030204" pitchFamily="18" charset="0"/>
                         </a:rPr>
                         <m:t>𝑡h𝑎𝑡</m:t>
                       </m:r>
                       <m:r>
-                        <a:rPr lang="en-US" b="0" i="1" smtClean="0">
+                        <a:rPr lang="en-US" sz="3200" b="0" i="1" smtClean="0">
                           <a:latin typeface="Cambria Math" panose="02040503050406030204" pitchFamily="18" charset="0"/>
                         </a:rPr>
                         <m:t> </m:t>
                       </m:r>
                       <m:r>
-                        <a:rPr lang="en-US" b="0" i="1" smtClean="0">
+                        <a:rPr lang="en-US" sz="3200" b="0" i="1" smtClean="0">
                           <a:latin typeface="Cambria Math" panose="02040503050406030204" pitchFamily="18" charset="0"/>
                         </a:rPr>
                         <m:t>𝑎𝑓</m:t>
@@ -23781,7 +23891,7 @@
                       <m:d>
                         <m:dPr>
                           <m:ctrlPr>
-                            <a:rPr lang="en-US" b="0" i="1" smtClean="0">
+                            <a:rPr lang="en-US" sz="3200" b="0" i="1" smtClean="0">
                               <a:latin typeface="Cambria Math" panose="02040503050406030204" pitchFamily="18" charset="0"/>
                             </a:rPr>
                           </m:ctrlPr>
@@ -23790,14 +23900,14 @@
                           <m:f>
                             <m:fPr>
                               <m:ctrlPr>
-                                <a:rPr lang="en-US" b="0" i="1" smtClean="0">
+                                <a:rPr lang="en-US" sz="3200" b="0" i="1" smtClean="0">
                                   <a:latin typeface="Cambria Math" panose="02040503050406030204" pitchFamily="18" charset="0"/>
                                 </a:rPr>
                               </m:ctrlPr>
                             </m:fPr>
                             <m:num>
                               <m:r>
-                                <a:rPr lang="en-US" b="0" i="1" smtClean="0">
+                                <a:rPr lang="en-US" sz="3200" b="0" i="1" smtClean="0">
                                   <a:latin typeface="Cambria Math" panose="02040503050406030204" pitchFamily="18" charset="0"/>
                                 </a:rPr>
                                 <m:t>𝑛</m:t>
@@ -23805,7 +23915,7 @@
                             </m:num>
                             <m:den>
                               <m:r>
-                                <a:rPr lang="en-US" b="0" i="1" smtClean="0">
+                                <a:rPr lang="en-US" sz="3200" b="0" i="1" smtClean="0">
                                   <a:latin typeface="Cambria Math" panose="02040503050406030204" pitchFamily="18" charset="0"/>
                                 </a:rPr>
                                 <m:t>𝑏</m:t>
@@ -23815,13 +23925,13 @@
                         </m:e>
                       </m:d>
                       <m:r>
-                        <a:rPr lang="en-US" b="0" i="1" smtClean="0">
+                        <a:rPr lang="en-US" sz="3200" b="0" i="1" smtClean="0">
                           <a:latin typeface="Cambria Math" panose="02040503050406030204" pitchFamily="18" charset="0"/>
                         </a:rPr>
                         <m:t>≤</m:t>
                       </m:r>
                       <m:r>
-                        <a:rPr lang="en-US" b="0" i="1" smtClean="0">
+                        <a:rPr lang="en-US" sz="3200" b="0" i="1" smtClean="0">
                           <a:latin typeface="Cambria Math" panose="02040503050406030204" pitchFamily="18" charset="0"/>
                         </a:rPr>
                         <m:t>𝑐𝑓</m:t>
@@ -23829,14 +23939,14 @@
                       <m:d>
                         <m:dPr>
                           <m:ctrlPr>
-                            <a:rPr lang="en-US" b="0" i="1" smtClean="0">
+                            <a:rPr lang="en-US" sz="3200" b="0" i="1" smtClean="0">
                               <a:latin typeface="Cambria Math" panose="02040503050406030204" pitchFamily="18" charset="0"/>
                             </a:rPr>
                           </m:ctrlPr>
                         </m:dPr>
                         <m:e>
                           <m:r>
-                            <a:rPr lang="en-US" b="0" i="1" smtClean="0">
+                            <a:rPr lang="en-US" sz="3200" b="0" i="1" smtClean="0">
                               <a:latin typeface="Cambria Math" panose="02040503050406030204" pitchFamily="18" charset="0"/>
                             </a:rPr>
                             <m:t>𝑛</m:t>
@@ -23844,20 +23954,79 @@
                         </m:e>
                       </m:d>
                       <m:r>
-                        <a:rPr lang="en-US" b="0" i="1" smtClean="0">
+                        <a:rPr lang="en-US" sz="3200" b="0" i="1" smtClean="0">
                           <a:latin typeface="Cambria Math" panose="02040503050406030204" pitchFamily="18" charset="0"/>
                         </a:rPr>
-                        <m:t> </m:t>
+                        <m:t>, </m:t>
                       </m:r>
+                      <m:r>
+                        <a:rPr lang="en-US" sz="3200" i="1">
+                          <a:latin typeface="Cambria Math" panose="02040503050406030204" pitchFamily="18" charset="0"/>
+                          <a:ea typeface="Cambria Math" panose="02040503050406030204" pitchFamily="18" charset="0"/>
+                        </a:rPr>
+                        <m:t>∀</m:t>
+                      </m:r>
+                      <m:r>
+                        <a:rPr lang="en-US" sz="3200" i="1">
+                          <a:latin typeface="Cambria Math" panose="02040503050406030204" pitchFamily="18" charset="0"/>
+                          <a:ea typeface="Cambria Math" panose="02040503050406030204" pitchFamily="18" charset="0"/>
+                        </a:rPr>
+                        <m:t>𝑛</m:t>
+                      </m:r>
+                      <m:r>
+                        <a:rPr lang="en-US" sz="3200" i="1">
+                          <a:latin typeface="Cambria Math" panose="02040503050406030204" pitchFamily="18" charset="0"/>
+                          <a:ea typeface="Cambria Math" panose="02040503050406030204" pitchFamily="18" charset="0"/>
+                        </a:rPr>
+                        <m:t>&gt; </m:t>
+                      </m:r>
+                      <m:sSub>
+                        <m:sSubPr>
+                          <m:ctrlPr>
+                            <a:rPr lang="en-US" sz="3200" i="1">
+                              <a:latin typeface="Cambria Math" panose="02040503050406030204" pitchFamily="18" charset="0"/>
+                              <a:ea typeface="Cambria Math" panose="02040503050406030204" pitchFamily="18" charset="0"/>
+                            </a:rPr>
+                          </m:ctrlPr>
+                        </m:sSubPr>
+                        <m:e>
+                          <m:r>
+                            <a:rPr lang="en-US" sz="3200" i="1">
+                              <a:latin typeface="Cambria Math" panose="02040503050406030204" pitchFamily="18" charset="0"/>
+                              <a:ea typeface="Cambria Math" panose="02040503050406030204" pitchFamily="18" charset="0"/>
+                            </a:rPr>
+                            <m:t>𝑛</m:t>
+                          </m:r>
+                        </m:e>
+                        <m:sub>
+                          <m:r>
+                            <a:rPr lang="en-US" sz="3200" i="1">
+                              <a:latin typeface="Cambria Math" panose="02040503050406030204" pitchFamily="18" charset="0"/>
+                              <a:ea typeface="Cambria Math" panose="02040503050406030204" pitchFamily="18" charset="0"/>
+                            </a:rPr>
+                            <m:t>0</m:t>
+                          </m:r>
+                          <m:r>
+                            <a:rPr lang="en-US" sz="3200" b="0" i="1" smtClean="0">
+                              <a:latin typeface="Cambria Math" panose="02040503050406030204" pitchFamily="18" charset="0"/>
+                              <a:ea typeface="Cambria Math" panose="02040503050406030204" pitchFamily="18" charset="0"/>
+                            </a:rPr>
+                            <m:t> </m:t>
+                          </m:r>
+                        </m:sub>
+                      </m:sSub>
                     </m:oMath>
                   </m:oMathPara>
                 </a14:m>
-                <a:endParaRPr lang="en-US" b="0" i="1" dirty="0">
+                <a:endParaRPr lang="en-US" sz="3200" b="0" i="1" dirty="0">
                   <a:latin typeface="Cambria Math" panose="02040503050406030204" pitchFamily="18" charset="0"/>
                 </a:endParaRPr>
               </a:p>
               <a:p>
                 <a:pPr marL="0" indent="0">
+                  <a:lnSpc>
+                    <a:spcPct val="100000"/>
+                  </a:lnSpc>
                   <a:buNone/>
                 </a:pPr>
                 <a14:m>
@@ -23867,19 +24036,19 @@
                     </m:oMathParaPr>
                     <m:oMath xmlns:m="http://schemas.openxmlformats.org/officeDocument/2006/math">
                       <m:r>
-                        <a:rPr lang="en-US" b="0" i="1" smtClean="0">
+                        <a:rPr lang="en-US" sz="3200" b="0" i="1" smtClean="0">
                           <a:latin typeface="Cambria Math" panose="02040503050406030204" pitchFamily="18" charset="0"/>
                         </a:rPr>
                         <m:t>𝑡h𝑒𝑛</m:t>
                       </m:r>
                       <m:r>
-                        <a:rPr lang="en-US" b="0" i="1" smtClean="0">
+                        <a:rPr lang="en-US" sz="3200" b="0" i="1" smtClean="0">
                           <a:latin typeface="Cambria Math" panose="02040503050406030204" pitchFamily="18" charset="0"/>
                         </a:rPr>
                         <m:t> </m:t>
                       </m:r>
                       <m:r>
-                        <a:rPr lang="en-US" b="0" i="1" smtClean="0">
+                        <a:rPr lang="en-US" sz="3200" b="0" i="1" smtClean="0">
                           <a:latin typeface="Cambria Math" panose="02040503050406030204" pitchFamily="18" charset="0"/>
                         </a:rPr>
                         <m:t>𝑇</m:t>
@@ -23887,14 +24056,14 @@
                       <m:d>
                         <m:dPr>
                           <m:ctrlPr>
-                            <a:rPr lang="en-US" b="0" i="1" smtClean="0">
+                            <a:rPr lang="en-US" sz="3200" b="0" i="1" smtClean="0">
                               <a:latin typeface="Cambria Math" panose="02040503050406030204" pitchFamily="18" charset="0"/>
                             </a:rPr>
                           </m:ctrlPr>
                         </m:dPr>
                         <m:e>
                           <m:r>
-                            <a:rPr lang="en-US" b="0" i="1" smtClean="0">
+                            <a:rPr lang="en-US" sz="3200" b="0" i="1" smtClean="0">
                               <a:latin typeface="Cambria Math" panose="02040503050406030204" pitchFamily="18" charset="0"/>
                             </a:rPr>
                             <m:t>𝑛</m:t>
@@ -23902,7 +24071,7 @@
                         </m:e>
                       </m:d>
                       <m:r>
-                        <a:rPr lang="en-US" b="0" i="1" smtClean="0">
+                        <a:rPr lang="en-US" sz="3200" b="0" i="1" smtClean="0">
                           <a:latin typeface="Cambria Math" panose="02040503050406030204" pitchFamily="18" charset="0"/>
                         </a:rPr>
                         <m:t>=</m:t>
@@ -23911,35 +24080,37 @@
                         <m:rPr>
                           <m:sty m:val="p"/>
                         </m:rPr>
-                        <a:rPr lang="el-GR" i="1"/>
+                        <a:rPr lang="el-GR" sz="3200" i="1">
+                          <a:latin typeface="Cambria Math" panose="02040503050406030204" pitchFamily="18" charset="0"/>
+                        </a:rPr>
                         <m:t>Θ</m:t>
                       </m:r>
                       <m:r>
-                        <a:rPr lang="en-US" b="0" i="1" smtClean="0">
+                        <a:rPr lang="en-US" sz="3200" b="0" i="1" smtClean="0">
                           <a:latin typeface="Cambria Math" panose="02040503050406030204" pitchFamily="18" charset="0"/>
                         </a:rPr>
                         <m:t>(</m:t>
                       </m:r>
                       <m:r>
-                        <a:rPr lang="en-US" b="0" i="1" smtClean="0">
+                        <a:rPr lang="en-US" sz="3200" b="0" i="1" smtClean="0">
                           <a:latin typeface="Cambria Math" panose="02040503050406030204" pitchFamily="18" charset="0"/>
                         </a:rPr>
                         <m:t>𝑓</m:t>
                       </m:r>
                       <m:r>
-                        <a:rPr lang="en-US" b="0" i="1" smtClean="0">
+                        <a:rPr lang="en-US" sz="3200" b="0" i="1" smtClean="0">
                           <a:latin typeface="Cambria Math" panose="02040503050406030204" pitchFamily="18" charset="0"/>
                         </a:rPr>
                         <m:t>(</m:t>
                       </m:r>
                       <m:r>
-                        <a:rPr lang="en-US" b="0" i="1" smtClean="0">
+                        <a:rPr lang="en-US" sz="3200" b="0" i="1" smtClean="0">
                           <a:latin typeface="Cambria Math" panose="02040503050406030204" pitchFamily="18" charset="0"/>
                         </a:rPr>
                         <m:t>𝑛</m:t>
                       </m:r>
                       <m:r>
-                        <a:rPr lang="en-US" b="0" i="1" smtClean="0">
+                        <a:rPr lang="en-US" sz="3200" b="0" i="1" smtClean="0">
                           <a:latin typeface="Cambria Math" panose="02040503050406030204" pitchFamily="18" charset="0"/>
                         </a:rPr>
                         <m:t>))</m:t>
@@ -23947,7 +24118,7 @@
                     </m:oMath>
                   </m:oMathPara>
                 </a14:m>
-                <a:endParaRPr lang="en-US" b="0" dirty="0"/>
+                <a:endParaRPr lang="en-US" sz="3200" b="0" dirty="0"/>
               </a:p>
               <a:p>
                 <a:pPr marL="0" indent="0">
@@ -23972,7 +24143,7 @@
             </p:txBody>
           </p:sp>
         </mc:Choice>
-        <mc:Fallback>
+        <mc:Fallback xmlns="">
           <p:sp>
             <p:nvSpPr>
               <p:cNvPr id="3" name="Content Placeholder 2">
@@ -23997,7 +24168,7 @@
               <a:blipFill>
                 <a:blip r:embed="rId2"/>
                 <a:stretch>
-                  <a:fillRect l="-319"/>
+                  <a:fillRect/>
                 </a:stretch>
               </a:blipFill>
             </p:spPr>
@@ -24560,8 +24731,8 @@
           <a:chExt cx="0" cy="0"/>
         </a:xfrm>
       </p:grpSpPr>
-      <mc:AlternateContent xmlns:mc="http://schemas.openxmlformats.org/markup-compatibility/2006">
-        <mc:Choice xmlns:a14="http://schemas.microsoft.com/office/drawing/2010/main" Requires="a14">
+      <mc:AlternateContent xmlns:mc="http://schemas.openxmlformats.org/markup-compatibility/2006" xmlns:a14="http://schemas.microsoft.com/office/drawing/2010/main">
+        <mc:Choice Requires="a14">
           <p:sp>
             <p:nvSpPr>
               <p:cNvPr id="2" name="Title 1">
@@ -24583,6 +24754,7 @@
               <a:bodyPr/>
               <a:lstStyle/>
               <a:p>
+                <a:pPr/>
                 <a14:m>
                   <m:oMathPara xmlns:m="http://schemas.openxmlformats.org/officeDocument/2006/math">
                     <m:oMathParaPr>
@@ -24710,7 +24882,7 @@
             </p:txBody>
           </p:sp>
         </mc:Choice>
-        <mc:Fallback>
+        <mc:Fallback xmlns="">
           <p:sp>
             <p:nvSpPr>
               <p:cNvPr id="2" name="Title 1">
@@ -24750,8 +24922,8 @@
           </p:sp>
         </mc:Fallback>
       </mc:AlternateContent>
-      <mc:AlternateContent xmlns:mc="http://schemas.openxmlformats.org/markup-compatibility/2006">
-        <mc:Choice xmlns:a14="http://schemas.microsoft.com/office/drawing/2010/main" Requires="a14">
+      <mc:AlternateContent xmlns:mc="http://schemas.openxmlformats.org/markup-compatibility/2006" xmlns:a14="http://schemas.microsoft.com/office/drawing/2010/main">
+        <mc:Choice Requires="a14">
           <p:sp>
             <p:nvSpPr>
               <p:cNvPr id="3" name="Content Placeholder 2">
@@ -24976,7 +25148,7 @@
             </p:txBody>
           </p:sp>
         </mc:Choice>
-        <mc:Fallback>
+        <mc:Fallback xmlns="">
           <p:sp>
             <p:nvSpPr>
               <p:cNvPr id="3" name="Content Placeholder 2">
@@ -25052,8 +25224,8 @@
           <a:chExt cx="0" cy="0"/>
         </a:xfrm>
       </p:grpSpPr>
-      <mc:AlternateContent xmlns:mc="http://schemas.openxmlformats.org/markup-compatibility/2006">
-        <mc:Choice xmlns:a14="http://schemas.microsoft.com/office/drawing/2010/main" Requires="a14">
+      <mc:AlternateContent xmlns:mc="http://schemas.openxmlformats.org/markup-compatibility/2006" xmlns:a14="http://schemas.microsoft.com/office/drawing/2010/main">
+        <mc:Choice Requires="a14">
           <p:sp>
             <p:nvSpPr>
               <p:cNvPr id="2" name="Title 1">
@@ -25203,7 +25375,7 @@
             </p:txBody>
           </p:sp>
         </mc:Choice>
-        <mc:Fallback>
+        <mc:Fallback xmlns="">
           <p:sp>
             <p:nvSpPr>
               <p:cNvPr id="2" name="Title 1">
@@ -25243,8 +25415,8 @@
           </p:sp>
         </mc:Fallback>
       </mc:AlternateContent>
-      <mc:AlternateContent xmlns:mc="http://schemas.openxmlformats.org/markup-compatibility/2006">
-        <mc:Choice xmlns:a14="http://schemas.microsoft.com/office/drawing/2010/main" Requires="a14">
+      <mc:AlternateContent xmlns:mc="http://schemas.openxmlformats.org/markup-compatibility/2006" xmlns:a14="http://schemas.microsoft.com/office/drawing/2010/main">
+        <mc:Choice Requires="a14">
           <p:sp>
             <p:nvSpPr>
               <p:cNvPr id="3" name="Content Placeholder 2">
@@ -25571,19 +25743,7 @@
                               <a:rPr lang="en-US" i="1">
                                 <a:latin typeface="Cambria Math" panose="02040503050406030204" pitchFamily="18" charset="0"/>
                               </a:rPr>
-                              <m:t>0</m:t>
-                            </m:r>
-                            <m:r>
-                              <a:rPr lang="en-US" i="1">
-                                <a:latin typeface="Cambria Math" panose="02040503050406030204" pitchFamily="18" charset="0"/>
-                              </a:rPr>
-                              <m:t>.</m:t>
-                            </m:r>
-                            <m:r>
-                              <a:rPr lang="en-US" i="1">
-                                <a:latin typeface="Cambria Math" panose="02040503050406030204" pitchFamily="18" charset="0"/>
-                              </a:rPr>
-                              <m:t>793</m:t>
+                              <m:t>0.793</m:t>
                             </m:r>
                             <m:r>
                               <a:rPr lang="en-US" b="0" i="1" smtClean="0">
@@ -25634,7 +25794,7 @@
             </p:txBody>
           </p:sp>
         </mc:Choice>
-        <mc:Fallback>
+        <mc:Fallback xmlns="">
           <p:sp>
             <p:nvSpPr>
               <p:cNvPr id="3" name="Content Placeholder 2">
@@ -25710,8 +25870,8 @@
           <a:chExt cx="0" cy="0"/>
         </a:xfrm>
       </p:grpSpPr>
-      <mc:AlternateContent xmlns:mc="http://schemas.openxmlformats.org/markup-compatibility/2006">
-        <mc:Choice xmlns:a14="http://schemas.microsoft.com/office/drawing/2010/main" Requires="a14">
+      <mc:AlternateContent xmlns:mc="http://schemas.openxmlformats.org/markup-compatibility/2006" xmlns:a14="http://schemas.microsoft.com/office/drawing/2010/main">
+        <mc:Choice Requires="a14">
           <p:sp>
             <p:nvSpPr>
               <p:cNvPr id="2" name="Title 1">
@@ -25861,7 +26021,7 @@
             </p:txBody>
           </p:sp>
         </mc:Choice>
-        <mc:Fallback>
+        <mc:Fallback xmlns="">
           <p:sp>
             <p:nvSpPr>
               <p:cNvPr id="2" name="Title 1">
@@ -25901,8 +26061,8 @@
           </p:sp>
         </mc:Fallback>
       </mc:AlternateContent>
-      <mc:AlternateContent xmlns:mc="http://schemas.openxmlformats.org/markup-compatibility/2006">
-        <mc:Choice xmlns:a14="http://schemas.microsoft.com/office/drawing/2010/main" Requires="a14">
+      <mc:AlternateContent xmlns:mc="http://schemas.openxmlformats.org/markup-compatibility/2006" xmlns:a14="http://schemas.microsoft.com/office/drawing/2010/main">
+        <mc:Choice Requires="a14">
           <p:sp>
             <p:nvSpPr>
               <p:cNvPr id="3" name="Content Placeholder 2">
@@ -25926,7 +26086,7 @@
               <a:p>
                 <a:pPr>
                   <a:lnSpc>
-                    <a:spcPct val="150000"/>
+                    <a:spcPct val="100000"/>
                   </a:lnSpc>
                 </a:pPr>
                 <a14:m>
@@ -26128,7 +26288,7 @@
               <a:p>
                 <a:pPr>
                   <a:lnSpc>
-                    <a:spcPct val="150000"/>
+                    <a:spcPct val="100000"/>
                   </a:lnSpc>
                 </a:pPr>
                 <a14:m>
@@ -26265,7 +26425,7 @@
               <a:p>
                 <a:pPr lvl="1">
                   <a:lnSpc>
-                    <a:spcPct val="150000"/>
+                    <a:spcPct val="100000"/>
                   </a:lnSpc>
                 </a:pPr>
                 <a14:m>
@@ -26291,7 +26451,7 @@
               <a:p>
                 <a:pPr>
                   <a:lnSpc>
-                    <a:spcPct val="150000"/>
+                    <a:spcPct val="100000"/>
                   </a:lnSpc>
                 </a:pPr>
                 <a14:m>
@@ -26347,61 +26507,61 @@
                         </m:ctrlPr>
                       </m:dPr>
                       <m:e>
-                        <m:f>
-                          <m:fPr>
+                        <m:func>
+                          <m:funcPr>
                             <m:ctrlPr>
                               <a:rPr lang="en-US" b="0" i="1" smtClean="0">
                                 <a:latin typeface="Cambria Math" panose="02040503050406030204" pitchFamily="18" charset="0"/>
                               </a:rPr>
                             </m:ctrlPr>
-                          </m:fPr>
-                          <m:num>
-                            <m:func>
-                              <m:funcPr>
+                          </m:funcPr>
+                          <m:fName>
+                            <m:r>
+                              <a:rPr lang="en-US" b="0" i="1" smtClean="0">
+                                <a:latin typeface="Cambria Math" panose="02040503050406030204" pitchFamily="18" charset="0"/>
+                              </a:rPr>
+                              <m:t>𝑙𝑔</m:t>
+                            </m:r>
+                          </m:fName>
+                          <m:e>
+                            <m:d>
+                              <m:dPr>
                                 <m:ctrlPr>
                                   <a:rPr lang="en-US" b="0" i="1" smtClean="0">
                                     <a:latin typeface="Cambria Math" panose="02040503050406030204" pitchFamily="18" charset="0"/>
                                   </a:rPr>
                                 </m:ctrlPr>
-                              </m:funcPr>
-                              <m:fName>
-                                <m:r>
-                                  <a:rPr lang="en-US" b="0" i="1" smtClean="0">
-                                    <a:latin typeface="Cambria Math" panose="02040503050406030204" pitchFamily="18" charset="0"/>
-                                  </a:rPr>
-                                  <m:t>𝑙𝑔</m:t>
-                                </m:r>
-                              </m:fName>
+                              </m:dPr>
                               <m:e>
-                                <m:d>
-                                  <m:dPr>
+                                <m:f>
+                                  <m:fPr>
                                     <m:ctrlPr>
                                       <a:rPr lang="en-US" b="0" i="1" smtClean="0">
                                         <a:latin typeface="Cambria Math" panose="02040503050406030204" pitchFamily="18" charset="0"/>
                                       </a:rPr>
                                     </m:ctrlPr>
-                                  </m:dPr>
-                                  <m:e>
+                                  </m:fPr>
+                                  <m:num>
                                     <m:r>
                                       <a:rPr lang="en-US" b="0" i="1" smtClean="0">
                                         <a:latin typeface="Cambria Math" panose="02040503050406030204" pitchFamily="18" charset="0"/>
                                       </a:rPr>
                                       <m:t>𝑛</m:t>
                                     </m:r>
-                                  </m:e>
-                                </m:d>
+                                  </m:num>
+                                  <m:den>
+                                    <m:r>
+                                      <a:rPr lang="en-US" b="0" i="1" smtClean="0">
+                                        <a:latin typeface="Cambria Math" panose="02040503050406030204" pitchFamily="18" charset="0"/>
+                                      </a:rPr>
+                                      <m:t>4</m:t>
+                                    </m:r>
+                                  </m:den>
+                                </m:f>
                               </m:e>
-                            </m:func>
-                          </m:num>
-                          <m:den>
-                            <m:r>
-                              <a:rPr lang="en-US" b="0" i="1" smtClean="0">
-                                <a:latin typeface="Cambria Math" panose="02040503050406030204" pitchFamily="18" charset="0"/>
-                              </a:rPr>
-                              <m:t>4</m:t>
-                            </m:r>
-                          </m:den>
-                        </m:f>
+                            </m:d>
+                          </m:e>
+                        </m:func>
                       </m:e>
                     </m:d>
                     <m:r>
@@ -26478,7 +26638,7 @@
             </p:txBody>
           </p:sp>
         </mc:Choice>
-        <mc:Fallback>
+        <mc:Fallback xmlns="">
           <p:sp>
             <p:nvSpPr>
               <p:cNvPr id="3" name="Content Placeholder 2">
@@ -26518,8 +26678,8 @@
           </p:sp>
         </mc:Fallback>
       </mc:AlternateContent>
-      <mc:AlternateContent xmlns:mc="http://schemas.openxmlformats.org/markup-compatibility/2006">
-        <mc:Choice xmlns:a14="http://schemas.microsoft.com/office/drawing/2010/main" Requires="a14">
+      <mc:AlternateContent xmlns:mc="http://schemas.openxmlformats.org/markup-compatibility/2006" xmlns:a14="http://schemas.microsoft.com/office/drawing/2010/main">
+        <mc:Choice Requires="a14">
           <p:sp>
             <p:nvSpPr>
               <p:cNvPr id="6" name="TextBox 5">
@@ -26649,7 +26809,7 @@
             </p:txBody>
           </p:sp>
         </mc:Choice>
-        <mc:Fallback>
+        <mc:Fallback xmlns="">
           <p:sp>
             <p:nvSpPr>
               <p:cNvPr id="6" name="TextBox 5">
@@ -26703,6 +26863,2285 @@
   </p:cSld>
   <p:clrMapOvr>
     <a:masterClrMapping/>
+  </p:clrMapOvr>
+</p:sld>
+</file>
+
+<file path=ppt/slides/slide57.xml><?xml version="1.0" encoding="utf-8"?>
+<p:sld xmlns:a="http://schemas.openxmlformats.org/drawingml/2006/main" xmlns:r="http://schemas.openxmlformats.org/officeDocument/2006/relationships" xmlns:p="http://schemas.openxmlformats.org/presentationml/2006/main">
+  <p:cSld>
+    <p:spTree>
+      <p:nvGrpSpPr>
+        <p:cNvPr id="1" name=""/>
+        <p:cNvGrpSpPr/>
+        <p:nvPr/>
+      </p:nvGrpSpPr>
+      <p:grpSpPr>
+        <a:xfrm>
+          <a:off x="0" y="0"/>
+          <a:ext cx="0" cy="0"/>
+          <a:chOff x="0" y="0"/>
+          <a:chExt cx="0" cy="0"/>
+        </a:xfrm>
+      </p:grpSpPr>
+      <p:sp>
+        <p:nvSpPr>
+          <p:cNvPr id="2" name="Title 1">
+            <a:extLst>
+              <a:ext uri="{FF2B5EF4-FFF2-40B4-BE49-F238E27FC236}">
+                <a16:creationId xmlns:a16="http://schemas.microsoft.com/office/drawing/2014/main" id="{085B0074-5025-9CD6-FFFC-12491C02F9CD}"/>
+              </a:ext>
+            </a:extLst>
+          </p:cNvPr>
+          <p:cNvSpPr>
+            <a:spLocks noGrp="1"/>
+          </p:cNvSpPr>
+          <p:nvPr>
+            <p:ph type="title"/>
+          </p:nvPr>
+        </p:nvSpPr>
+        <p:spPr/>
+        <p:txBody>
+          <a:bodyPr/>
+          <a:lstStyle/>
+          <a:p>
+            <a:r>
+              <a:rPr lang="en-US" dirty="0"/>
+              <a:t>Master method - recap</a:t>
+            </a:r>
+          </a:p>
+        </p:txBody>
+      </p:sp>
+      <mc:AlternateContent xmlns:mc="http://schemas.openxmlformats.org/markup-compatibility/2006" xmlns:a14="http://schemas.microsoft.com/office/drawing/2010/main">
+        <mc:Choice Requires="a14">
+          <p:sp>
+            <p:nvSpPr>
+              <p:cNvPr id="3" name="Content Placeholder 2">
+                <a:extLst>
+                  <a:ext uri="{FF2B5EF4-FFF2-40B4-BE49-F238E27FC236}">
+                    <a16:creationId xmlns:a16="http://schemas.microsoft.com/office/drawing/2014/main" id="{9909A0C0-71EE-18A4-4A98-F63C91C01B1F}"/>
+                  </a:ext>
+                </a:extLst>
+              </p:cNvPr>
+              <p:cNvSpPr>
+                <a:spLocks noGrp="1"/>
+              </p:cNvSpPr>
+              <p:nvPr>
+                <p:ph idx="1"/>
+              </p:nvPr>
+            </p:nvSpPr>
+            <p:spPr/>
+            <p:txBody>
+              <a:bodyPr/>
+              <a:lstStyle/>
+              <a:p>
+                <a:r>
+                  <a:rPr lang="en-US" dirty="0"/>
+                  <a:t>If the recurrence is in the form </a:t>
+                </a:r>
+                <a14:m>
+                  <m:oMath xmlns:m="http://schemas.openxmlformats.org/officeDocument/2006/math">
+                    <m:r>
+                      <a:rPr lang="en-US" b="0" i="1" smtClean="0">
+                        <a:latin typeface="Cambria Math" panose="02040503050406030204" pitchFamily="18" charset="0"/>
+                      </a:rPr>
+                      <m:t>𝑇</m:t>
+                    </m:r>
+                    <m:d>
+                      <m:dPr>
+                        <m:ctrlPr>
+                          <a:rPr lang="en-US" b="0" i="1" smtClean="0">
+                            <a:latin typeface="Cambria Math" panose="02040503050406030204" pitchFamily="18" charset="0"/>
+                          </a:rPr>
+                        </m:ctrlPr>
+                      </m:dPr>
+                      <m:e>
+                        <m:r>
+                          <a:rPr lang="en-US" b="0" i="1" smtClean="0">
+                            <a:latin typeface="Cambria Math" panose="02040503050406030204" pitchFamily="18" charset="0"/>
+                          </a:rPr>
+                          <m:t>𝑛</m:t>
+                        </m:r>
+                      </m:e>
+                    </m:d>
+                    <m:r>
+                      <a:rPr lang="en-US" b="0" i="1" smtClean="0">
+                        <a:latin typeface="Cambria Math" panose="02040503050406030204" pitchFamily="18" charset="0"/>
+                      </a:rPr>
+                      <m:t>=</m:t>
+                    </m:r>
+                    <m:r>
+                      <a:rPr lang="en-US" b="0" i="1" smtClean="0">
+                        <a:latin typeface="Cambria Math" panose="02040503050406030204" pitchFamily="18" charset="0"/>
+                      </a:rPr>
+                      <m:t>𝑎𝑇</m:t>
+                    </m:r>
+                    <m:d>
+                      <m:dPr>
+                        <m:ctrlPr>
+                          <a:rPr lang="en-US" b="0" i="1" smtClean="0">
+                            <a:latin typeface="Cambria Math" panose="02040503050406030204" pitchFamily="18" charset="0"/>
+                          </a:rPr>
+                        </m:ctrlPr>
+                      </m:dPr>
+                      <m:e>
+                        <m:f>
+                          <m:fPr>
+                            <m:ctrlPr>
+                              <a:rPr lang="en-US" b="0" i="1" smtClean="0">
+                                <a:latin typeface="Cambria Math" panose="02040503050406030204" pitchFamily="18" charset="0"/>
+                              </a:rPr>
+                            </m:ctrlPr>
+                          </m:fPr>
+                          <m:num>
+                            <m:r>
+                              <a:rPr lang="en-US" b="0" i="1" smtClean="0">
+                                <a:latin typeface="Cambria Math" panose="02040503050406030204" pitchFamily="18" charset="0"/>
+                              </a:rPr>
+                              <m:t>𝑛</m:t>
+                            </m:r>
+                          </m:num>
+                          <m:den>
+                            <m:r>
+                              <a:rPr lang="en-US" b="0" i="1" smtClean="0">
+                                <a:latin typeface="Cambria Math" panose="02040503050406030204" pitchFamily="18" charset="0"/>
+                              </a:rPr>
+                              <m:t>𝑏</m:t>
+                            </m:r>
+                          </m:den>
+                        </m:f>
+                      </m:e>
+                    </m:d>
+                    <m:r>
+                      <a:rPr lang="en-US" b="0" i="1" smtClean="0">
+                        <a:latin typeface="Cambria Math" panose="02040503050406030204" pitchFamily="18" charset="0"/>
+                      </a:rPr>
+                      <m:t>+</m:t>
+                    </m:r>
+                    <m:r>
+                      <a:rPr lang="en-US" b="0" i="1" smtClean="0">
+                        <a:latin typeface="Cambria Math" panose="02040503050406030204" pitchFamily="18" charset="0"/>
+                      </a:rPr>
+                      <m:t>𝑓</m:t>
+                    </m:r>
+                    <m:r>
+                      <a:rPr lang="en-US" b="0" i="1" smtClean="0">
+                        <a:latin typeface="Cambria Math" panose="02040503050406030204" pitchFamily="18" charset="0"/>
+                      </a:rPr>
+                      <m:t>(</m:t>
+                    </m:r>
+                    <m:r>
+                      <a:rPr lang="en-US" b="0" i="1" smtClean="0">
+                        <a:latin typeface="Cambria Math" panose="02040503050406030204" pitchFamily="18" charset="0"/>
+                      </a:rPr>
+                      <m:t>𝑛</m:t>
+                    </m:r>
+                    <m:r>
+                      <a:rPr lang="en-US" b="0" i="1" smtClean="0">
+                        <a:latin typeface="Cambria Math" panose="02040503050406030204" pitchFamily="18" charset="0"/>
+                      </a:rPr>
+                      <m:t>)</m:t>
+                    </m:r>
+                  </m:oMath>
+                </a14:m>
+                <a:endParaRPr lang="en-US" dirty="0"/>
+              </a:p>
+              <a:p>
+                <a:r>
+                  <a:rPr lang="en-US" dirty="0"/>
+                  <a:t> </a:t>
+                </a:r>
+                <a14:m>
+                  <m:oMath xmlns:m="http://schemas.openxmlformats.org/officeDocument/2006/math">
+                    <m:r>
+                      <a:rPr lang="en-US" i="1">
+                        <a:latin typeface="Cambria Math" panose="02040503050406030204" pitchFamily="18" charset="0"/>
+                      </a:rPr>
+                      <m:t>𝑓</m:t>
+                    </m:r>
+                    <m:r>
+                      <a:rPr lang="en-US" i="1">
+                        <a:latin typeface="Cambria Math" panose="02040503050406030204" pitchFamily="18" charset="0"/>
+                      </a:rPr>
+                      <m:t>(</m:t>
+                    </m:r>
+                    <m:r>
+                      <a:rPr lang="en-US" i="1">
+                        <a:latin typeface="Cambria Math" panose="02040503050406030204" pitchFamily="18" charset="0"/>
+                      </a:rPr>
+                      <m:t>𝑛</m:t>
+                    </m:r>
+                    <m:r>
+                      <a:rPr lang="en-US" i="1">
+                        <a:latin typeface="Cambria Math" panose="02040503050406030204" pitchFamily="18" charset="0"/>
+                      </a:rPr>
+                      <m:t>)</m:t>
+                    </m:r>
+                  </m:oMath>
+                </a14:m>
+                <a:r>
+                  <a:rPr lang="en-US" dirty="0"/>
+                  <a:t> is called the “driving function”</a:t>
+                </a:r>
+              </a:p>
+              <a:p>
+                <a14:m>
+                  <m:oMath xmlns:m="http://schemas.openxmlformats.org/officeDocument/2006/math">
+                    <m:sSup>
+                      <m:sSupPr>
+                        <m:ctrlPr>
+                          <a:rPr lang="en-US" i="1" smtClean="0">
+                            <a:latin typeface="Cambria Math" panose="02040503050406030204" pitchFamily="18" charset="0"/>
+                          </a:rPr>
+                        </m:ctrlPr>
+                      </m:sSupPr>
+                      <m:e>
+                        <m:r>
+                          <a:rPr lang="en-US" b="0" i="1" smtClean="0">
+                            <a:latin typeface="Cambria Math" panose="02040503050406030204" pitchFamily="18" charset="0"/>
+                          </a:rPr>
+                          <m:t>𝑛</m:t>
+                        </m:r>
+                      </m:e>
+                      <m:sup>
+                        <m:sSub>
+                          <m:sSubPr>
+                            <m:ctrlPr>
+                              <a:rPr lang="en-US" i="1" smtClean="0">
+                                <a:latin typeface="Cambria Math" panose="02040503050406030204" pitchFamily="18" charset="0"/>
+                              </a:rPr>
+                            </m:ctrlPr>
+                          </m:sSubPr>
+                          <m:e>
+                            <m:r>
+                              <a:rPr lang="en-US" b="0" i="1" smtClean="0">
+                                <a:latin typeface="Cambria Math" panose="02040503050406030204" pitchFamily="18" charset="0"/>
+                              </a:rPr>
+                              <m:t>𝑙𝑜𝑔</m:t>
+                            </m:r>
+                          </m:e>
+                          <m:sub>
+                            <m:r>
+                              <a:rPr lang="en-US" b="0" i="1" smtClean="0">
+                                <a:latin typeface="Cambria Math" panose="02040503050406030204" pitchFamily="18" charset="0"/>
+                              </a:rPr>
+                              <m:t>𝑏</m:t>
+                            </m:r>
+                          </m:sub>
+                        </m:sSub>
+                        <m:r>
+                          <a:rPr lang="en-US" b="0" i="1" smtClean="0">
+                            <a:latin typeface="Cambria Math" panose="02040503050406030204" pitchFamily="18" charset="0"/>
+                          </a:rPr>
+                          <m:t>(</m:t>
+                        </m:r>
+                        <m:r>
+                          <a:rPr lang="en-US" b="0" i="1" smtClean="0">
+                            <a:latin typeface="Cambria Math" panose="02040503050406030204" pitchFamily="18" charset="0"/>
+                          </a:rPr>
+                          <m:t>𝑎</m:t>
+                        </m:r>
+                        <m:r>
+                          <a:rPr lang="en-US" b="0" i="1" smtClean="0">
+                            <a:latin typeface="Cambria Math" panose="02040503050406030204" pitchFamily="18" charset="0"/>
+                          </a:rPr>
+                          <m:t>)</m:t>
+                        </m:r>
+                      </m:sup>
+                    </m:sSup>
+                  </m:oMath>
+                </a14:m>
+                <a:r>
+                  <a:rPr lang="en-US" dirty="0"/>
+                  <a:t> is called the “watershed function”</a:t>
+                </a:r>
+              </a:p>
+              <a:p>
+                <a:r>
+                  <a:rPr lang="en-US" dirty="0"/>
+                  <a:t>3 Special cases make calculations easier:</a:t>
+                </a:r>
+              </a:p>
+              <a:p>
+                <a:pPr marL="914400" lvl="1" indent="-457200">
+                  <a:buFont typeface="+mj-lt"/>
+                  <a:buAutoNum type="arabicPeriod"/>
+                </a:pPr>
+                <a:r>
+                  <a:rPr lang="en-US" dirty="0"/>
+                  <a:t>If </a:t>
+                </a:r>
+                <a14:m>
+                  <m:oMath xmlns:m="http://schemas.openxmlformats.org/officeDocument/2006/math">
+                    <m:sSup>
+                      <m:sSupPr>
+                        <m:ctrlPr>
+                          <a:rPr lang="en-US" i="1">
+                            <a:latin typeface="Cambria Math" panose="02040503050406030204" pitchFamily="18" charset="0"/>
+                          </a:rPr>
+                        </m:ctrlPr>
+                      </m:sSupPr>
+                      <m:e>
+                        <m:r>
+                          <a:rPr lang="en-US" i="1">
+                            <a:latin typeface="Cambria Math" panose="02040503050406030204" pitchFamily="18" charset="0"/>
+                          </a:rPr>
+                          <m:t>𝑛</m:t>
+                        </m:r>
+                      </m:e>
+                      <m:sup>
+                        <m:sSub>
+                          <m:sSubPr>
+                            <m:ctrlPr>
+                              <a:rPr lang="en-US" i="1">
+                                <a:latin typeface="Cambria Math" panose="02040503050406030204" pitchFamily="18" charset="0"/>
+                              </a:rPr>
+                            </m:ctrlPr>
+                          </m:sSubPr>
+                          <m:e>
+                            <m:r>
+                              <a:rPr lang="en-US" i="1">
+                                <a:latin typeface="Cambria Math" panose="02040503050406030204" pitchFamily="18" charset="0"/>
+                              </a:rPr>
+                              <m:t>𝑙𝑜𝑔</m:t>
+                            </m:r>
+                          </m:e>
+                          <m:sub>
+                            <m:r>
+                              <a:rPr lang="en-US" i="1">
+                                <a:latin typeface="Cambria Math" panose="02040503050406030204" pitchFamily="18" charset="0"/>
+                              </a:rPr>
+                              <m:t>𝑏</m:t>
+                            </m:r>
+                          </m:sub>
+                        </m:sSub>
+                        <m:r>
+                          <a:rPr lang="en-US" i="1">
+                            <a:latin typeface="Cambria Math" panose="02040503050406030204" pitchFamily="18" charset="0"/>
+                          </a:rPr>
+                          <m:t>(</m:t>
+                        </m:r>
+                        <m:r>
+                          <a:rPr lang="en-US" i="1">
+                            <a:latin typeface="Cambria Math" panose="02040503050406030204" pitchFamily="18" charset="0"/>
+                          </a:rPr>
+                          <m:t>𝑎</m:t>
+                        </m:r>
+                        <m:r>
+                          <a:rPr lang="en-US" i="1">
+                            <a:latin typeface="Cambria Math" panose="02040503050406030204" pitchFamily="18" charset="0"/>
+                          </a:rPr>
+                          <m:t>)</m:t>
+                        </m:r>
+                      </m:sup>
+                    </m:sSup>
+                    <m:r>
+                      <a:rPr lang="en-US" i="1" smtClean="0">
+                        <a:latin typeface="Cambria Math" panose="02040503050406030204" pitchFamily="18" charset="0"/>
+                        <a:ea typeface="Cambria Math" panose="02040503050406030204" pitchFamily="18" charset="0"/>
+                      </a:rPr>
+                      <m:t>≫</m:t>
+                    </m:r>
+                    <m:r>
+                      <a:rPr lang="en-US" b="0" i="1" smtClean="0">
+                        <a:latin typeface="Cambria Math" panose="02040503050406030204" pitchFamily="18" charset="0"/>
+                        <a:ea typeface="Cambria Math" panose="02040503050406030204" pitchFamily="18" charset="0"/>
+                      </a:rPr>
+                      <m:t>𝑓</m:t>
+                    </m:r>
+                    <m:d>
+                      <m:dPr>
+                        <m:ctrlPr>
+                          <a:rPr lang="en-US" b="0" i="1" smtClean="0">
+                            <a:latin typeface="Cambria Math" panose="02040503050406030204" pitchFamily="18" charset="0"/>
+                            <a:ea typeface="Cambria Math" panose="02040503050406030204" pitchFamily="18" charset="0"/>
+                          </a:rPr>
+                        </m:ctrlPr>
+                      </m:dPr>
+                      <m:e>
+                        <m:r>
+                          <a:rPr lang="en-US" b="0" i="1" smtClean="0">
+                            <a:latin typeface="Cambria Math" panose="02040503050406030204" pitchFamily="18" charset="0"/>
+                            <a:ea typeface="Cambria Math" panose="02040503050406030204" pitchFamily="18" charset="0"/>
+                          </a:rPr>
+                          <m:t>𝑛</m:t>
+                        </m:r>
+                      </m:e>
+                    </m:d>
+                    <m:r>
+                      <a:rPr lang="en-US" b="0" i="1" smtClean="0">
+                        <a:latin typeface="Cambria Math" panose="02040503050406030204" pitchFamily="18" charset="0"/>
+                        <a:ea typeface="Cambria Math" panose="02040503050406030204" pitchFamily="18" charset="0"/>
+                      </a:rPr>
+                      <m:t>, </m:t>
+                    </m:r>
+                    <m:r>
+                      <a:rPr lang="en-US" b="0" i="1" smtClean="0">
+                        <a:latin typeface="Cambria Math" panose="02040503050406030204" pitchFamily="18" charset="0"/>
+                        <a:ea typeface="Cambria Math" panose="02040503050406030204" pitchFamily="18" charset="0"/>
+                      </a:rPr>
+                      <m:t>𝑡h𝑒𝑛</m:t>
+                    </m:r>
+                    <m:r>
+                      <a:rPr lang="en-US" b="0" i="1" smtClean="0">
+                        <a:latin typeface="Cambria Math" panose="02040503050406030204" pitchFamily="18" charset="0"/>
+                        <a:ea typeface="Cambria Math" panose="02040503050406030204" pitchFamily="18" charset="0"/>
+                      </a:rPr>
+                      <m:t> </m:t>
+                    </m:r>
+                    <m:r>
+                      <a:rPr lang="en-US" b="0" i="1" smtClean="0">
+                        <a:latin typeface="Cambria Math" panose="02040503050406030204" pitchFamily="18" charset="0"/>
+                        <a:ea typeface="Cambria Math" panose="02040503050406030204" pitchFamily="18" charset="0"/>
+                      </a:rPr>
+                      <m:t>𝑇</m:t>
+                    </m:r>
+                    <m:d>
+                      <m:dPr>
+                        <m:ctrlPr>
+                          <a:rPr lang="en-US" b="0" i="1" smtClean="0">
+                            <a:latin typeface="Cambria Math" panose="02040503050406030204" pitchFamily="18" charset="0"/>
+                            <a:ea typeface="Cambria Math" panose="02040503050406030204" pitchFamily="18" charset="0"/>
+                          </a:rPr>
+                        </m:ctrlPr>
+                      </m:dPr>
+                      <m:e>
+                        <m:r>
+                          <a:rPr lang="en-US" b="0" i="1" smtClean="0">
+                            <a:latin typeface="Cambria Math" panose="02040503050406030204" pitchFamily="18" charset="0"/>
+                            <a:ea typeface="Cambria Math" panose="02040503050406030204" pitchFamily="18" charset="0"/>
+                          </a:rPr>
+                          <m:t>𝑛</m:t>
+                        </m:r>
+                      </m:e>
+                    </m:d>
+                    <m:r>
+                      <a:rPr lang="en-US" b="0" i="1" smtClean="0">
+                        <a:latin typeface="Cambria Math" panose="02040503050406030204" pitchFamily="18" charset="0"/>
+                        <a:ea typeface="Cambria Math" panose="02040503050406030204" pitchFamily="18" charset="0"/>
+                      </a:rPr>
+                      <m:t>= </m:t>
+                    </m:r>
+                    <m:r>
+                      <m:rPr>
+                        <m:sty m:val="p"/>
+                      </m:rPr>
+                      <a:rPr lang="el-GR" b="0" i="1" smtClean="0">
+                        <a:latin typeface="Cambria Math" panose="02040503050406030204" pitchFamily="18" charset="0"/>
+                        <a:ea typeface="Cambria Math" panose="02040503050406030204" pitchFamily="18" charset="0"/>
+                      </a:rPr>
+                      <m:t>Θ</m:t>
+                    </m:r>
+                    <m:d>
+                      <m:dPr>
+                        <m:ctrlPr>
+                          <a:rPr lang="en-US" b="0" i="1" smtClean="0">
+                            <a:latin typeface="Cambria Math" panose="02040503050406030204" pitchFamily="18" charset="0"/>
+                            <a:ea typeface="Cambria Math" panose="02040503050406030204" pitchFamily="18" charset="0"/>
+                          </a:rPr>
+                        </m:ctrlPr>
+                      </m:dPr>
+                      <m:e>
+                        <m:sSup>
+                          <m:sSupPr>
+                            <m:ctrlPr>
+                              <a:rPr lang="en-US" i="1">
+                                <a:latin typeface="Cambria Math" panose="02040503050406030204" pitchFamily="18" charset="0"/>
+                              </a:rPr>
+                            </m:ctrlPr>
+                          </m:sSupPr>
+                          <m:e>
+                            <m:r>
+                              <a:rPr lang="en-US" i="1">
+                                <a:latin typeface="Cambria Math" panose="02040503050406030204" pitchFamily="18" charset="0"/>
+                              </a:rPr>
+                              <m:t>𝑛</m:t>
+                            </m:r>
+                          </m:e>
+                          <m:sup>
+                            <m:sSub>
+                              <m:sSubPr>
+                                <m:ctrlPr>
+                                  <a:rPr lang="en-US" i="1">
+                                    <a:latin typeface="Cambria Math" panose="02040503050406030204" pitchFamily="18" charset="0"/>
+                                  </a:rPr>
+                                </m:ctrlPr>
+                              </m:sSubPr>
+                              <m:e>
+                                <m:r>
+                                  <a:rPr lang="en-US" i="1">
+                                    <a:latin typeface="Cambria Math" panose="02040503050406030204" pitchFamily="18" charset="0"/>
+                                  </a:rPr>
+                                  <m:t>𝑙𝑜𝑔</m:t>
+                                </m:r>
+                              </m:e>
+                              <m:sub>
+                                <m:r>
+                                  <a:rPr lang="en-US" i="1">
+                                    <a:latin typeface="Cambria Math" panose="02040503050406030204" pitchFamily="18" charset="0"/>
+                                  </a:rPr>
+                                  <m:t>𝑏</m:t>
+                                </m:r>
+                              </m:sub>
+                            </m:sSub>
+                            <m:d>
+                              <m:dPr>
+                                <m:ctrlPr>
+                                  <a:rPr lang="en-US" i="1">
+                                    <a:latin typeface="Cambria Math" panose="02040503050406030204" pitchFamily="18" charset="0"/>
+                                  </a:rPr>
+                                </m:ctrlPr>
+                              </m:dPr>
+                              <m:e>
+                                <m:r>
+                                  <a:rPr lang="en-US" i="1">
+                                    <a:latin typeface="Cambria Math" panose="02040503050406030204" pitchFamily="18" charset="0"/>
+                                  </a:rPr>
+                                  <m:t>𝑎</m:t>
+                                </m:r>
+                              </m:e>
+                            </m:d>
+                          </m:sup>
+                        </m:sSup>
+                      </m:e>
+                    </m:d>
+                  </m:oMath>
+                </a14:m>
+                <a:endParaRPr lang="en-US" b="0" dirty="0">
+                  <a:ea typeface="Cambria Math" panose="02040503050406030204" pitchFamily="18" charset="0"/>
+                </a:endParaRPr>
+              </a:p>
+              <a:p>
+                <a:pPr marL="914400" lvl="1" indent="-457200">
+                  <a:buFont typeface="+mj-lt"/>
+                  <a:buAutoNum type="arabicPeriod"/>
+                </a:pPr>
+                <a:r>
+                  <a:rPr lang="en-US" dirty="0"/>
+                  <a:t>If </a:t>
+                </a:r>
+                <a14:m>
+                  <m:oMath xmlns:m="http://schemas.openxmlformats.org/officeDocument/2006/math">
+                    <m:sSup>
+                      <m:sSupPr>
+                        <m:ctrlPr>
+                          <a:rPr lang="en-US" i="1">
+                            <a:latin typeface="Cambria Math" panose="02040503050406030204" pitchFamily="18" charset="0"/>
+                          </a:rPr>
+                        </m:ctrlPr>
+                      </m:sSupPr>
+                      <m:e>
+                        <m:r>
+                          <a:rPr lang="en-US" i="1">
+                            <a:latin typeface="Cambria Math" panose="02040503050406030204" pitchFamily="18" charset="0"/>
+                          </a:rPr>
+                          <m:t>𝑛</m:t>
+                        </m:r>
+                      </m:e>
+                      <m:sup>
+                        <m:sSub>
+                          <m:sSubPr>
+                            <m:ctrlPr>
+                              <a:rPr lang="en-US" i="1">
+                                <a:latin typeface="Cambria Math" panose="02040503050406030204" pitchFamily="18" charset="0"/>
+                              </a:rPr>
+                            </m:ctrlPr>
+                          </m:sSubPr>
+                          <m:e>
+                            <m:r>
+                              <a:rPr lang="en-US" i="1">
+                                <a:latin typeface="Cambria Math" panose="02040503050406030204" pitchFamily="18" charset="0"/>
+                              </a:rPr>
+                              <m:t>𝑙𝑜𝑔</m:t>
+                            </m:r>
+                          </m:e>
+                          <m:sub>
+                            <m:r>
+                              <a:rPr lang="en-US" i="1">
+                                <a:latin typeface="Cambria Math" panose="02040503050406030204" pitchFamily="18" charset="0"/>
+                              </a:rPr>
+                              <m:t>𝑏</m:t>
+                            </m:r>
+                          </m:sub>
+                        </m:sSub>
+                        <m:r>
+                          <a:rPr lang="en-US" i="1">
+                            <a:latin typeface="Cambria Math" panose="02040503050406030204" pitchFamily="18" charset="0"/>
+                          </a:rPr>
+                          <m:t>(</m:t>
+                        </m:r>
+                        <m:r>
+                          <a:rPr lang="en-US" i="1">
+                            <a:latin typeface="Cambria Math" panose="02040503050406030204" pitchFamily="18" charset="0"/>
+                          </a:rPr>
+                          <m:t>𝑎</m:t>
+                        </m:r>
+                        <m:r>
+                          <a:rPr lang="en-US" i="1">
+                            <a:latin typeface="Cambria Math" panose="02040503050406030204" pitchFamily="18" charset="0"/>
+                          </a:rPr>
+                          <m:t>)</m:t>
+                        </m:r>
+                      </m:sup>
+                    </m:sSup>
+                    <m:r>
+                      <a:rPr lang="en-US" i="1" smtClean="0">
+                        <a:latin typeface="Cambria Math" panose="02040503050406030204" pitchFamily="18" charset="0"/>
+                        <a:ea typeface="Cambria Math" panose="02040503050406030204" pitchFamily="18" charset="0"/>
+                      </a:rPr>
+                      <m:t>≈</m:t>
+                    </m:r>
+                    <m:r>
+                      <a:rPr lang="en-US" b="0" i="1" smtClean="0">
+                        <a:latin typeface="Cambria Math" panose="02040503050406030204" pitchFamily="18" charset="0"/>
+                        <a:ea typeface="Cambria Math" panose="02040503050406030204" pitchFamily="18" charset="0"/>
+                      </a:rPr>
+                      <m:t>𝑓</m:t>
+                    </m:r>
+                    <m:d>
+                      <m:dPr>
+                        <m:ctrlPr>
+                          <a:rPr lang="en-US" b="0" i="1" smtClean="0">
+                            <a:latin typeface="Cambria Math" panose="02040503050406030204" pitchFamily="18" charset="0"/>
+                            <a:ea typeface="Cambria Math" panose="02040503050406030204" pitchFamily="18" charset="0"/>
+                          </a:rPr>
+                        </m:ctrlPr>
+                      </m:dPr>
+                      <m:e>
+                        <m:r>
+                          <a:rPr lang="en-US" b="0" i="1" smtClean="0">
+                            <a:latin typeface="Cambria Math" panose="02040503050406030204" pitchFamily="18" charset="0"/>
+                            <a:ea typeface="Cambria Math" panose="02040503050406030204" pitchFamily="18" charset="0"/>
+                          </a:rPr>
+                          <m:t>𝑛</m:t>
+                        </m:r>
+                      </m:e>
+                    </m:d>
+                    <m:r>
+                      <a:rPr lang="en-US" b="0" i="1" smtClean="0">
+                        <a:latin typeface="Cambria Math" panose="02040503050406030204" pitchFamily="18" charset="0"/>
+                        <a:ea typeface="Cambria Math" panose="02040503050406030204" pitchFamily="18" charset="0"/>
+                      </a:rPr>
+                      <m:t>, </m:t>
+                    </m:r>
+                    <m:r>
+                      <a:rPr lang="en-US" b="0" i="1" smtClean="0">
+                        <a:latin typeface="Cambria Math" panose="02040503050406030204" pitchFamily="18" charset="0"/>
+                        <a:ea typeface="Cambria Math" panose="02040503050406030204" pitchFamily="18" charset="0"/>
+                      </a:rPr>
+                      <m:t>𝑡h𝑒𝑛</m:t>
+                    </m:r>
+                    <m:r>
+                      <a:rPr lang="en-US" b="0" i="1" smtClean="0">
+                        <a:latin typeface="Cambria Math" panose="02040503050406030204" pitchFamily="18" charset="0"/>
+                        <a:ea typeface="Cambria Math" panose="02040503050406030204" pitchFamily="18" charset="0"/>
+                      </a:rPr>
+                      <m:t> </m:t>
+                    </m:r>
+                    <m:r>
+                      <a:rPr lang="en-US" i="1">
+                        <a:latin typeface="Cambria Math" panose="02040503050406030204" pitchFamily="18" charset="0"/>
+                        <a:ea typeface="Cambria Math" panose="02040503050406030204" pitchFamily="18" charset="0"/>
+                      </a:rPr>
+                      <m:t>𝑇</m:t>
+                    </m:r>
+                    <m:d>
+                      <m:dPr>
+                        <m:ctrlPr>
+                          <a:rPr lang="en-US" i="1">
+                            <a:latin typeface="Cambria Math" panose="02040503050406030204" pitchFamily="18" charset="0"/>
+                            <a:ea typeface="Cambria Math" panose="02040503050406030204" pitchFamily="18" charset="0"/>
+                          </a:rPr>
+                        </m:ctrlPr>
+                      </m:dPr>
+                      <m:e>
+                        <m:r>
+                          <a:rPr lang="en-US" i="1">
+                            <a:latin typeface="Cambria Math" panose="02040503050406030204" pitchFamily="18" charset="0"/>
+                            <a:ea typeface="Cambria Math" panose="02040503050406030204" pitchFamily="18" charset="0"/>
+                          </a:rPr>
+                          <m:t>𝑛</m:t>
+                        </m:r>
+                      </m:e>
+                    </m:d>
+                    <m:r>
+                      <a:rPr lang="en-US" i="1">
+                        <a:latin typeface="Cambria Math" panose="02040503050406030204" pitchFamily="18" charset="0"/>
+                        <a:ea typeface="Cambria Math" panose="02040503050406030204" pitchFamily="18" charset="0"/>
+                      </a:rPr>
+                      <m:t>=</m:t>
+                    </m:r>
+                    <m:r>
+                      <m:rPr>
+                        <m:sty m:val="p"/>
+                      </m:rPr>
+                      <a:rPr lang="el-GR" i="1">
+                        <a:latin typeface="Cambria Math" panose="02040503050406030204" pitchFamily="18" charset="0"/>
+                        <a:ea typeface="Cambria Math" panose="02040503050406030204" pitchFamily="18" charset="0"/>
+                      </a:rPr>
+                      <m:t>Θ</m:t>
+                    </m:r>
+                    <m:d>
+                      <m:dPr>
+                        <m:ctrlPr>
+                          <a:rPr lang="en-US" i="1">
+                            <a:latin typeface="Cambria Math" panose="02040503050406030204" pitchFamily="18" charset="0"/>
+                            <a:ea typeface="Cambria Math" panose="02040503050406030204" pitchFamily="18" charset="0"/>
+                          </a:rPr>
+                        </m:ctrlPr>
+                      </m:dPr>
+                      <m:e>
+                        <m:sSup>
+                          <m:sSupPr>
+                            <m:ctrlPr>
+                              <a:rPr lang="en-US" i="1">
+                                <a:latin typeface="Cambria Math" panose="02040503050406030204" pitchFamily="18" charset="0"/>
+                                <a:ea typeface="Cambria Math" panose="02040503050406030204" pitchFamily="18" charset="0"/>
+                              </a:rPr>
+                            </m:ctrlPr>
+                          </m:sSupPr>
+                          <m:e>
+                            <m:r>
+                              <a:rPr lang="en-US" i="1">
+                                <a:latin typeface="Cambria Math" panose="02040503050406030204" pitchFamily="18" charset="0"/>
+                                <a:ea typeface="Cambria Math" panose="02040503050406030204" pitchFamily="18" charset="0"/>
+                              </a:rPr>
+                              <m:t>𝑛</m:t>
+                            </m:r>
+                          </m:e>
+                          <m:sup>
+                            <m:sSub>
+                              <m:sSubPr>
+                                <m:ctrlPr>
+                                  <a:rPr lang="en-US" i="1">
+                                    <a:latin typeface="Cambria Math" panose="02040503050406030204" pitchFamily="18" charset="0"/>
+                                    <a:ea typeface="Cambria Math" panose="02040503050406030204" pitchFamily="18" charset="0"/>
+                                  </a:rPr>
+                                </m:ctrlPr>
+                              </m:sSubPr>
+                              <m:e>
+                                <m:r>
+                                  <a:rPr lang="en-US" i="1">
+                                    <a:latin typeface="Cambria Math" panose="02040503050406030204" pitchFamily="18" charset="0"/>
+                                    <a:ea typeface="Cambria Math" panose="02040503050406030204" pitchFamily="18" charset="0"/>
+                                  </a:rPr>
+                                  <m:t>𝑙𝑜𝑔</m:t>
+                                </m:r>
+                              </m:e>
+                              <m:sub>
+                                <m:r>
+                                  <a:rPr lang="en-US" i="1">
+                                    <a:latin typeface="Cambria Math" panose="02040503050406030204" pitchFamily="18" charset="0"/>
+                                    <a:ea typeface="Cambria Math" panose="02040503050406030204" pitchFamily="18" charset="0"/>
+                                  </a:rPr>
+                                  <m:t>𝑏</m:t>
+                                </m:r>
+                              </m:sub>
+                            </m:sSub>
+                            <m:d>
+                              <m:dPr>
+                                <m:ctrlPr>
+                                  <a:rPr lang="en-US" i="1">
+                                    <a:latin typeface="Cambria Math" panose="02040503050406030204" pitchFamily="18" charset="0"/>
+                                    <a:ea typeface="Cambria Math" panose="02040503050406030204" pitchFamily="18" charset="0"/>
+                                  </a:rPr>
+                                </m:ctrlPr>
+                              </m:dPr>
+                              <m:e>
+                                <m:r>
+                                  <a:rPr lang="en-US" i="1">
+                                    <a:latin typeface="Cambria Math" panose="02040503050406030204" pitchFamily="18" charset="0"/>
+                                    <a:ea typeface="Cambria Math" panose="02040503050406030204" pitchFamily="18" charset="0"/>
+                                  </a:rPr>
+                                  <m:t>𝑎</m:t>
+                                </m:r>
+                              </m:e>
+                            </m:d>
+                          </m:sup>
+                        </m:sSup>
+                        <m:r>
+                          <a:rPr lang="en-US" i="1">
+                            <a:latin typeface="Cambria Math" panose="02040503050406030204" pitchFamily="18" charset="0"/>
+                            <a:ea typeface="Cambria Math" panose="02040503050406030204" pitchFamily="18" charset="0"/>
+                          </a:rPr>
+                          <m:t>∗</m:t>
+                        </m:r>
+                        <m:sSup>
+                          <m:sSupPr>
+                            <m:ctrlPr>
+                              <a:rPr lang="en-US" i="1">
+                                <a:latin typeface="Cambria Math" panose="02040503050406030204" pitchFamily="18" charset="0"/>
+                                <a:ea typeface="Cambria Math" panose="02040503050406030204" pitchFamily="18" charset="0"/>
+                              </a:rPr>
+                            </m:ctrlPr>
+                          </m:sSupPr>
+                          <m:e>
+                            <m:r>
+                              <a:rPr lang="en-US" i="1">
+                                <a:latin typeface="Cambria Math" panose="02040503050406030204" pitchFamily="18" charset="0"/>
+                                <a:ea typeface="Cambria Math" panose="02040503050406030204" pitchFamily="18" charset="0"/>
+                              </a:rPr>
+                              <m:t>𝑙𝑔</m:t>
+                            </m:r>
+                          </m:e>
+                          <m:sup>
+                            <m:r>
+                              <a:rPr lang="en-US" i="1">
+                                <a:latin typeface="Cambria Math" panose="02040503050406030204" pitchFamily="18" charset="0"/>
+                                <a:ea typeface="Cambria Math" panose="02040503050406030204" pitchFamily="18" charset="0"/>
+                              </a:rPr>
+                              <m:t>𝑘</m:t>
+                            </m:r>
+                            <m:r>
+                              <a:rPr lang="en-US" i="1">
+                                <a:latin typeface="Cambria Math" panose="02040503050406030204" pitchFamily="18" charset="0"/>
+                                <a:ea typeface="Cambria Math" panose="02040503050406030204" pitchFamily="18" charset="0"/>
+                              </a:rPr>
+                              <m:t>+1</m:t>
+                            </m:r>
+                          </m:sup>
+                        </m:sSup>
+                        <m:d>
+                          <m:dPr>
+                            <m:ctrlPr>
+                              <a:rPr lang="en-US" i="1">
+                                <a:latin typeface="Cambria Math" panose="02040503050406030204" pitchFamily="18" charset="0"/>
+                                <a:ea typeface="Cambria Math" panose="02040503050406030204" pitchFamily="18" charset="0"/>
+                              </a:rPr>
+                            </m:ctrlPr>
+                          </m:dPr>
+                          <m:e>
+                            <m:r>
+                              <a:rPr lang="en-US" i="1">
+                                <a:latin typeface="Cambria Math" panose="02040503050406030204" pitchFamily="18" charset="0"/>
+                                <a:ea typeface="Cambria Math" panose="02040503050406030204" pitchFamily="18" charset="0"/>
+                              </a:rPr>
+                              <m:t>𝑛</m:t>
+                            </m:r>
+                          </m:e>
+                        </m:d>
+                      </m:e>
+                    </m:d>
+                  </m:oMath>
+                </a14:m>
+                <a:endParaRPr lang="en-US" dirty="0"/>
+              </a:p>
+              <a:p>
+                <a:pPr marL="914400" lvl="1" indent="-457200">
+                  <a:buFont typeface="+mj-lt"/>
+                  <a:buAutoNum type="arabicPeriod"/>
+                </a:pPr>
+                <a:r>
+                  <a:rPr lang="en-US" dirty="0"/>
+                  <a:t>If </a:t>
+                </a:r>
+                <a14:m>
+                  <m:oMath xmlns:m="http://schemas.openxmlformats.org/officeDocument/2006/math">
+                    <m:sSup>
+                      <m:sSupPr>
+                        <m:ctrlPr>
+                          <a:rPr lang="en-US" i="1">
+                            <a:latin typeface="Cambria Math" panose="02040503050406030204" pitchFamily="18" charset="0"/>
+                          </a:rPr>
+                        </m:ctrlPr>
+                      </m:sSupPr>
+                      <m:e>
+                        <m:r>
+                          <a:rPr lang="en-US" i="1">
+                            <a:latin typeface="Cambria Math" panose="02040503050406030204" pitchFamily="18" charset="0"/>
+                          </a:rPr>
+                          <m:t>𝑛</m:t>
+                        </m:r>
+                      </m:e>
+                      <m:sup>
+                        <m:sSub>
+                          <m:sSubPr>
+                            <m:ctrlPr>
+                              <a:rPr lang="en-US" i="1">
+                                <a:latin typeface="Cambria Math" panose="02040503050406030204" pitchFamily="18" charset="0"/>
+                              </a:rPr>
+                            </m:ctrlPr>
+                          </m:sSubPr>
+                          <m:e>
+                            <m:r>
+                              <a:rPr lang="en-US" i="1">
+                                <a:latin typeface="Cambria Math" panose="02040503050406030204" pitchFamily="18" charset="0"/>
+                              </a:rPr>
+                              <m:t>𝑙𝑜𝑔</m:t>
+                            </m:r>
+                          </m:e>
+                          <m:sub>
+                            <m:r>
+                              <a:rPr lang="en-US" i="1">
+                                <a:latin typeface="Cambria Math" panose="02040503050406030204" pitchFamily="18" charset="0"/>
+                              </a:rPr>
+                              <m:t>𝑏</m:t>
+                            </m:r>
+                          </m:sub>
+                        </m:sSub>
+                        <m:r>
+                          <a:rPr lang="en-US" i="1">
+                            <a:latin typeface="Cambria Math" panose="02040503050406030204" pitchFamily="18" charset="0"/>
+                          </a:rPr>
+                          <m:t>(</m:t>
+                        </m:r>
+                        <m:r>
+                          <a:rPr lang="en-US" i="1">
+                            <a:latin typeface="Cambria Math" panose="02040503050406030204" pitchFamily="18" charset="0"/>
+                          </a:rPr>
+                          <m:t>𝑎</m:t>
+                        </m:r>
+                        <m:r>
+                          <a:rPr lang="en-US" i="1">
+                            <a:latin typeface="Cambria Math" panose="02040503050406030204" pitchFamily="18" charset="0"/>
+                          </a:rPr>
+                          <m:t>)</m:t>
+                        </m:r>
+                      </m:sup>
+                    </m:sSup>
+                    <m:r>
+                      <a:rPr lang="en-US" b="0" i="1" smtClean="0">
+                        <a:latin typeface="Cambria Math" panose="02040503050406030204" pitchFamily="18" charset="0"/>
+                      </a:rPr>
+                      <m:t>≪</m:t>
+                    </m:r>
+                    <m:r>
+                      <a:rPr lang="en-US" b="0" i="1" smtClean="0">
+                        <a:latin typeface="Cambria Math" panose="02040503050406030204" pitchFamily="18" charset="0"/>
+                      </a:rPr>
+                      <m:t>𝑓</m:t>
+                    </m:r>
+                    <m:d>
+                      <m:dPr>
+                        <m:ctrlPr>
+                          <a:rPr lang="en-US" b="0" i="1" smtClean="0">
+                            <a:latin typeface="Cambria Math" panose="02040503050406030204" pitchFamily="18" charset="0"/>
+                          </a:rPr>
+                        </m:ctrlPr>
+                      </m:dPr>
+                      <m:e>
+                        <m:r>
+                          <a:rPr lang="en-US" b="0" i="1" smtClean="0">
+                            <a:latin typeface="Cambria Math" panose="02040503050406030204" pitchFamily="18" charset="0"/>
+                          </a:rPr>
+                          <m:t>𝑛</m:t>
+                        </m:r>
+                      </m:e>
+                    </m:d>
+                    <m:r>
+                      <a:rPr lang="en-US" b="0" i="1" smtClean="0">
+                        <a:latin typeface="Cambria Math" panose="02040503050406030204" pitchFamily="18" charset="0"/>
+                      </a:rPr>
+                      <m:t>, </m:t>
+                    </m:r>
+                    <m:r>
+                      <a:rPr lang="en-US" b="0" i="1" smtClean="0">
+                        <a:latin typeface="Cambria Math" panose="02040503050406030204" pitchFamily="18" charset="0"/>
+                      </a:rPr>
+                      <m:t>𝑡h𝑒𝑛</m:t>
+                    </m:r>
+                    <m:r>
+                      <a:rPr lang="en-US" b="0" i="1" smtClean="0">
+                        <a:latin typeface="Cambria Math" panose="02040503050406030204" pitchFamily="18" charset="0"/>
+                      </a:rPr>
+                      <m:t> </m:t>
+                    </m:r>
+                    <m:r>
+                      <a:rPr lang="en-US" b="0" i="1" smtClean="0">
+                        <a:latin typeface="Cambria Math" panose="02040503050406030204" pitchFamily="18" charset="0"/>
+                      </a:rPr>
+                      <m:t>𝑇</m:t>
+                    </m:r>
+                    <m:d>
+                      <m:dPr>
+                        <m:ctrlPr>
+                          <a:rPr lang="en-US" b="0" i="1" smtClean="0">
+                            <a:latin typeface="Cambria Math" panose="02040503050406030204" pitchFamily="18" charset="0"/>
+                          </a:rPr>
+                        </m:ctrlPr>
+                      </m:dPr>
+                      <m:e>
+                        <m:r>
+                          <a:rPr lang="en-US" b="0" i="1" smtClean="0">
+                            <a:latin typeface="Cambria Math" panose="02040503050406030204" pitchFamily="18" charset="0"/>
+                          </a:rPr>
+                          <m:t>𝑛</m:t>
+                        </m:r>
+                      </m:e>
+                    </m:d>
+                    <m:r>
+                      <a:rPr lang="en-US" b="0" i="1" smtClean="0">
+                        <a:latin typeface="Cambria Math" panose="02040503050406030204" pitchFamily="18" charset="0"/>
+                      </a:rPr>
+                      <m:t>=</m:t>
+                    </m:r>
+                    <m:r>
+                      <m:rPr>
+                        <m:sty m:val="p"/>
+                      </m:rPr>
+                      <a:rPr lang="el-GR" i="1">
+                        <a:latin typeface="Cambria Math" panose="02040503050406030204" pitchFamily="18" charset="0"/>
+                        <a:ea typeface="Cambria Math" panose="02040503050406030204" pitchFamily="18" charset="0"/>
+                      </a:rPr>
+                      <m:t>Θ</m:t>
+                    </m:r>
+                    <m:d>
+                      <m:dPr>
+                        <m:ctrlPr>
+                          <a:rPr lang="en-US" b="0" i="1" smtClean="0">
+                            <a:latin typeface="Cambria Math" panose="02040503050406030204" pitchFamily="18" charset="0"/>
+                            <a:ea typeface="Cambria Math" panose="02040503050406030204" pitchFamily="18" charset="0"/>
+                          </a:rPr>
+                        </m:ctrlPr>
+                      </m:dPr>
+                      <m:e>
+                        <m:r>
+                          <a:rPr lang="en-US" b="0" i="1" smtClean="0">
+                            <a:latin typeface="Cambria Math" panose="02040503050406030204" pitchFamily="18" charset="0"/>
+                            <a:ea typeface="Cambria Math" panose="02040503050406030204" pitchFamily="18" charset="0"/>
+                          </a:rPr>
+                          <m:t>𝑓</m:t>
+                        </m:r>
+                        <m:d>
+                          <m:dPr>
+                            <m:ctrlPr>
+                              <a:rPr lang="en-US" b="0" i="1" smtClean="0">
+                                <a:latin typeface="Cambria Math" panose="02040503050406030204" pitchFamily="18" charset="0"/>
+                                <a:ea typeface="Cambria Math" panose="02040503050406030204" pitchFamily="18" charset="0"/>
+                              </a:rPr>
+                            </m:ctrlPr>
+                          </m:dPr>
+                          <m:e>
+                            <m:r>
+                              <a:rPr lang="en-US" b="0" i="1" smtClean="0">
+                                <a:latin typeface="Cambria Math" panose="02040503050406030204" pitchFamily="18" charset="0"/>
+                                <a:ea typeface="Cambria Math" panose="02040503050406030204" pitchFamily="18" charset="0"/>
+                              </a:rPr>
+                              <m:t>𝑛</m:t>
+                            </m:r>
+                          </m:e>
+                        </m:d>
+                      </m:e>
+                    </m:d>
+                  </m:oMath>
+                </a14:m>
+                <a:endParaRPr lang="en-US" dirty="0"/>
+              </a:p>
+              <a:p>
+                <a:endParaRPr lang="en-US" dirty="0"/>
+              </a:p>
+            </p:txBody>
+          </p:sp>
+        </mc:Choice>
+        <mc:Fallback xmlns="">
+          <p:sp>
+            <p:nvSpPr>
+              <p:cNvPr id="3" name="Content Placeholder 2">
+                <a:extLst>
+                  <a:ext uri="{FF2B5EF4-FFF2-40B4-BE49-F238E27FC236}">
+                    <a16:creationId xmlns:a16="http://schemas.microsoft.com/office/drawing/2014/main" id="{9909A0C0-71EE-18A4-4A98-F63C91C01B1F}"/>
+                  </a:ext>
+                </a:extLst>
+              </p:cNvPr>
+              <p:cNvSpPr>
+                <a:spLocks noGrp="1" noRot="1" noChangeAspect="1" noMove="1" noResize="1" noEditPoints="1" noAdjustHandles="1" noChangeArrowheads="1" noChangeShapeType="1" noTextEdit="1"/>
+              </p:cNvSpPr>
+              <p:nvPr>
+                <p:ph idx="1"/>
+              </p:nvPr>
+            </p:nvSpPr>
+            <p:spPr>
+              <a:blipFill>
+                <a:blip r:embed="rId2"/>
+                <a:stretch>
+                  <a:fillRect l="-1043"/>
+                </a:stretch>
+              </a:blipFill>
+            </p:spPr>
+            <p:txBody>
+              <a:bodyPr/>
+              <a:lstStyle/>
+              <a:p>
+                <a:r>
+                  <a:rPr lang="en-US">
+                    <a:noFill/>
+                  </a:rPr>
+                  <a:t> </a:t>
+                </a:r>
+              </a:p>
+            </p:txBody>
+          </p:sp>
+        </mc:Fallback>
+      </mc:AlternateContent>
+    </p:spTree>
+    <p:extLst>
+      <p:ext uri="{BB962C8B-B14F-4D97-AF65-F5344CB8AC3E}">
+        <p14:creationId xmlns:p14="http://schemas.microsoft.com/office/powerpoint/2010/main" val="3208078414"/>
+      </p:ext>
+    </p:extLst>
+  </p:cSld>
+  <p:clrMapOvr>
+    <a:masterClrMapping/>
+  </p:clrMapOvr>
+</p:sld>
+</file>
+
+<file path=ppt/slides/slide58.xml><?xml version="1.0" encoding="utf-8"?>
+<p:sld xmlns:a="http://schemas.openxmlformats.org/drawingml/2006/main" xmlns:r="http://schemas.openxmlformats.org/officeDocument/2006/relationships" xmlns:p="http://schemas.openxmlformats.org/presentationml/2006/main">
+  <p:cSld>
+    <p:spTree>
+      <p:nvGrpSpPr>
+        <p:cNvPr id="1" name=""/>
+        <p:cNvGrpSpPr/>
+        <p:nvPr/>
+      </p:nvGrpSpPr>
+      <p:grpSpPr>
+        <a:xfrm>
+          <a:off x="0" y="0"/>
+          <a:ext cx="0" cy="0"/>
+          <a:chOff x="0" y="0"/>
+          <a:chExt cx="0" cy="0"/>
+        </a:xfrm>
+      </p:grpSpPr>
+      <p:sp>
+        <p:nvSpPr>
+          <p:cNvPr id="2" name="Title 1">
+            <a:extLst>
+              <a:ext uri="{FF2B5EF4-FFF2-40B4-BE49-F238E27FC236}">
+                <a16:creationId xmlns:a16="http://schemas.microsoft.com/office/drawing/2014/main" id="{79B17E39-6851-E345-1E34-18BB8E6B0905}"/>
+              </a:ext>
+            </a:extLst>
+          </p:cNvPr>
+          <p:cNvSpPr>
+            <a:spLocks noGrp="1"/>
+          </p:cNvSpPr>
+          <p:nvPr>
+            <p:ph type="title"/>
+          </p:nvPr>
+        </p:nvSpPr>
+        <p:spPr/>
+        <p:txBody>
+          <a:bodyPr/>
+          <a:lstStyle/>
+          <a:p>
+            <a:r>
+              <a:rPr lang="en-US"/>
+              <a:t>Appendix</a:t>
+            </a:r>
+            <a:endParaRPr lang="en-US" dirty="0"/>
+          </a:p>
+        </p:txBody>
+      </p:sp>
+      <mc:AlternateContent xmlns:mc="http://schemas.openxmlformats.org/markup-compatibility/2006" xmlns:a14="http://schemas.microsoft.com/office/drawing/2010/main">
+        <mc:Choice Requires="a14">
+          <p:sp>
+            <p:nvSpPr>
+              <p:cNvPr id="3" name="Content Placeholder 2">
+                <a:extLst>
+                  <a:ext uri="{FF2B5EF4-FFF2-40B4-BE49-F238E27FC236}">
+                    <a16:creationId xmlns:a16="http://schemas.microsoft.com/office/drawing/2014/main" id="{8F0982BA-7FD9-E6A8-8955-F7036DC43270}"/>
+                  </a:ext>
+                </a:extLst>
+              </p:cNvPr>
+              <p:cNvSpPr>
+                <a:spLocks noGrp="1"/>
+              </p:cNvSpPr>
+              <p:nvPr>
+                <p:ph idx="1"/>
+              </p:nvPr>
+            </p:nvSpPr>
+            <p:spPr/>
+            <p:txBody>
+              <a:bodyPr/>
+              <a:lstStyle/>
+              <a:p>
+                <a:r>
+                  <a:rPr lang="en-US" dirty="0"/>
+                  <a:t>When we write “</a:t>
+                </a:r>
+                <a14:m>
+                  <m:oMath xmlns:m="http://schemas.openxmlformats.org/officeDocument/2006/math">
+                    <m:r>
+                      <m:rPr>
+                        <m:sty m:val="p"/>
+                      </m:rPr>
+                      <a:rPr lang="en-US">
+                        <a:latin typeface="Cambria Math" panose="02040503050406030204" pitchFamily="18" charset="0"/>
+                      </a:rPr>
+                      <m:t>g</m:t>
+                    </m:r>
+                    <m:r>
+                      <a:rPr lang="en-US" b="0" i="0" smtClean="0">
+                        <a:latin typeface="Cambria Math" panose="02040503050406030204" pitchFamily="18" charset="0"/>
+                      </a:rPr>
+                      <m:t>(</m:t>
+                    </m:r>
+                    <m:r>
+                      <m:rPr>
+                        <m:sty m:val="p"/>
+                      </m:rPr>
+                      <a:rPr lang="en-US" b="0" i="0" smtClean="0">
+                        <a:latin typeface="Cambria Math" panose="02040503050406030204" pitchFamily="18" charset="0"/>
+                      </a:rPr>
+                      <m:t>n</m:t>
+                    </m:r>
+                    <m:r>
+                      <a:rPr lang="en-US" b="0" i="0" smtClean="0">
+                        <a:latin typeface="Cambria Math" panose="02040503050406030204" pitchFamily="18" charset="0"/>
+                      </a:rPr>
+                      <m:t>)</m:t>
+                    </m:r>
+                    <m:r>
+                      <a:rPr lang="en-US" b="0" i="1" smtClean="0">
+                        <a:latin typeface="Cambria Math" panose="02040503050406030204" pitchFamily="18" charset="0"/>
+                      </a:rPr>
+                      <m:t>≫</m:t>
+                    </m:r>
+                    <m:r>
+                      <a:rPr lang="en-US" b="0" i="1" smtClean="0">
+                        <a:latin typeface="Cambria Math" panose="02040503050406030204" pitchFamily="18" charset="0"/>
+                      </a:rPr>
+                      <m:t>𝑓</m:t>
+                    </m:r>
+                    <m:r>
+                      <a:rPr lang="en-US" b="0" i="1" smtClean="0">
+                        <a:latin typeface="Cambria Math" panose="02040503050406030204" pitchFamily="18" charset="0"/>
+                      </a:rPr>
+                      <m:t>(</m:t>
+                    </m:r>
+                    <m:r>
+                      <a:rPr lang="en-US" b="0" i="1" smtClean="0">
+                        <a:latin typeface="Cambria Math" panose="02040503050406030204" pitchFamily="18" charset="0"/>
+                      </a:rPr>
+                      <m:t>𝑛</m:t>
+                    </m:r>
+                    <m:r>
+                      <a:rPr lang="en-US" b="0" i="1" smtClean="0">
+                        <a:latin typeface="Cambria Math" panose="02040503050406030204" pitchFamily="18" charset="0"/>
+                      </a:rPr>
+                      <m:t>)</m:t>
+                    </m:r>
+                  </m:oMath>
+                </a14:m>
+                <a:r>
+                  <a:rPr lang="en-US" dirty="0"/>
+                  <a:t>” In the context of </a:t>
+                </a:r>
+                <a:r>
+                  <a:rPr lang="en-US" dirty="0" err="1"/>
+                  <a:t>the“Master</a:t>
+                </a:r>
+                <a:r>
+                  <a:rPr lang="en-US" dirty="0"/>
+                  <a:t> Theorem”, we mean that </a:t>
+                </a:r>
+                <a:r>
+                  <a:rPr lang="en-US" i="1" dirty="0"/>
+                  <a:t>g</a:t>
+                </a:r>
+                <a:r>
+                  <a:rPr lang="en-US" dirty="0"/>
+                  <a:t> grows </a:t>
+                </a:r>
+                <a:r>
+                  <a:rPr lang="en-US" i="1" dirty="0" err="1"/>
+                  <a:t>polynomially</a:t>
+                </a:r>
+                <a:r>
+                  <a:rPr lang="en-US" i="1" dirty="0"/>
+                  <a:t> faster than f</a:t>
+                </a:r>
+              </a:p>
+              <a:p>
+                <a:pPr lvl="1"/>
+                <a:r>
+                  <a:rPr lang="en-US" i="1" dirty="0"/>
+                  <a:t>Which means </a:t>
+                </a:r>
+                <a14:m>
+                  <m:oMath xmlns:m="http://schemas.openxmlformats.org/officeDocument/2006/math">
+                    <m:f>
+                      <m:fPr>
+                        <m:ctrlPr>
+                          <a:rPr lang="en-US" b="0" i="1" smtClean="0">
+                            <a:latin typeface="Cambria Math" panose="02040503050406030204" pitchFamily="18" charset="0"/>
+                          </a:rPr>
+                        </m:ctrlPr>
+                      </m:fPr>
+                      <m:num>
+                        <m:r>
+                          <a:rPr lang="en-US" b="0" i="1" smtClean="0">
+                            <a:latin typeface="Cambria Math" panose="02040503050406030204" pitchFamily="18" charset="0"/>
+                          </a:rPr>
+                          <m:t>𝑔</m:t>
+                        </m:r>
+                        <m:d>
+                          <m:dPr>
+                            <m:ctrlPr>
+                              <a:rPr lang="en-US" b="0" i="1" smtClean="0">
+                                <a:latin typeface="Cambria Math" panose="02040503050406030204" pitchFamily="18" charset="0"/>
+                              </a:rPr>
+                            </m:ctrlPr>
+                          </m:dPr>
+                          <m:e>
+                            <m:r>
+                              <a:rPr lang="en-US" b="0" i="1" smtClean="0">
+                                <a:latin typeface="Cambria Math" panose="02040503050406030204" pitchFamily="18" charset="0"/>
+                              </a:rPr>
+                              <m:t>𝑛</m:t>
+                            </m:r>
+                          </m:e>
+                        </m:d>
+                      </m:num>
+                      <m:den>
+                        <m:r>
+                          <a:rPr lang="en-US" b="0" i="1" smtClean="0">
+                            <a:latin typeface="Cambria Math" panose="02040503050406030204" pitchFamily="18" charset="0"/>
+                          </a:rPr>
+                          <m:t>𝑓</m:t>
+                        </m:r>
+                        <m:d>
+                          <m:dPr>
+                            <m:ctrlPr>
+                              <a:rPr lang="en-US" b="0" i="1" smtClean="0">
+                                <a:latin typeface="Cambria Math" panose="02040503050406030204" pitchFamily="18" charset="0"/>
+                              </a:rPr>
+                            </m:ctrlPr>
+                          </m:dPr>
+                          <m:e>
+                            <m:r>
+                              <a:rPr lang="en-US" b="0" i="1" smtClean="0">
+                                <a:latin typeface="Cambria Math" panose="02040503050406030204" pitchFamily="18" charset="0"/>
+                              </a:rPr>
+                              <m:t>𝑛</m:t>
+                            </m:r>
+                          </m:e>
+                        </m:d>
+                      </m:den>
+                    </m:f>
+                    <m:r>
+                      <a:rPr lang="en-US" b="0" i="1" smtClean="0">
+                        <a:latin typeface="Cambria Math" panose="02040503050406030204" pitchFamily="18" charset="0"/>
+                      </a:rPr>
+                      <m:t>=</m:t>
+                    </m:r>
+                    <m:sSup>
+                      <m:sSupPr>
+                        <m:ctrlPr>
+                          <a:rPr lang="en-US" b="0" i="1" smtClean="0">
+                            <a:latin typeface="Cambria Math" panose="02040503050406030204" pitchFamily="18" charset="0"/>
+                          </a:rPr>
+                        </m:ctrlPr>
+                      </m:sSupPr>
+                      <m:e>
+                        <m:r>
+                          <a:rPr lang="en-US" b="0" i="1" smtClean="0">
+                            <a:latin typeface="Cambria Math" panose="02040503050406030204" pitchFamily="18" charset="0"/>
+                          </a:rPr>
+                          <m:t>𝑛</m:t>
+                        </m:r>
+                      </m:e>
+                      <m:sup>
+                        <m:r>
+                          <a:rPr lang="en-US" b="0" i="1" smtClean="0">
+                            <a:latin typeface="Cambria Math" panose="02040503050406030204" pitchFamily="18" charset="0"/>
+                          </a:rPr>
+                          <m:t>𝑘</m:t>
+                        </m:r>
+                      </m:sup>
+                    </m:sSup>
+                    <m:r>
+                      <a:rPr lang="en-US" b="0" i="1" smtClean="0">
+                        <a:latin typeface="Cambria Math" panose="02040503050406030204" pitchFamily="18" charset="0"/>
+                      </a:rPr>
+                      <m:t>,  </m:t>
+                    </m:r>
+                    <m:r>
+                      <a:rPr lang="en-US" b="0" i="1" smtClean="0">
+                        <a:latin typeface="Cambria Math" panose="02040503050406030204" pitchFamily="18" charset="0"/>
+                      </a:rPr>
+                      <m:t>𝑘</m:t>
+                    </m:r>
+                    <m:r>
+                      <a:rPr lang="en-US" b="0" i="1" smtClean="0">
+                        <a:latin typeface="Cambria Math" panose="02040503050406030204" pitchFamily="18" charset="0"/>
+                      </a:rPr>
+                      <m:t>&gt;0</m:t>
+                    </m:r>
+                  </m:oMath>
+                </a14:m>
+                <a:endParaRPr lang="en-US" i="1" dirty="0"/>
+              </a:p>
+              <a:p>
+                <a:r>
+                  <a:rPr lang="en-US" i="1" dirty="0"/>
+                  <a:t>Examples:</a:t>
+                </a:r>
+              </a:p>
+              <a:p>
+                <a:pPr lvl="1">
+                  <a:lnSpc>
+                    <a:spcPct val="100000"/>
+                  </a:lnSpc>
+                </a:pPr>
+                <a14:m>
+                  <m:oMath xmlns:m="http://schemas.openxmlformats.org/officeDocument/2006/math">
+                    <m:f>
+                      <m:fPr>
+                        <m:ctrlPr>
+                          <a:rPr lang="en-US" i="1" smtClean="0">
+                            <a:latin typeface="Cambria Math" panose="02040503050406030204" pitchFamily="18" charset="0"/>
+                          </a:rPr>
+                        </m:ctrlPr>
+                      </m:fPr>
+                      <m:num>
+                        <m:sSup>
+                          <m:sSupPr>
+                            <m:ctrlPr>
+                              <a:rPr lang="en-US" i="1" smtClean="0">
+                                <a:latin typeface="Cambria Math" panose="02040503050406030204" pitchFamily="18" charset="0"/>
+                              </a:rPr>
+                            </m:ctrlPr>
+                          </m:sSupPr>
+                          <m:e>
+                            <m:r>
+                              <a:rPr lang="en-US" b="0" i="1" smtClean="0">
+                                <a:latin typeface="Cambria Math" panose="02040503050406030204" pitchFamily="18" charset="0"/>
+                              </a:rPr>
+                              <m:t>𝑛</m:t>
+                            </m:r>
+                          </m:e>
+                          <m:sup>
+                            <m:r>
+                              <a:rPr lang="en-US" b="0" i="1" smtClean="0">
+                                <a:latin typeface="Cambria Math" panose="02040503050406030204" pitchFamily="18" charset="0"/>
+                              </a:rPr>
+                              <m:t>2</m:t>
+                            </m:r>
+                          </m:sup>
+                        </m:sSup>
+                      </m:num>
+                      <m:den>
+                        <m:sSup>
+                          <m:sSupPr>
+                            <m:ctrlPr>
+                              <a:rPr lang="en-US" i="1" smtClean="0">
+                                <a:latin typeface="Cambria Math" panose="02040503050406030204" pitchFamily="18" charset="0"/>
+                              </a:rPr>
+                            </m:ctrlPr>
+                          </m:sSupPr>
+                          <m:e>
+                            <m:r>
+                              <a:rPr lang="en-US" b="0" i="1" smtClean="0">
+                                <a:latin typeface="Cambria Math" panose="02040503050406030204" pitchFamily="18" charset="0"/>
+                              </a:rPr>
+                              <m:t>𝑛</m:t>
+                            </m:r>
+                          </m:e>
+                          <m:sup>
+                            <m:r>
+                              <a:rPr lang="en-US" b="0" i="1" smtClean="0">
+                                <a:latin typeface="Cambria Math" panose="02040503050406030204" pitchFamily="18" charset="0"/>
+                              </a:rPr>
+                              <m:t>1.99</m:t>
+                            </m:r>
+                          </m:sup>
+                        </m:sSup>
+                      </m:den>
+                    </m:f>
+                    <m:r>
+                      <a:rPr lang="en-US" b="0" i="1" smtClean="0">
+                        <a:latin typeface="Cambria Math" panose="02040503050406030204" pitchFamily="18" charset="0"/>
+                      </a:rPr>
+                      <m:t>=</m:t>
+                    </m:r>
+                    <m:sSup>
+                      <m:sSupPr>
+                        <m:ctrlPr>
+                          <a:rPr lang="en-US" b="0" i="1" smtClean="0">
+                            <a:latin typeface="Cambria Math" panose="02040503050406030204" pitchFamily="18" charset="0"/>
+                          </a:rPr>
+                        </m:ctrlPr>
+                      </m:sSupPr>
+                      <m:e>
+                        <m:r>
+                          <a:rPr lang="en-US" b="0" i="1" smtClean="0">
+                            <a:latin typeface="Cambria Math" panose="02040503050406030204" pitchFamily="18" charset="0"/>
+                          </a:rPr>
+                          <m:t>𝑛</m:t>
+                        </m:r>
+                      </m:e>
+                      <m:sup>
+                        <m:r>
+                          <a:rPr lang="en-US" b="0" i="1" smtClean="0">
+                            <a:latin typeface="Cambria Math" panose="02040503050406030204" pitchFamily="18" charset="0"/>
+                          </a:rPr>
+                          <m:t>0.01</m:t>
+                        </m:r>
+                      </m:sup>
+                    </m:sSup>
+                  </m:oMath>
+                </a14:m>
+                <a:r>
+                  <a:rPr lang="en-US" dirty="0"/>
+                  <a:t>, therefore </a:t>
+                </a:r>
+                <a14:m>
+                  <m:oMath xmlns:m="http://schemas.openxmlformats.org/officeDocument/2006/math">
+                    <m:sSup>
+                      <m:sSupPr>
+                        <m:ctrlPr>
+                          <a:rPr lang="en-US" i="1" smtClean="0">
+                            <a:latin typeface="Cambria Math" panose="02040503050406030204" pitchFamily="18" charset="0"/>
+                          </a:rPr>
+                        </m:ctrlPr>
+                      </m:sSupPr>
+                      <m:e>
+                        <m:r>
+                          <a:rPr lang="en-US" b="0" i="1" smtClean="0">
+                            <a:latin typeface="Cambria Math" panose="02040503050406030204" pitchFamily="18" charset="0"/>
+                          </a:rPr>
+                          <m:t>𝑛</m:t>
+                        </m:r>
+                      </m:e>
+                      <m:sup>
+                        <m:r>
+                          <a:rPr lang="en-US" b="0" i="1" smtClean="0">
+                            <a:latin typeface="Cambria Math" panose="02040503050406030204" pitchFamily="18" charset="0"/>
+                          </a:rPr>
+                          <m:t>2</m:t>
+                        </m:r>
+                      </m:sup>
+                    </m:sSup>
+                    <m:r>
+                      <a:rPr lang="en-US" i="1">
+                        <a:latin typeface="Cambria Math" panose="02040503050406030204" pitchFamily="18" charset="0"/>
+                      </a:rPr>
+                      <m:t>≫</m:t>
+                    </m:r>
+                    <m:sSup>
+                      <m:sSupPr>
+                        <m:ctrlPr>
+                          <a:rPr lang="en-US" i="1" smtClean="0">
+                            <a:latin typeface="Cambria Math" panose="02040503050406030204" pitchFamily="18" charset="0"/>
+                          </a:rPr>
+                        </m:ctrlPr>
+                      </m:sSupPr>
+                      <m:e>
+                        <m:r>
+                          <a:rPr lang="en-US" b="0" i="1" smtClean="0">
+                            <a:latin typeface="Cambria Math" panose="02040503050406030204" pitchFamily="18" charset="0"/>
+                          </a:rPr>
+                          <m:t>𝑛</m:t>
+                        </m:r>
+                      </m:e>
+                      <m:sup>
+                        <m:r>
+                          <a:rPr lang="en-US" b="0" i="1" smtClean="0">
+                            <a:latin typeface="Cambria Math" panose="02040503050406030204" pitchFamily="18" charset="0"/>
+                          </a:rPr>
+                          <m:t>1.99</m:t>
+                        </m:r>
+                      </m:sup>
+                    </m:sSup>
+                  </m:oMath>
+                </a14:m>
+                <a:endParaRPr lang="en-US" dirty="0"/>
+              </a:p>
+              <a:p>
+                <a:pPr lvl="1">
+                  <a:lnSpc>
+                    <a:spcPct val="100000"/>
+                  </a:lnSpc>
+                </a:pPr>
+                <a14:m>
+                  <m:oMath xmlns:m="http://schemas.openxmlformats.org/officeDocument/2006/math">
+                    <m:f>
+                      <m:fPr>
+                        <m:ctrlPr>
+                          <a:rPr lang="en-US" b="0" i="1" smtClean="0">
+                            <a:latin typeface="Cambria Math" panose="02040503050406030204" pitchFamily="18" charset="0"/>
+                          </a:rPr>
+                        </m:ctrlPr>
+                      </m:fPr>
+                      <m:num>
+                        <m:r>
+                          <a:rPr lang="en-US" b="0" i="1" smtClean="0">
+                            <a:latin typeface="Cambria Math" panose="02040503050406030204" pitchFamily="18" charset="0"/>
+                          </a:rPr>
+                          <m:t>𝑛</m:t>
+                        </m:r>
+                        <m:r>
+                          <a:rPr lang="en-US" b="0" i="1" smtClean="0">
+                            <a:latin typeface="Cambria Math" panose="02040503050406030204" pitchFamily="18" charset="0"/>
+                          </a:rPr>
+                          <m:t>∗</m:t>
+                        </m:r>
+                        <m:r>
+                          <a:rPr lang="en-US" b="0" i="1" smtClean="0">
+                            <a:latin typeface="Cambria Math" panose="02040503050406030204" pitchFamily="18" charset="0"/>
+                          </a:rPr>
+                          <m:t>𝑙𝑔</m:t>
+                        </m:r>
+                        <m:r>
+                          <a:rPr lang="en-US" b="0" i="1" smtClean="0">
+                            <a:latin typeface="Cambria Math" panose="02040503050406030204" pitchFamily="18" charset="0"/>
+                          </a:rPr>
+                          <m:t>⁡(</m:t>
+                        </m:r>
+                        <m:r>
+                          <a:rPr lang="en-US" b="0" i="1" smtClean="0">
+                            <a:latin typeface="Cambria Math" panose="02040503050406030204" pitchFamily="18" charset="0"/>
+                          </a:rPr>
+                          <m:t>𝑛</m:t>
+                        </m:r>
+                        <m:r>
+                          <a:rPr lang="en-US" b="0" i="1" smtClean="0">
+                            <a:latin typeface="Cambria Math" panose="02040503050406030204" pitchFamily="18" charset="0"/>
+                          </a:rPr>
+                          <m:t>)</m:t>
+                        </m:r>
+                      </m:num>
+                      <m:den>
+                        <m:r>
+                          <a:rPr lang="en-US" b="0" i="1" smtClean="0">
+                            <a:latin typeface="Cambria Math" panose="02040503050406030204" pitchFamily="18" charset="0"/>
+                          </a:rPr>
+                          <m:t>𝑛</m:t>
+                        </m:r>
+                      </m:den>
+                    </m:f>
+                    <m:r>
+                      <a:rPr lang="en-US" b="0" i="1" smtClean="0">
+                        <a:latin typeface="Cambria Math" panose="02040503050406030204" pitchFamily="18" charset="0"/>
+                      </a:rPr>
+                      <m:t>=</m:t>
+                    </m:r>
+                    <m:r>
+                      <a:rPr lang="en-US" b="0" i="1" smtClean="0">
+                        <a:latin typeface="Cambria Math" panose="02040503050406030204" pitchFamily="18" charset="0"/>
+                      </a:rPr>
+                      <m:t>𝑙𝑔</m:t>
+                    </m:r>
+                    <m:r>
+                      <a:rPr lang="en-US" b="0" i="1" smtClean="0">
+                        <a:latin typeface="Cambria Math" panose="02040503050406030204" pitchFamily="18" charset="0"/>
+                      </a:rPr>
+                      <m:t>⁡(</m:t>
+                    </m:r>
+                    <m:r>
+                      <a:rPr lang="en-US" b="0" i="1" smtClean="0">
+                        <a:latin typeface="Cambria Math" panose="02040503050406030204" pitchFamily="18" charset="0"/>
+                      </a:rPr>
+                      <m:t>𝑛</m:t>
+                    </m:r>
+                    <m:r>
+                      <a:rPr lang="en-US" b="0" i="1" smtClean="0">
+                        <a:latin typeface="Cambria Math" panose="02040503050406030204" pitchFamily="18" charset="0"/>
+                      </a:rPr>
+                      <m:t>)</m:t>
+                    </m:r>
+                  </m:oMath>
+                </a14:m>
+                <a:r>
+                  <a:rPr lang="en-US" dirty="0"/>
+                  <a:t>, therefore </a:t>
+                </a:r>
+                <a14:m>
+                  <m:oMath xmlns:m="http://schemas.openxmlformats.org/officeDocument/2006/math">
+                    <m:r>
+                      <a:rPr lang="en-US" b="0" i="1" smtClean="0">
+                        <a:latin typeface="Cambria Math" panose="02040503050406030204" pitchFamily="18" charset="0"/>
+                      </a:rPr>
+                      <m:t>𝑛</m:t>
+                    </m:r>
+                    <m:r>
+                      <a:rPr lang="en-US" b="0" i="1" smtClean="0">
+                        <a:latin typeface="Cambria Math" panose="02040503050406030204" pitchFamily="18" charset="0"/>
+                      </a:rPr>
+                      <m:t>≈</m:t>
+                    </m:r>
+                    <m:r>
+                      <a:rPr lang="en-US" b="0" i="1" smtClean="0">
+                        <a:latin typeface="Cambria Math" panose="02040503050406030204" pitchFamily="18" charset="0"/>
+                      </a:rPr>
+                      <m:t>𝑛</m:t>
+                    </m:r>
+                    <m:r>
+                      <a:rPr lang="en-US" b="0" i="1" smtClean="0">
+                        <a:latin typeface="Cambria Math" panose="02040503050406030204" pitchFamily="18" charset="0"/>
+                      </a:rPr>
+                      <m:t>∗ </m:t>
+                    </m:r>
+                    <m:r>
+                      <a:rPr lang="en-US" b="0" i="1" smtClean="0">
+                        <a:latin typeface="Cambria Math" panose="02040503050406030204" pitchFamily="18" charset="0"/>
+                      </a:rPr>
+                      <m:t>𝑙𝑔</m:t>
+                    </m:r>
+                    <m:d>
+                      <m:dPr>
+                        <m:ctrlPr>
+                          <a:rPr lang="en-US" b="0" i="1" smtClean="0">
+                            <a:latin typeface="Cambria Math" panose="02040503050406030204" pitchFamily="18" charset="0"/>
+                          </a:rPr>
+                        </m:ctrlPr>
+                      </m:dPr>
+                      <m:e>
+                        <m:r>
+                          <a:rPr lang="en-US" b="0" i="1" smtClean="0">
+                            <a:latin typeface="Cambria Math" panose="02040503050406030204" pitchFamily="18" charset="0"/>
+                          </a:rPr>
+                          <m:t>𝑛</m:t>
+                        </m:r>
+                      </m:e>
+                    </m:d>
+                    <m:r>
+                      <a:rPr lang="en-US" b="0" i="1" smtClean="0">
+                        <a:latin typeface="Cambria Math" panose="02040503050406030204" pitchFamily="18" charset="0"/>
+                      </a:rPr>
+                      <m:t> </m:t>
+                    </m:r>
+                  </m:oMath>
+                </a14:m>
+                <a:endParaRPr lang="en-US" dirty="0"/>
+              </a:p>
+              <a:p>
+                <a:pPr marL="0" indent="0">
+                  <a:buNone/>
+                </a:pPr>
+                <a:endParaRPr lang="en-US" dirty="0"/>
+              </a:p>
+            </p:txBody>
+          </p:sp>
+        </mc:Choice>
+        <mc:Fallback xmlns="">
+          <p:sp>
+            <p:nvSpPr>
+              <p:cNvPr id="3" name="Content Placeholder 2">
+                <a:extLst>
+                  <a:ext uri="{FF2B5EF4-FFF2-40B4-BE49-F238E27FC236}">
+                    <a16:creationId xmlns:a16="http://schemas.microsoft.com/office/drawing/2014/main" id="{8F0982BA-7FD9-E6A8-8955-F7036DC43270}"/>
+                  </a:ext>
+                </a:extLst>
+              </p:cNvPr>
+              <p:cNvSpPr>
+                <a:spLocks noGrp="1" noRot="1" noChangeAspect="1" noMove="1" noResize="1" noEditPoints="1" noAdjustHandles="1" noChangeArrowheads="1" noChangeShapeType="1" noTextEdit="1"/>
+              </p:cNvSpPr>
+              <p:nvPr>
+                <p:ph idx="1"/>
+              </p:nvPr>
+            </p:nvSpPr>
+            <p:spPr>
+              <a:blipFill>
+                <a:blip r:embed="rId2"/>
+                <a:stretch>
+                  <a:fillRect l="-1043" t="-2381"/>
+                </a:stretch>
+              </a:blipFill>
+            </p:spPr>
+            <p:txBody>
+              <a:bodyPr/>
+              <a:lstStyle/>
+              <a:p>
+                <a:r>
+                  <a:rPr lang="en-US">
+                    <a:noFill/>
+                  </a:rPr>
+                  <a:t> </a:t>
+                </a:r>
+              </a:p>
+            </p:txBody>
+          </p:sp>
+        </mc:Fallback>
+      </mc:AlternateContent>
+    </p:spTree>
+    <p:extLst>
+      <p:ext uri="{BB962C8B-B14F-4D97-AF65-F5344CB8AC3E}">
+        <p14:creationId xmlns:p14="http://schemas.microsoft.com/office/powerpoint/2010/main" val="3621828002"/>
+      </p:ext>
+    </p:extLst>
+  </p:cSld>
+  <p:clrMapOvr>
+    <a:masterClrMapping/>
+  </p:clrMapOvr>
+</p:sld>
+</file>
+
+<file path=ppt/slides/slide59.xml><?xml version="1.0" encoding="utf-8"?>
+<p:sld xmlns:a="http://schemas.openxmlformats.org/drawingml/2006/main" xmlns:r="http://schemas.openxmlformats.org/officeDocument/2006/relationships" xmlns:p="http://schemas.openxmlformats.org/presentationml/2006/main">
+  <p:cSld>
+    <p:bg>
+      <p:bgPr>
+        <a:solidFill>
+          <a:schemeClr val="bg1">
+            <a:tint val="95000"/>
+            <a:satMod val="170000"/>
+          </a:schemeClr>
+        </a:solidFill>
+        <a:effectLst/>
+      </p:bgPr>
+    </p:bg>
+    <p:spTree>
+      <p:nvGrpSpPr>
+        <p:cNvPr id="1" name="">
+          <a:extLst>
+            <a:ext uri="{FF2B5EF4-FFF2-40B4-BE49-F238E27FC236}">
+              <a16:creationId xmlns:a16="http://schemas.microsoft.com/office/drawing/2014/main" id="{E8604117-1F71-DE92-66CC-A2093F0D79A6}"/>
+            </a:ext>
+          </a:extLst>
+        </p:cNvPr>
+        <p:cNvGrpSpPr/>
+        <p:nvPr/>
+      </p:nvGrpSpPr>
+      <p:grpSpPr>
+        <a:xfrm>
+          <a:off x="0" y="0"/>
+          <a:ext cx="0" cy="0"/>
+          <a:chOff x="0" y="0"/>
+          <a:chExt cx="0" cy="0"/>
+        </a:xfrm>
+      </p:grpSpPr>
+      <p:sp>
+        <p:nvSpPr>
+          <p:cNvPr id="7" name="Freeform: Shape 6">
+            <a:extLst>
+              <a:ext uri="{FF2B5EF4-FFF2-40B4-BE49-F238E27FC236}">
+                <a16:creationId xmlns:a16="http://schemas.microsoft.com/office/drawing/2014/main" id="{344F51C6-6E74-77C1-1F09-3A7322ADA498}"/>
+              </a:ext>
+              <a:ext uri="{C183D7F6-B498-43B3-948B-1728B52AA6E4}">
+                <adec:decorative xmlns:adec="http://schemas.microsoft.com/office/drawing/2017/decorative" val="1"/>
+              </a:ext>
+            </a:extLst>
+          </p:cNvPr>
+          <p:cNvSpPr>
+            <a:spLocks noGrp="1" noRot="1" noChangeAspect="1" noMove="1" noResize="1" noEditPoints="1" noAdjustHandles="1" noChangeArrowheads="1" noChangeShapeType="1" noTextEdit="1"/>
+          </p:cNvSpPr>
+          <p:nvPr>
+            <p:extLst>
+              <p:ext uri="{386F3935-93C4-4BCD-93E2-E3B085C9AB24}">
+                <p16:designElem xmlns:p16="http://schemas.microsoft.com/office/powerpoint/2015/main" val="1"/>
+              </p:ext>
+            </p:extLst>
+          </p:nvPr>
+        </p:nvSpPr>
+        <p:spPr>
+          <a:xfrm>
+            <a:off x="1953768" y="0"/>
+            <a:ext cx="8284464" cy="6858000"/>
+          </a:xfrm>
+          <a:custGeom>
+            <a:avLst/>
+            <a:gdLst>
+              <a:gd name="connsiteX0" fmla="*/ 1818109 w 8284464"/>
+              <a:gd name="connsiteY0" fmla="*/ 0 h 6858000"/>
+              <a:gd name="connsiteX1" fmla="*/ 6466355 w 8284464"/>
+              <a:gd name="connsiteY1" fmla="*/ 0 h 6858000"/>
+              <a:gd name="connsiteX2" fmla="*/ 6620596 w 8284464"/>
+              <a:gd name="connsiteY2" fmla="*/ 109683 h 6858000"/>
+              <a:gd name="connsiteX3" fmla="*/ 8284464 w 8284464"/>
+              <a:gd name="connsiteY3" fmla="*/ 3429000 h 6858000"/>
+              <a:gd name="connsiteX4" fmla="*/ 6620596 w 8284464"/>
+              <a:gd name="connsiteY4" fmla="*/ 6748318 h 6858000"/>
+              <a:gd name="connsiteX5" fmla="*/ 6466355 w 8284464"/>
+              <a:gd name="connsiteY5" fmla="*/ 6858000 h 6858000"/>
+              <a:gd name="connsiteX6" fmla="*/ 1818109 w 8284464"/>
+              <a:gd name="connsiteY6" fmla="*/ 6858000 h 6858000"/>
+              <a:gd name="connsiteX7" fmla="*/ 1663869 w 8284464"/>
+              <a:gd name="connsiteY7" fmla="*/ 6748318 h 6858000"/>
+              <a:gd name="connsiteX8" fmla="*/ 0 w 8284464"/>
+              <a:gd name="connsiteY8" fmla="*/ 3429000 h 6858000"/>
+              <a:gd name="connsiteX9" fmla="*/ 1663869 w 8284464"/>
+              <a:gd name="connsiteY9" fmla="*/ 109683 h 6858000"/>
+            </a:gdLst>
+            <a:ahLst/>
+            <a:cxnLst>
+              <a:cxn ang="0">
+                <a:pos x="connsiteX0" y="connsiteY0"/>
+              </a:cxn>
+              <a:cxn ang="0">
+                <a:pos x="connsiteX1" y="connsiteY1"/>
+              </a:cxn>
+              <a:cxn ang="0">
+                <a:pos x="connsiteX2" y="connsiteY2"/>
+              </a:cxn>
+              <a:cxn ang="0">
+                <a:pos x="connsiteX3" y="connsiteY3"/>
+              </a:cxn>
+              <a:cxn ang="0">
+                <a:pos x="connsiteX4" y="connsiteY4"/>
+              </a:cxn>
+              <a:cxn ang="0">
+                <a:pos x="connsiteX5" y="connsiteY5"/>
+              </a:cxn>
+              <a:cxn ang="0">
+                <a:pos x="connsiteX6" y="connsiteY6"/>
+              </a:cxn>
+              <a:cxn ang="0">
+                <a:pos x="connsiteX7" y="connsiteY7"/>
+              </a:cxn>
+              <a:cxn ang="0">
+                <a:pos x="connsiteX8" y="connsiteY8"/>
+              </a:cxn>
+              <a:cxn ang="0">
+                <a:pos x="connsiteX9" y="connsiteY9"/>
+              </a:cxn>
+            </a:cxnLst>
+            <a:rect l="l" t="t" r="r" b="b"/>
+            <a:pathLst>
+              <a:path w="8284464" h="6858000">
+                <a:moveTo>
+                  <a:pt x="1818109" y="0"/>
+                </a:moveTo>
+                <a:lnTo>
+                  <a:pt x="6466355" y="0"/>
+                </a:lnTo>
+                <a:lnTo>
+                  <a:pt x="6620596" y="109683"/>
+                </a:lnTo>
+                <a:cubicBezTo>
+                  <a:pt x="7630666" y="865069"/>
+                  <a:pt x="8284464" y="2070683"/>
+                  <a:pt x="8284464" y="3429000"/>
+                </a:cubicBezTo>
+                <a:cubicBezTo>
+                  <a:pt x="8284464" y="4787317"/>
+                  <a:pt x="7630666" y="5992931"/>
+                  <a:pt x="6620596" y="6748318"/>
+                </a:cubicBezTo>
+                <a:lnTo>
+                  <a:pt x="6466355" y="6858000"/>
+                </a:lnTo>
+                <a:lnTo>
+                  <a:pt x="1818109" y="6858000"/>
+                </a:lnTo>
+                <a:lnTo>
+                  <a:pt x="1663869" y="6748318"/>
+                </a:lnTo>
+                <a:cubicBezTo>
+                  <a:pt x="653798" y="5992931"/>
+                  <a:pt x="0" y="4787317"/>
+                  <a:pt x="0" y="3429000"/>
+                </a:cubicBezTo>
+                <a:cubicBezTo>
+                  <a:pt x="0" y="2070683"/>
+                  <a:pt x="653798" y="865069"/>
+                  <a:pt x="1663869" y="109683"/>
+                </a:cubicBezTo>
+                <a:close/>
+              </a:path>
+            </a:pathLst>
+          </a:custGeom>
+          <a:solidFill>
+            <a:srgbClr val="FFFFFF">
+              <a:alpha val="80000"/>
+            </a:srgbClr>
+          </a:solidFill>
+          <a:ln>
+            <a:noFill/>
+          </a:ln>
+        </p:spPr>
+        <p:style>
+          <a:lnRef idx="2">
+            <a:schemeClr val="accent1">
+              <a:shade val="50000"/>
+            </a:schemeClr>
+          </a:lnRef>
+          <a:fillRef idx="1">
+            <a:schemeClr val="accent1"/>
+          </a:fillRef>
+          <a:effectRef idx="0">
+            <a:schemeClr val="accent1"/>
+          </a:effectRef>
+          <a:fontRef idx="minor">
+            <a:schemeClr val="lt1"/>
+          </a:fontRef>
+        </p:style>
+        <p:txBody>
+          <a:bodyPr wrap="square" rtlCol="0" anchor="ctr">
+            <a:noAutofit/>
+          </a:bodyPr>
+          <a:lstStyle/>
+          <a:p>
+            <a:pPr marL="0" marR="0" lvl="0" indent="0" algn="ctr" defTabSz="914400" rtl="0" eaLnBrk="1" fontAlgn="auto" latinLnBrk="0" hangingPunct="1">
+              <a:lnSpc>
+                <a:spcPct val="100000"/>
+              </a:lnSpc>
+              <a:spcBef>
+                <a:spcPts val="0"/>
+              </a:spcBef>
+              <a:spcAft>
+                <a:spcPts val="0"/>
+              </a:spcAft>
+              <a:buClrTx/>
+              <a:buSzTx/>
+              <a:buFontTx/>
+              <a:buNone/>
+              <a:tabLst/>
+              <a:defRPr/>
+            </a:pPr>
+            <a:endParaRPr kumimoji="0" lang="en-US" sz="1800" b="0" i="0" u="none" strike="noStrike" kern="1200" cap="none" spc="0" normalizeH="0" baseline="0" noProof="0">
+              <a:ln>
+                <a:noFill/>
+              </a:ln>
+              <a:solidFill>
+                <a:prstClr val="white"/>
+              </a:solidFill>
+              <a:effectLst/>
+              <a:uLnTx/>
+              <a:uFillTx/>
+              <a:latin typeface="Aptos" panose="02110004020202020204"/>
+              <a:ea typeface="+mn-ea"/>
+              <a:cs typeface="+mn-cs"/>
+            </a:endParaRPr>
+          </a:p>
+        </p:txBody>
+      </p:sp>
+      <p:sp>
+        <p:nvSpPr>
+          <p:cNvPr id="9" name="Freeform: Shape 8">
+            <a:extLst>
+              <a:ext uri="{FF2B5EF4-FFF2-40B4-BE49-F238E27FC236}">
+                <a16:creationId xmlns:a16="http://schemas.microsoft.com/office/drawing/2014/main" id="{FB56525E-1945-B8DC-783F-7AA098D34879}"/>
+              </a:ext>
+              <a:ext uri="{C183D7F6-B498-43B3-948B-1728B52AA6E4}">
+                <adec:decorative xmlns:adec="http://schemas.microsoft.com/office/drawing/2017/decorative" val="1"/>
+              </a:ext>
+            </a:extLst>
+          </p:cNvPr>
+          <p:cNvSpPr>
+            <a:spLocks noGrp="1" noRot="1" noChangeAspect="1" noMove="1" noResize="1" noEditPoints="1" noAdjustHandles="1" noChangeArrowheads="1" noChangeShapeType="1" noTextEdit="1"/>
+          </p:cNvSpPr>
+          <p:nvPr>
+            <p:extLst>
+              <p:ext uri="{386F3935-93C4-4BCD-93E2-E3B085C9AB24}">
+                <p16:designElem xmlns:p16="http://schemas.microsoft.com/office/powerpoint/2015/main" val="1"/>
+              </p:ext>
+            </p:extLst>
+          </p:nvPr>
+        </p:nvSpPr>
+        <p:spPr>
+          <a:xfrm>
+            <a:off x="2118360" y="0"/>
+            <a:ext cx="7955280" cy="6858000"/>
+          </a:xfrm>
+          <a:custGeom>
+            <a:avLst/>
+            <a:gdLst>
+              <a:gd name="connsiteX0" fmla="*/ 1962423 w 7955280"/>
+              <a:gd name="connsiteY0" fmla="*/ 0 h 6858000"/>
+              <a:gd name="connsiteX1" fmla="*/ 5992858 w 7955280"/>
+              <a:gd name="connsiteY1" fmla="*/ 0 h 6858000"/>
+              <a:gd name="connsiteX2" fmla="*/ 6040191 w 7955280"/>
+              <a:gd name="connsiteY2" fmla="*/ 27216 h 6858000"/>
+              <a:gd name="connsiteX3" fmla="*/ 7955280 w 7955280"/>
+              <a:gd name="connsiteY3" fmla="*/ 3429000 h 6858000"/>
+              <a:gd name="connsiteX4" fmla="*/ 6040191 w 7955280"/>
+              <a:gd name="connsiteY4" fmla="*/ 6830784 h 6858000"/>
+              <a:gd name="connsiteX5" fmla="*/ 5992858 w 7955280"/>
+              <a:gd name="connsiteY5" fmla="*/ 6858000 h 6858000"/>
+              <a:gd name="connsiteX6" fmla="*/ 1962423 w 7955280"/>
+              <a:gd name="connsiteY6" fmla="*/ 6858000 h 6858000"/>
+              <a:gd name="connsiteX7" fmla="*/ 1915089 w 7955280"/>
+              <a:gd name="connsiteY7" fmla="*/ 6830784 h 6858000"/>
+              <a:gd name="connsiteX8" fmla="*/ 0 w 7955280"/>
+              <a:gd name="connsiteY8" fmla="*/ 3429000 h 6858000"/>
+              <a:gd name="connsiteX9" fmla="*/ 1915089 w 7955280"/>
+              <a:gd name="connsiteY9" fmla="*/ 27216 h 6858000"/>
+            </a:gdLst>
+            <a:ahLst/>
+            <a:cxnLst>
+              <a:cxn ang="0">
+                <a:pos x="connsiteX0" y="connsiteY0"/>
+              </a:cxn>
+              <a:cxn ang="0">
+                <a:pos x="connsiteX1" y="connsiteY1"/>
+              </a:cxn>
+              <a:cxn ang="0">
+                <a:pos x="connsiteX2" y="connsiteY2"/>
+              </a:cxn>
+              <a:cxn ang="0">
+                <a:pos x="connsiteX3" y="connsiteY3"/>
+              </a:cxn>
+              <a:cxn ang="0">
+                <a:pos x="connsiteX4" y="connsiteY4"/>
+              </a:cxn>
+              <a:cxn ang="0">
+                <a:pos x="connsiteX5" y="connsiteY5"/>
+              </a:cxn>
+              <a:cxn ang="0">
+                <a:pos x="connsiteX6" y="connsiteY6"/>
+              </a:cxn>
+              <a:cxn ang="0">
+                <a:pos x="connsiteX7" y="connsiteY7"/>
+              </a:cxn>
+              <a:cxn ang="0">
+                <a:pos x="connsiteX8" y="connsiteY8"/>
+              </a:cxn>
+              <a:cxn ang="0">
+                <a:pos x="connsiteX9" y="connsiteY9"/>
+              </a:cxn>
+            </a:cxnLst>
+            <a:rect l="l" t="t" r="r" b="b"/>
+            <a:pathLst>
+              <a:path w="7955280" h="6858000">
+                <a:moveTo>
+                  <a:pt x="1962423" y="0"/>
+                </a:moveTo>
+                <a:lnTo>
+                  <a:pt x="5992858" y="0"/>
+                </a:lnTo>
+                <a:lnTo>
+                  <a:pt x="6040191" y="27216"/>
+                </a:lnTo>
+                <a:cubicBezTo>
+                  <a:pt x="7188332" y="724844"/>
+                  <a:pt x="7955280" y="1987357"/>
+                  <a:pt x="7955280" y="3429000"/>
+                </a:cubicBezTo>
+                <a:cubicBezTo>
+                  <a:pt x="7955280" y="4870644"/>
+                  <a:pt x="7188332" y="6133157"/>
+                  <a:pt x="6040191" y="6830784"/>
+                </a:cubicBezTo>
+                <a:lnTo>
+                  <a:pt x="5992858" y="6858000"/>
+                </a:lnTo>
+                <a:lnTo>
+                  <a:pt x="1962423" y="6858000"/>
+                </a:lnTo>
+                <a:lnTo>
+                  <a:pt x="1915089" y="6830784"/>
+                </a:lnTo>
+                <a:cubicBezTo>
+                  <a:pt x="766948" y="6133157"/>
+                  <a:pt x="0" y="4870644"/>
+                  <a:pt x="0" y="3429000"/>
+                </a:cubicBezTo>
+                <a:cubicBezTo>
+                  <a:pt x="0" y="1987357"/>
+                  <a:pt x="766948" y="724844"/>
+                  <a:pt x="1915089" y="27216"/>
+                </a:cubicBezTo>
+                <a:close/>
+              </a:path>
+            </a:pathLst>
+          </a:custGeom>
+          <a:solidFill>
+            <a:schemeClr val="tx1"/>
+          </a:solidFill>
+          <a:ln>
+            <a:noFill/>
+          </a:ln>
+        </p:spPr>
+        <p:style>
+          <a:lnRef idx="2">
+            <a:schemeClr val="accent1">
+              <a:shade val="50000"/>
+            </a:schemeClr>
+          </a:lnRef>
+          <a:fillRef idx="1">
+            <a:schemeClr val="accent1"/>
+          </a:fillRef>
+          <a:effectRef idx="0">
+            <a:schemeClr val="accent1"/>
+          </a:effectRef>
+          <a:fontRef idx="minor">
+            <a:schemeClr val="lt1"/>
+          </a:fontRef>
+        </p:style>
+        <p:txBody>
+          <a:bodyPr wrap="square" rtlCol="0" anchor="ctr">
+            <a:noAutofit/>
+          </a:bodyPr>
+          <a:lstStyle/>
+          <a:p>
+            <a:pPr marL="0" marR="0" lvl="0" indent="0" algn="ctr" defTabSz="914400" rtl="0" eaLnBrk="1" fontAlgn="auto" latinLnBrk="0" hangingPunct="1">
+              <a:lnSpc>
+                <a:spcPct val="100000"/>
+              </a:lnSpc>
+              <a:spcBef>
+                <a:spcPts val="0"/>
+              </a:spcBef>
+              <a:spcAft>
+                <a:spcPts val="0"/>
+              </a:spcAft>
+              <a:buClrTx/>
+              <a:buSzTx/>
+              <a:buFontTx/>
+              <a:buNone/>
+              <a:tabLst/>
+              <a:defRPr/>
+            </a:pPr>
+            <a:endParaRPr kumimoji="0" lang="en-US" sz="1800" b="0" i="0" u="none" strike="noStrike" kern="1200" cap="none" spc="0" normalizeH="0" baseline="0" noProof="0">
+              <a:ln>
+                <a:noFill/>
+              </a:ln>
+              <a:solidFill>
+                <a:prstClr val="white"/>
+              </a:solidFill>
+              <a:effectLst/>
+              <a:uLnTx/>
+              <a:uFillTx/>
+              <a:latin typeface="Aptos" panose="02110004020202020204"/>
+              <a:ea typeface="+mn-ea"/>
+              <a:cs typeface="+mn-cs"/>
+            </a:endParaRPr>
+          </a:p>
+        </p:txBody>
+      </p:sp>
+      <p:sp>
+        <p:nvSpPr>
+          <p:cNvPr id="2" name="Title 1">
+            <a:extLst>
+              <a:ext uri="{FF2B5EF4-FFF2-40B4-BE49-F238E27FC236}">
+                <a16:creationId xmlns:a16="http://schemas.microsoft.com/office/drawing/2014/main" id="{F0A52E9D-03B8-9396-44B1-8993A6CA7B1B}"/>
+              </a:ext>
+            </a:extLst>
+          </p:cNvPr>
+          <p:cNvSpPr>
+            <a:spLocks noGrp="1"/>
+          </p:cNvSpPr>
+          <p:nvPr>
+            <p:ph type="title"/>
+          </p:nvPr>
+        </p:nvSpPr>
+        <p:spPr>
+          <a:xfrm>
+            <a:off x="2555631" y="1441938"/>
+            <a:ext cx="7080738" cy="3974124"/>
+          </a:xfrm>
+        </p:spPr>
+        <p:txBody>
+          <a:bodyPr vert="horz" lIns="91440" tIns="45720" rIns="91440" bIns="45720" rtlCol="0" anchor="ctr">
+            <a:normAutofit/>
+          </a:bodyPr>
+          <a:lstStyle/>
+          <a:p>
+            <a:pPr algn="ctr"/>
+            <a:r>
+              <a:rPr lang="en-US" sz="5400">
+                <a:solidFill>
+                  <a:schemeClr val="bg1">
+                    <a:lumMod val="95000"/>
+                    <a:lumOff val="5000"/>
+                  </a:schemeClr>
+                </a:solidFill>
+              </a:rPr>
+              <a:t>Exercises</a:t>
+            </a:r>
+          </a:p>
+        </p:txBody>
+      </p:sp>
+    </p:spTree>
+    <p:extLst>
+      <p:ext uri="{BB962C8B-B14F-4D97-AF65-F5344CB8AC3E}">
+        <p14:creationId xmlns:p14="http://schemas.microsoft.com/office/powerpoint/2010/main" val="921677391"/>
+      </p:ext>
+    </p:extLst>
+  </p:cSld>
+  <p:clrMapOvr>
+    <a:overrideClrMapping bg1="dk1" tx1="lt1" bg2="dk2" tx2="lt2" accent1="accent1" accent2="accent2" accent3="accent3" accent4="accent4" accent5="accent5" accent6="accent6" hlink="hlink" folHlink="folHlink"/>
   </p:clrMapOvr>
 </p:sld>
 </file>
@@ -26884,6 +29323,215 @@
     <p:extLst>
       <p:ext uri="{BB962C8B-B14F-4D97-AF65-F5344CB8AC3E}">
         <p14:creationId xmlns:p14="http://schemas.microsoft.com/office/powerpoint/2010/main" val="3133606700"/>
+      </p:ext>
+    </p:extLst>
+  </p:cSld>
+  <p:clrMapOvr>
+    <a:masterClrMapping/>
+  </p:clrMapOvr>
+</p:sld>
+</file>
+
+<file path=ppt/slides/slide60.xml><?xml version="1.0" encoding="utf-8"?>
+<p:sld xmlns:a="http://schemas.openxmlformats.org/drawingml/2006/main" xmlns:r="http://schemas.openxmlformats.org/officeDocument/2006/relationships" xmlns:p="http://schemas.openxmlformats.org/presentationml/2006/main">
+  <p:cSld>
+    <p:bg>
+      <p:bgPr>
+        <a:solidFill>
+          <a:schemeClr val="bg1"/>
+        </a:solidFill>
+        <a:effectLst/>
+      </p:bgPr>
+    </p:bg>
+    <p:spTree>
+      <p:nvGrpSpPr>
+        <p:cNvPr id="1" name=""/>
+        <p:cNvGrpSpPr/>
+        <p:nvPr/>
+      </p:nvGrpSpPr>
+      <p:grpSpPr>
+        <a:xfrm>
+          <a:off x="0" y="0"/>
+          <a:ext cx="0" cy="0"/>
+          <a:chOff x="0" y="0"/>
+          <a:chExt cx="0" cy="0"/>
+        </a:xfrm>
+      </p:grpSpPr>
+      <p:sp>
+        <p:nvSpPr>
+          <p:cNvPr id="10" name="Rectangle 9">
+            <a:extLst>
+              <a:ext uri="{FF2B5EF4-FFF2-40B4-BE49-F238E27FC236}">
+                <a16:creationId xmlns:a16="http://schemas.microsoft.com/office/drawing/2014/main" id="{01D0AF59-99C3-4251-AB9A-C966C6AD4400}"/>
+              </a:ext>
+              <a:ext uri="{C183D7F6-B498-43B3-948B-1728B52AA6E4}">
+                <adec:decorative xmlns:adec="http://schemas.microsoft.com/office/drawing/2017/decorative" val="1"/>
+              </a:ext>
+            </a:extLst>
+          </p:cNvPr>
+          <p:cNvSpPr>
+            <a:spLocks noGrp="1" noRot="1" noChangeAspect="1" noMove="1" noResize="1" noEditPoints="1" noAdjustHandles="1" noChangeArrowheads="1" noChangeShapeType="1" noTextEdit="1"/>
+          </p:cNvSpPr>
+          <p:nvPr>
+            <p:extLst>
+              <p:ext uri="{386F3935-93C4-4BCD-93E2-E3B085C9AB24}">
+                <p16:designElem xmlns:p16="http://schemas.microsoft.com/office/powerpoint/2015/main" val="1"/>
+              </p:ext>
+            </p:extLst>
+          </p:nvPr>
+        </p:nvSpPr>
+        <p:spPr>
+          <a:xfrm>
+            <a:off x="0" y="0"/>
+            <a:ext cx="12192000" cy="6858000"/>
+          </a:xfrm>
+          <a:prstGeom prst="rect">
+            <a:avLst/>
+          </a:prstGeom>
+          <a:solidFill>
+            <a:schemeClr val="bg2"/>
+          </a:solidFill>
+          <a:ln>
+            <a:noFill/>
+          </a:ln>
+        </p:spPr>
+        <p:style>
+          <a:lnRef idx="2">
+            <a:schemeClr val="accent1">
+              <a:shade val="50000"/>
+            </a:schemeClr>
+          </a:lnRef>
+          <a:fillRef idx="1">
+            <a:schemeClr val="accent1"/>
+          </a:fillRef>
+          <a:effectRef idx="0">
+            <a:schemeClr val="accent1"/>
+          </a:effectRef>
+          <a:fontRef idx="minor">
+            <a:schemeClr val="lt1"/>
+          </a:fontRef>
+        </p:style>
+        <p:txBody>
+          <a:bodyPr rtlCol="0" anchor="ctr"/>
+          <a:lstStyle/>
+          <a:p>
+            <a:pPr algn="ctr"/>
+            <a:endParaRPr lang="en-US"/>
+          </a:p>
+        </p:txBody>
+      </p:sp>
+      <p:sp>
+        <p:nvSpPr>
+          <p:cNvPr id="12" name="Rectangle 11">
+            <a:extLst>
+              <a:ext uri="{FF2B5EF4-FFF2-40B4-BE49-F238E27FC236}">
+                <a16:creationId xmlns:a16="http://schemas.microsoft.com/office/drawing/2014/main" id="{1855405F-37A2-4869-9154-F8BE3BECE6C3}"/>
+              </a:ext>
+              <a:ext uri="{C183D7F6-B498-43B3-948B-1728B52AA6E4}">
+                <adec:decorative xmlns:adec="http://schemas.microsoft.com/office/drawing/2017/decorative" val="1"/>
+              </a:ext>
+            </a:extLst>
+          </p:cNvPr>
+          <p:cNvSpPr>
+            <a:spLocks noGrp="1" noRot="1" noChangeAspect="1" noMove="1" noResize="1" noEditPoints="1" noAdjustHandles="1" noChangeArrowheads="1" noChangeShapeType="1" noTextEdit="1"/>
+          </p:cNvSpPr>
+          <p:nvPr>
+            <p:extLst>
+              <p:ext uri="{386F3935-93C4-4BCD-93E2-E3B085C9AB24}">
+                <p16:designElem xmlns:p16="http://schemas.microsoft.com/office/powerpoint/2015/main" val="1"/>
+              </p:ext>
+            </p:extLst>
+          </p:nvPr>
+        </p:nvSpPr>
+        <p:spPr>
+          <a:xfrm>
+            <a:off x="477012" y="480060"/>
+            <a:ext cx="11237976" cy="5897880"/>
+          </a:xfrm>
+          <a:prstGeom prst="rect">
+            <a:avLst/>
+          </a:prstGeom>
+          <a:solidFill>
+            <a:srgbClr val="FFFFFF"/>
+          </a:solidFill>
+          <a:ln w="9525">
+            <a:noFill/>
+          </a:ln>
+          <a:effectLst>
+            <a:outerShdw blurRad="63500" dist="17780" dir="5400000" algn="t" rotWithShape="0">
+              <a:prstClr val="black">
+                <a:alpha val="43000"/>
+              </a:prstClr>
+            </a:outerShdw>
+          </a:effectLst>
+        </p:spPr>
+        <p:style>
+          <a:lnRef idx="2">
+            <a:schemeClr val="accent1">
+              <a:shade val="50000"/>
+            </a:schemeClr>
+          </a:lnRef>
+          <a:fillRef idx="1">
+            <a:schemeClr val="accent1"/>
+          </a:fillRef>
+          <a:effectRef idx="0">
+            <a:schemeClr val="accent1"/>
+          </a:effectRef>
+          <a:fontRef idx="minor">
+            <a:schemeClr val="lt1"/>
+          </a:fontRef>
+        </p:style>
+        <p:txBody>
+          <a:bodyPr rtlCol="0" anchor="ctr"/>
+          <a:lstStyle/>
+          <a:p>
+            <a:pPr algn="ctr"/>
+            <a:endParaRPr lang="en-US"/>
+          </a:p>
+        </p:txBody>
+      </p:sp>
+      <p:pic>
+        <p:nvPicPr>
+          <p:cNvPr id="5" name="Content Placeholder 4" descr="A math equations on a white background&#10;&#10;AI-generated content may be incorrect.">
+            <a:extLst>
+              <a:ext uri="{FF2B5EF4-FFF2-40B4-BE49-F238E27FC236}">
+                <a16:creationId xmlns:a16="http://schemas.microsoft.com/office/drawing/2014/main" id="{A23279A0-2F8F-3EAE-D60C-BF219F2868AF}"/>
+              </a:ext>
+            </a:extLst>
+          </p:cNvPr>
+          <p:cNvPicPr>
+            <a:picLocks noGrp="1" noChangeAspect="1"/>
+          </p:cNvPicPr>
+          <p:nvPr>
+            <p:ph idx="1"/>
+          </p:nvPr>
+        </p:nvPicPr>
+        <p:blipFill>
+          <a:blip r:embed="rId2">
+            <a:extLst>
+              <a:ext uri="{28A0092B-C50C-407E-A947-70E740481C1C}">
+                <a14:useLocalDpi xmlns:a14="http://schemas.microsoft.com/office/drawing/2010/main" val="0"/>
+              </a:ext>
+            </a:extLst>
+          </a:blip>
+          <a:stretch>
+            <a:fillRect/>
+          </a:stretch>
+        </p:blipFill>
+        <p:spPr>
+          <a:xfrm>
+            <a:off x="643467" y="1479720"/>
+            <a:ext cx="10905066" cy="3898560"/>
+          </a:xfrm>
+          <a:prstGeom prst="rect">
+            <a:avLst/>
+          </a:prstGeom>
+        </p:spPr>
+      </p:pic>
+    </p:spTree>
+    <p:extLst>
+      <p:ext uri="{BB962C8B-B14F-4D97-AF65-F5344CB8AC3E}">
+        <p14:creationId xmlns:p14="http://schemas.microsoft.com/office/powerpoint/2010/main" val="795666788"/>
       </p:ext>
     </p:extLst>
   </p:cSld>

</xml_diff>